<commit_message>
feat: RTX 5060 CUDA baseline, agent bus/memory, report fix
- Fix LaTeX/PDF generator (placeholder escaping, circled digits).
- RTX 5060 CUDA llama-server with KV-cache q4_0: Qwen3.5-4B 82.6 tok/s,
  gemma-4-E4B 39.9 tok/s; visual struct 8-frame parse_rate 0.75.
- Add AgentBus, MultiAgentOrchestrator, StrategyMemory, Critic role,
  multi-bus/multi-bus-memory modes.
- Add exp_multi_agent_matrix.py for gameplay matrix.
- Update REPORT.md / EXPERIMENT_RESULTS.md; regenerate PDF/PPTX.
- 641 pytest passed, ruff clean.
</commit_message>
<xml_diff>
--- a/reports/smallgameagent_report.pptx
+++ b/reports/smallgameagent_report.pptx
@@ -13,6 +13,9 @@
     <p:sldId id="261" r:id="rId12"/>
     <p:sldId id="262" r:id="rId13"/>
     <p:sldId id="263" r:id="rId14"/>
+    <p:sldId id="264" r:id="rId15"/>
+    <p:sldId id="265" r:id="rId16"/>
+    <p:sldId id="266" r:id="rId17"/>
   </p:sldIdLst>
   <p:sldSz cx="12191695" cy="6858000" type="screen4x3"/>
   <p:notesSz cx="6858000" cy="9144000"/>
@@ -3169,6 +3172,258 @@
 </p:sld>
 </file>
 
+<file path=ppt/slides/slide10.xml><?xml version="1.0" encoding="utf-8"?>
+<p:sld xmlns:a="http://schemas.openxmlformats.org/drawingml/2006/main" xmlns:p="http://schemas.openxmlformats.org/presentationml/2006/main" xmlns:r="http://schemas.openxmlformats.org/officeDocument/2006/relationships">
+  <p:cSld>
+    <p:spTree>
+      <p:nvGrpSpPr>
+        <p:cNvPr id="1" name=""/>
+        <p:cNvGrpSpPr/>
+        <p:nvPr/>
+      </p:nvGrpSpPr>
+      <p:grpSpPr/>
+      <p:sp>
+        <p:nvSpPr>
+          <p:cNvPr id="2" name="TextBox 1"/>
+          <p:cNvSpPr txBox="1"/>
+          <p:nvPr/>
+        </p:nvSpPr>
+        <p:spPr>
+          <a:xfrm>
+            <a:off x="457200" y="365760"/>
+            <a:ext cx="11247120" cy="822960"/>
+          </a:xfrm>
+          <a:prstGeom prst="rect">
+            <a:avLst/>
+          </a:prstGeom>
+          <a:noFill/>
+        </p:spPr>
+        <p:txBody>
+          <a:bodyPr wrap="none">
+            <a:spAutoFit/>
+          </a:bodyPr>
+          <a:lstStyle/>
+          <a:p>
+            <a:pPr>
+              <a:defRPr sz="3200" b="1">
+                <a:latin typeface="Microsoft YaHei"/>
+              </a:defRPr>
+            </a:pPr>
+            <a:r>
+              <a:t>云端 API 与在线 gameplay 状态</a:t>
+            </a:r>
+          </a:p>
+        </p:txBody>
+      </p:sp>
+      <p:sp>
+        <p:nvSpPr>
+          <p:cNvPr id="3" name="TextBox 2"/>
+          <p:cNvSpPr txBox="1"/>
+          <p:nvPr/>
+        </p:nvSpPr>
+        <p:spPr>
+          <a:xfrm>
+            <a:off x="548640" y="1371600"/>
+            <a:ext cx="11064240" cy="5120640"/>
+          </a:xfrm>
+          <a:prstGeom prst="rect">
+            <a:avLst/>
+          </a:prstGeom>
+          <a:noFill/>
+        </p:spPr>
+        <p:txBody>
+          <a:bodyPr wrap="square">
+            <a:spAutoFit/>
+          </a:bodyPr>
+          <a:lstStyle/>
+          <a:p>
+            <a:pPr>
+              <a:spcAft>
+                <a:spcPts val="1000"/>
+              </a:spcAft>
+              <a:defRPr sz="2000">
+                <a:latin typeface="Microsoft YaHei"/>
+              </a:defRPr>
+            </a:pPr>
+            <a:r>
+              <a:t>• OpenCodeGo 认证通过但余额不足（CreditsError）</a:t>
+            </a:r>
+          </a:p>
+          <a:p>
+            <a:pPr>
+              <a:spcAft>
+                <a:spcPts val="1000"/>
+              </a:spcAft>
+              <a:defRPr sz="2000">
+                <a:latin typeface="Microsoft YaHei"/>
+              </a:defRPr>
+            </a:pPr>
+            <a:r>
+              <a:t>• mimo-v2.5 / kimi-k2.7-code / kimi-k2.6 混合实验待充值后跑</a:t>
+            </a:r>
+          </a:p>
+          <a:p>
+            <a:pPr>
+              <a:spcAft>
+                <a:spcPts val="1000"/>
+              </a:spcAft>
+              <a:defRPr sz="2000">
+                <a:latin typeface="Microsoft YaHei"/>
+              </a:defRPr>
+            </a:pPr>
+            <a:r>
+              <a:t>• WSL2 headless Chromium 无法初始化 Cocos 场景（cc.director.getScene() 为 null）</a:t>
+            </a:r>
+          </a:p>
+          <a:p>
+            <a:pPr>
+              <a:spcAft>
+                <a:spcPts val="1000"/>
+              </a:spcAft>
+              <a:defRPr sz="2000">
+                <a:latin typeface="Microsoft YaHei"/>
+              </a:defRPr>
+            </a:pPr>
+            <a:r>
+              <a:t>• 在线矩阵当前被环境阻塞，已记录并准备复跑</a:t>
+            </a:r>
+          </a:p>
+        </p:txBody>
+      </p:sp>
+    </p:spTree>
+  </p:cSld>
+  <p:clrMapOvr>
+    <a:masterClrMapping/>
+  </p:clrMapOvr>
+</p:sld>
+</file>
+
+<file path=ppt/slides/slide11.xml><?xml version="1.0" encoding="utf-8"?>
+<p:sld xmlns:a="http://schemas.openxmlformats.org/drawingml/2006/main" xmlns:p="http://schemas.openxmlformats.org/presentationml/2006/main" xmlns:r="http://schemas.openxmlformats.org/officeDocument/2006/relationships">
+  <p:cSld>
+    <p:spTree>
+      <p:nvGrpSpPr>
+        <p:cNvPr id="1" name=""/>
+        <p:cNvGrpSpPr/>
+        <p:nvPr/>
+      </p:nvGrpSpPr>
+      <p:grpSpPr/>
+      <p:sp>
+        <p:nvSpPr>
+          <p:cNvPr id="2" name="TextBox 1"/>
+          <p:cNvSpPr txBox="1"/>
+          <p:nvPr/>
+        </p:nvSpPr>
+        <p:spPr>
+          <a:xfrm>
+            <a:off x="457200" y="365760"/>
+            <a:ext cx="11247120" cy="822960"/>
+          </a:xfrm>
+          <a:prstGeom prst="rect">
+            <a:avLst/>
+          </a:prstGeom>
+          <a:noFill/>
+        </p:spPr>
+        <p:txBody>
+          <a:bodyPr wrap="none">
+            <a:spAutoFit/>
+          </a:bodyPr>
+          <a:lstStyle/>
+          <a:p>
+            <a:pPr>
+              <a:defRPr sz="3200" b="1">
+                <a:latin typeface="Microsoft YaHei"/>
+              </a:defRPr>
+            </a:pPr>
+            <a:r>
+              <a:t>训练准备与后续工作</a:t>
+            </a:r>
+          </a:p>
+        </p:txBody>
+      </p:sp>
+      <p:sp>
+        <p:nvSpPr>
+          <p:cNvPr id="3" name="TextBox 2"/>
+          <p:cNvSpPr txBox="1"/>
+          <p:nvPr/>
+        </p:nvSpPr>
+        <p:spPr>
+          <a:xfrm>
+            <a:off x="548640" y="1371600"/>
+            <a:ext cx="11064240" cy="5120640"/>
+          </a:xfrm>
+          <a:prstGeom prst="rect">
+            <a:avLst/>
+          </a:prstGeom>
+          <a:noFill/>
+        </p:spPr>
+        <p:txBody>
+          <a:bodyPr wrap="square">
+            <a:spAutoFit/>
+          </a:bodyPr>
+          <a:lstStyle/>
+          <a:p>
+            <a:pPr>
+              <a:spcAft>
+                <a:spcPts val="1000"/>
+              </a:spcAft>
+              <a:defRPr sz="2000">
+                <a:latin typeface="Microsoft YaHei"/>
+              </a:defRPr>
+            </a:pPr>
+            <a:r>
+              <a:t>• processed-runs → 15,083 样本 / 7 任务，VLMColdStartDataset 已验证</a:t>
+            </a:r>
+          </a:p>
+          <a:p>
+            <a:pPr>
+              <a:spcAft>
+                <a:spcPts val="1000"/>
+              </a:spcAft>
+              <a:defRPr sz="2000">
+                <a:latin typeface="Microsoft YaHei"/>
+              </a:defRPr>
+            </a:pPr>
+            <a:r>
+              <a:t>• train_qwen35.py（QLoRA 4bit NF4 + ZeRO-2）就绪</a:t>
+            </a:r>
+          </a:p>
+          <a:p>
+            <a:pPr>
+              <a:spcAft>
+                <a:spcPts val="1000"/>
+              </a:spcAft>
+              <a:defRPr sz="2000">
+                <a:latin typeface="Microsoft YaHei"/>
+              </a:defRPr>
+            </a:pPr>
+            <a:r>
+              <a:t>• ssh5090 可访问后：bash scripts/scp_to_ssh5090.sh 并开训</a:t>
+            </a:r>
+          </a:p>
+          <a:p>
+            <a:pPr>
+              <a:spcAft>
+                <a:spcPts val="1000"/>
+              </a:spcAft>
+              <a:defRPr sz="2000">
+                <a:latin typeface="Microsoft YaHei"/>
+              </a:defRPr>
+            </a:pPr>
+            <a:r>
+              <a:t>• 下一步：面板泛化、9B/E4B 调优、22 游戏 benchmark、verifiers 对抗数据</a:t>
+            </a:r>
+          </a:p>
+        </p:txBody>
+      </p:sp>
+    </p:spTree>
+  </p:cSld>
+  <p:clrMapOvr>
+    <a:masterClrMapping/>
+  </p:clrMapOvr>
+</p:sld>
+</file>
+
 <file path=ppt/slides/slide2.xml><?xml version="1.0" encoding="utf-8"?>
 <p:sld xmlns:a="http://schemas.openxmlformats.org/drawingml/2006/main" xmlns:p="http://schemas.openxmlformats.org/presentationml/2006/main" xmlns:r="http://schemas.openxmlformats.org/officeDocument/2006/relationships">
   <p:cSld>
@@ -3837,7 +4092,7 @@
               </a:defRPr>
             </a:pPr>
             <a:r>
-              <a:t>本地 VLM 实测画像</a:t>
+              <a:t>本地 VLM：Intel 核显 Vulkan（旧基线）</a:t>
             </a:r>
           </a:p>
         </p:txBody>
@@ -3873,7 +4128,7 @@
               </a:defRPr>
             </a:pPr>
             <a:r>
-              <a:t>• Intel 核显 Vulkan Q4_K_M 文本生成：</a:t>
+              <a:t>• Qwen3.5-4B 2.75 tok/s，9B 0.72 tok/s，E4B 0.67 tok/s</a:t>
             </a:r>
           </a:p>
           <a:p>
@@ -3886,7 +4141,7 @@
               </a:defRPr>
             </a:pPr>
             <a:r>
-              <a:t>•   Qwen3.5-4B  2.75 tok/s</a:t>
+              <a:t>• 视觉编码必须 --no-mmproj-offload 回 CPU</a:t>
             </a:r>
           </a:p>
           <a:p>
@@ -3899,7 +4154,7 @@
               </a:defRPr>
             </a:pPr>
             <a:r>
-              <a:t>•   Qwen3.5-9B  0.72 tok/s</a:t>
+              <a:t>• 4 帧 struct 解析率 0/4，平均 534 s/帧</a:t>
             </a:r>
           </a:p>
           <a:p>
@@ -3912,33 +4167,7 @@
               </a:defRPr>
             </a:pPr>
             <a:r>
-              <a:t>•   gemma-4-E4B 0.67 tok/s</a:t>
-            </a:r>
-          </a:p>
-          <a:p>
-            <a:pPr>
-              <a:spcAft>
-                <a:spcPts val="1000"/>
-              </a:spcAft>
-              <a:defRPr sz="2000">
-                <a:latin typeface="Microsoft YaHei"/>
-              </a:defRPr>
-            </a:pPr>
-            <a:r>
-              <a:t>• 视觉编码必须 --no-mmproj-offload 回 CPU；4 帧 struct 解析率 0/4</a:t>
-            </a:r>
-          </a:p>
-          <a:p>
-            <a:pPr>
-              <a:spcAft>
-                <a:spcPts val="1000"/>
-              </a:spcAft>
-              <a:defRPr sz="2000">
-                <a:latin typeface="Microsoft YaHei"/>
-              </a:defRPr>
-            </a:pPr>
-            <a:r>
-              <a:t>• 当前本地 VLM 仅适合作离线标注，不适合在线逐步控制</a:t>
+              <a:t>• 结论：仅适合作离线数据标注</a:t>
             </a:r>
           </a:p>
         </p:txBody>
@@ -3989,7 +4218,7 @@
               </a:defRPr>
             </a:pPr>
             <a:r>
-              <a:t>训练准备与后续工作</a:t>
+              <a:t>本地 VLM：RTX 5060 CUDA + KV-cache 量化（新基线）</a:t>
             </a:r>
           </a:p>
         </p:txBody>
@@ -4025,7 +4254,7 @@
               </a:defRPr>
             </a:pPr>
             <a:r>
-              <a:t>• processed-runs → 15,083 样本 / 7 任务，VLMColdStartDataset 已验证</a:t>
+              <a:t>• 后端：llama.cpp CUDA12，-ngl 99 --flash-attn，K/V cache q4_0</a:t>
             </a:r>
           </a:p>
           <a:p>
@@ -4038,7 +4267,7 @@
               </a:defRPr>
             </a:pPr>
             <a:r>
-              <a:t>• train_qwen35.py（QLoRA 4bit NF4 + ZeRO-2）就绪</a:t>
+              <a:t>• Qwen3.5-4B：文本 82.6 tok/s，视觉 8 帧解析率 0.75，target_acc 0.83，平均 24.8 s/帧</a:t>
             </a:r>
           </a:p>
           <a:p>
@@ -4051,7 +4280,7 @@
               </a:defRPr>
             </a:pPr>
             <a:r>
-              <a:t>• ssh5090 可访问后：bash scripts/scp_to_ssh5090.sh 并开训</a:t>
+              <a:t>• gemma-4-E4B：文本 39.9 tok/s，单帧视觉 14.6 s</a:t>
             </a:r>
           </a:p>
           <a:p>
@@ -4064,7 +4293,159 @@
               </a:defRPr>
             </a:pPr>
             <a:r>
-              <a:t>• 下一步：面板泛化、9B/E4B 调优、22 游戏 benchmark、verifiers 对抗数据</a:t>
+              <a:t>• 8 GB 显存跑 4B 宽裕，E4B 接近上限（7082 MB）</a:t>
+            </a:r>
+          </a:p>
+          <a:p>
+            <a:pPr>
+              <a:spcAft>
+                <a:spcPts val="1000"/>
+              </a:spcAft>
+              <a:defRPr sz="2000">
+                <a:latin typeface="Microsoft YaHei"/>
+              </a:defRPr>
+            </a:pPr>
+            <a:r>
+              <a:t>• Qwen3.5 思考模型需 max_tokens=2048 才能输出 content JSON</a:t>
+            </a:r>
+          </a:p>
+        </p:txBody>
+      </p:sp>
+    </p:spTree>
+  </p:cSld>
+  <p:clrMapOvr>
+    <a:masterClrMapping/>
+  </p:clrMapOvr>
+</p:sld>
+</file>
+
+<file path=ppt/slides/slide9.xml><?xml version="1.0" encoding="utf-8"?>
+<p:sld xmlns:a="http://schemas.openxmlformats.org/drawingml/2006/main" xmlns:p="http://schemas.openxmlformats.org/presentationml/2006/main" xmlns:r="http://schemas.openxmlformats.org/officeDocument/2006/relationships">
+  <p:cSld>
+    <p:spTree>
+      <p:nvGrpSpPr>
+        <p:cNvPr id="1" name=""/>
+        <p:cNvGrpSpPr/>
+        <p:nvPr/>
+      </p:nvGrpSpPr>
+      <p:grpSpPr/>
+      <p:sp>
+        <p:nvSpPr>
+          <p:cNvPr id="2" name="TextBox 1"/>
+          <p:cNvSpPr txBox="1"/>
+          <p:nvPr/>
+        </p:nvSpPr>
+        <p:spPr>
+          <a:xfrm>
+            <a:off x="457200" y="365760"/>
+            <a:ext cx="11247120" cy="822960"/>
+          </a:xfrm>
+          <a:prstGeom prst="rect">
+            <a:avLst/>
+          </a:prstGeom>
+          <a:noFill/>
+        </p:spPr>
+        <p:txBody>
+          <a:bodyPr wrap="none">
+            <a:spAutoFit/>
+          </a:bodyPr>
+          <a:lstStyle/>
+          <a:p>
+            <a:pPr>
+              <a:defRPr sz="3200" b="1">
+                <a:latin typeface="Microsoft YaHei"/>
+              </a:defRPr>
+            </a:pPr>
+            <a:r>
+              <a:t>Agent 通信与记忆（P8）</a:t>
+            </a:r>
+          </a:p>
+        </p:txBody>
+      </p:sp>
+      <p:sp>
+        <p:nvSpPr>
+          <p:cNvPr id="3" name="TextBox 2"/>
+          <p:cNvSpPr txBox="1"/>
+          <p:nvPr/>
+        </p:nvSpPr>
+        <p:spPr>
+          <a:xfrm>
+            <a:off x="548640" y="1371600"/>
+            <a:ext cx="11064240" cy="5120640"/>
+          </a:xfrm>
+          <a:prstGeom prst="rect">
+            <a:avLst/>
+          </a:prstGeom>
+          <a:noFill/>
+        </p:spPr>
+        <p:txBody>
+          <a:bodyPr wrap="square">
+            <a:spAutoFit/>
+          </a:bodyPr>
+          <a:lstStyle/>
+          <a:p>
+            <a:pPr>
+              <a:spcAft>
+                <a:spcPts val="1000"/>
+              </a:spcAft>
+              <a:defRPr sz="2000">
+                <a:latin typeface="Microsoft YaHei"/>
+              </a:defRPr>
+            </a:pPr>
+            <a:r>
+              <a:t>• 新增显式消息总线 AgentBus：OBSERVE / PERCEIVE / DECIDE / VERIFY / CRITIC / MEMORY</a:t>
+            </a:r>
+          </a:p>
+          <a:p>
+            <a:pPr>
+              <a:spcAft>
+                <a:spcPts val="1000"/>
+              </a:spcAft>
+              <a:defRPr sz="2000">
+                <a:latin typeface="Microsoft YaHei"/>
+              </a:defRPr>
+            </a:pPr>
+            <a:r>
+              <a:t>• MultiAgentOrchestrator：循环流水线，Verifier 可触发 re-decide</a:t>
+            </a:r>
+          </a:p>
+          <a:p>
+            <a:pPr>
+              <a:spcAft>
+                <a:spcPts val="1000"/>
+              </a:spcAft>
+              <a:defRPr sz="2000">
+                <a:latin typeface="Microsoft YaHei"/>
+              </a:defRPr>
+            </a:pPr>
+            <a:r>
+              <a:t>• StrategyMemory：文件型策略记忆，不依赖 sqlite-vec</a:t>
+            </a:r>
+          </a:p>
+          <a:p>
+            <a:pPr>
+              <a:spcAft>
+                <a:spcPts val="1000"/>
+              </a:spcAft>
+              <a:defRPr sz="2000">
+                <a:latin typeface="Microsoft YaHei"/>
+              </a:defRPr>
+            </a:pPr>
+            <a:r>
+              <a:t>• 新增 multi-bus / multi-bus-memory 模式与 Critic 角色</a:t>
+            </a:r>
+          </a:p>
+          <a:p>
+            <a:pPr>
+              <a:spcAft>
+                <a:spcPts val="1000"/>
+              </a:spcAft>
+              <a:defRPr sz="2000">
+                <a:latin typeface="Microsoft YaHei"/>
+              </a:defRPr>
+            </a:pPr>
+            <a:r>
+              <a:t>• 19 单测覆盖；在线 gameplay 矩阵脚本已就绪</a:t>
             </a:r>
           </a:p>
         </p:txBody>

</xml_diff>

<commit_message>
Update PPT matrix and core conclusions with representative subset results
</commit_message>
<xml_diff>
--- a/reports/smallgameagent_report.pptx
+++ b/reports/smallgameagent_report.pptx
@@ -4690,7 +4690,7 @@
               </a:defRPr>
             </a:pPr>
             <a:r>
-              <a:t>最佳配置仍是 multi-bus + StrategyMemory 读回，稳定达到 composite 0.300（多 seed 一致）。</a:t>
+              <a:t>代表性子集（6 游戏 × 15 runs）已跑通：B 类 tap-only 游戏 rule 模式即达 composite 0.300；A 类 joystick 游戏中 multi-bus-memory 对 00461 提升最大（0.106 → 0.300）。</a:t>
             </a:r>
           </a:p>
           <a:p>
@@ -4706,7 +4706,7 @@
               </a:defRPr>
             </a:pPr>
             <a:r>
-              <a:t>记忆读回把 composite 从 0.150 提升到 0.300，关键在于世界模型违规从 3 降到 0。</a:t>
+              <a:t>浏览器环境修复是前置条件：WSL2 headless 需 Playwright bundled Chromium + --enable-unsafe-swiftshader --in-process-gpu。</a:t>
             </a:r>
           </a:p>
           <a:p>
@@ -4722,7 +4722,7 @@
               </a:defRPr>
             </a:pPr>
             <a:r>
-              <a:t>22 个游戏已自动分类：7 个 joystick 驱动 + 15 个 tap-to-move；8/15 的 B 类游戏用 tap-only 驱动即可达 0.300。</a:t>
+              <a:t>记忆读回效果因游戏而异：对 00461 显著，但对 00483 无帮助，说明需要按游戏类型调优 driver/profile。</a:t>
             </a:r>
           </a:p>
           <a:p>
@@ -4770,7 +4770,7 @@
               </a:defRPr>
             </a:pPr>
             <a:r>
-              <a:t>训练数据已达 23,596 条 7 任务样本，为后续 QLoRA 微调做好了准备。</a:t>
+              <a:t>训练数据：processed-runs 34,150 条 + representative 1,173 条，为后续 QLoRA 微调做好准备。</a:t>
             </a:r>
           </a:p>
         </p:txBody>
@@ -6063,7 +6063,7 @@
                 <a:gridCol w="1874520"/>
                 <a:gridCol w="1874520"/>
               </a:tblGrid>
-              <a:tr h="640080">
+              <a:tr h="731520">
                 <a:tc>
                   <a:txBody>
                     <a:bodyPr/>
@@ -6150,7 +6150,7 @@
                         </a:defRPr>
                       </a:pPr>
                       <a:r>
-                        <a:t>multi-bus-memory</a:t>
+                        <a:t>multi-bus</a:t>
                       </a:r>
                     </a:p>
                   </a:txBody>
@@ -6174,7 +6174,7 @@
                         </a:defRPr>
                       </a:pPr>
                       <a:r>
-                        <a:t>multi-bus</a:t>
+                        <a:t>multi-bus-memory</a:t>
                       </a:r>
                     </a:p>
                   </a:txBody>
@@ -6209,7 +6209,7 @@
                   </a:tcPr>
                 </a:tc>
               </a:tr>
-              <a:tr h="640080">
+              <a:tr h="731520">
                 <a:tc>
                   <a:txBody>
                     <a:bodyPr/>
@@ -6263,7 +6263,7 @@
                         </a:defRPr>
                       </a:pPr>
                       <a:r>
-                        <a:t>0.113</a:t>
+                        <a:t>0.106</a:t>
                       </a:r>
                     </a:p>
                   </a:txBody>
@@ -6284,7 +6284,7 @@
                         </a:defRPr>
                       </a:pPr>
                       <a:r>
-                        <a:t>0.300</a:t>
+                        <a:t>0.161</a:t>
                       </a:r>
                     </a:p>
                   </a:txBody>
@@ -6305,7 +6305,7 @@
                         </a:defRPr>
                       </a:pPr>
                       <a:r>
-                        <a:t>0.297</a:t>
+                        <a:t>0.300</a:t>
                       </a:r>
                     </a:p>
                   </a:txBody>
@@ -6326,7 +6326,7 @@
                         </a:defRPr>
                       </a:pPr>
                       <a:r>
-                        <a:t>0.150</a:t>
+                        <a:t>未跑</a:t>
                       </a:r>
                     </a:p>
                   </a:txBody>
@@ -6337,7 +6337,7 @@
                   </a:tcPr>
                 </a:tc>
               </a:tr>
-              <a:tr h="640080">
+              <a:tr h="731520">
                 <a:tc>
                   <a:txBody>
                     <a:bodyPr/>
@@ -6383,7 +6383,7 @@
                         </a:defRPr>
                       </a:pPr>
                       <a:r>
-                        <a:t>0.139</a:t>
+                        <a:t>0.244</a:t>
                       </a:r>
                     </a:p>
                   </a:txBody>
@@ -6400,7 +6400,7 @@
                         </a:defRPr>
                       </a:pPr>
                       <a:r>
-                        <a:t>0.300</a:t>
+                        <a:t>0.150</a:t>
                       </a:r>
                     </a:p>
                   </a:txBody>
@@ -6417,7 +6417,7 @@
                         </a:defRPr>
                       </a:pPr>
                       <a:r>
-                        <a:t>0.300</a:t>
+                        <a:t>0.150</a:t>
                       </a:r>
                     </a:p>
                   </a:txBody>
@@ -6434,26 +6434,26 @@
                         </a:defRPr>
                       </a:pPr>
                       <a:r>
-                        <a:t>0.150</a:t>
+                        <a:t>未跑</a:t>
                       </a:r>
                     </a:p>
                   </a:txBody>
                   <a:tcPr/>
                 </a:tc>
               </a:tr>
-              <a:tr h="640080">
-                <a:tc>
-                  <a:txBody>
-                    <a:bodyPr/>
-                    <a:lstStyle/>
-                    <a:p>
-                      <a:pPr algn="ctr">
-                        <a:defRPr sz="1200">
-                          <a:latin typeface="Microsoft YaHei"/>
-                        </a:defRPr>
-                      </a:pPr>
-                      <a:r>
-                        <a:t>00496 电网抓丧尸</a:t>
+              <a:tr h="731520">
+                <a:tc>
+                  <a:txBody>
+                    <a:bodyPr/>
+                    <a:lstStyle/>
+                    <a:p>
+                      <a:pPr algn="ctr">
+                        <a:defRPr sz="1200">
+                          <a:latin typeface="Microsoft YaHei"/>
+                        </a:defRPr>
+                      </a:pPr>
+                      <a:r>
+                        <a:t>00522 地下炸矿</a:t>
                       </a:r>
                     </a:p>
                   </a:txBody>
@@ -6495,7 +6495,7 @@
                         </a:defRPr>
                       </a:pPr>
                       <a:r>
-                        <a:t>0.275</a:t>
+                        <a:t>0.215</a:t>
                       </a:r>
                     </a:p>
                   </a:txBody>
@@ -6516,7 +6516,7 @@
                         </a:defRPr>
                       </a:pPr>
                       <a:r>
-                        <a:t>0.150</a:t>
+                        <a:t>0.227</a:t>
                       </a:r>
                     </a:p>
                   </a:txBody>
@@ -6537,7 +6537,7 @@
                         </a:defRPr>
                       </a:pPr>
                       <a:r>
-                        <a:t>0.150</a:t>
+                        <a:t>0.240</a:t>
                       </a:r>
                     </a:p>
                   </a:txBody>
@@ -6558,7 +6558,7 @@
                         </a:defRPr>
                       </a:pPr>
                       <a:r>
-                        <a:t>0.150</a:t>
+                        <a:t>未跑</a:t>
                       </a:r>
                     </a:p>
                   </a:txBody>
@@ -6569,19 +6569,19 @@
                   </a:tcPr>
                 </a:tc>
               </a:tr>
-              <a:tr h="640080">
-                <a:tc>
-                  <a:txBody>
-                    <a:bodyPr/>
-                    <a:lstStyle/>
-                    <a:p>
-                      <a:pPr algn="ctr">
-                        <a:defRPr sz="1200">
-                          <a:latin typeface="Microsoft YaHei"/>
-                        </a:defRPr>
-                      </a:pPr>
-                      <a:r>
-                        <a:t>00522 地下炸矿</a:t>
+              <a:tr h="731520">
+                <a:tc>
+                  <a:txBody>
+                    <a:bodyPr/>
+                    <a:lstStyle/>
+                    <a:p>
+                      <a:pPr algn="ctr">
+                        <a:defRPr sz="1200">
+                          <a:latin typeface="Microsoft YaHei"/>
+                        </a:defRPr>
+                      </a:pPr>
+                      <a:r>
+                        <a:t>00382 低坑杀鲨鱼</a:t>
                       </a:r>
                     </a:p>
                   </a:txBody>
@@ -6598,7 +6598,7 @@
                         </a:defRPr>
                       </a:pPr>
                       <a:r>
-                        <a:t>joystick</a:t>
+                        <a:t>tap-only</a:t>
                       </a:r>
                     </a:p>
                   </a:txBody>
@@ -6615,7 +6615,7 @@
                         </a:defRPr>
                       </a:pPr>
                       <a:r>
-                        <a:t>0.215</a:t>
+                        <a:t>0.300</a:t>
                       </a:r>
                     </a:p>
                   </a:txBody>
@@ -6632,7 +6632,7 @@
                         </a:defRPr>
                       </a:pPr>
                       <a:r>
-                        <a:t>0.240</a:t>
+                        <a:t>—</a:t>
                       </a:r>
                     </a:p>
                   </a:txBody>
@@ -6673,19 +6673,19 @@
                   <a:tcPr/>
                 </a:tc>
               </a:tr>
-              <a:tr h="640080">
-                <a:tc>
-                  <a:txBody>
-                    <a:bodyPr/>
-                    <a:lstStyle/>
-                    <a:p>
-                      <a:pPr algn="ctr">
-                        <a:defRPr sz="1200">
-                          <a:latin typeface="Microsoft YaHei"/>
-                        </a:defRPr>
-                      </a:pPr>
-                      <a:r>
-                        <a:t>00382 低坑杀鲨鱼</a:t>
+              <a:tr h="731520">
+                <a:tc>
+                  <a:txBody>
+                    <a:bodyPr/>
+                    <a:lstStyle/>
+                    <a:p>
+                      <a:pPr algn="ctr">
+                        <a:defRPr sz="1200">
+                          <a:latin typeface="Microsoft YaHei"/>
+                        </a:defRPr>
+                      </a:pPr>
+                      <a:r>
+                        <a:t>00594 破石收水</a:t>
                       </a:r>
                     </a:p>
                   </a:txBody>
@@ -6748,7 +6748,7 @@
                         </a:defRPr>
                       </a:pPr>
                       <a:r>
-                        <a:t>0.300</a:t>
+                        <a:t>—</a:t>
                       </a:r>
                     </a:p>
                   </a:txBody>
@@ -6769,7 +6769,7 @@
                         </a:defRPr>
                       </a:pPr>
                       <a:r>
-                        <a:t>—</a:t>
+                        <a:t>0.300</a:t>
                       </a:r>
                     </a:p>
                   </a:txBody>
@@ -6801,19 +6801,19 @@
                   </a:tcPr>
                 </a:tc>
               </a:tr>
-              <a:tr h="640080">
-                <a:tc>
-                  <a:txBody>
-                    <a:bodyPr/>
-                    <a:lstStyle/>
-                    <a:p>
-                      <a:pPr algn="ctr">
-                        <a:defRPr sz="1200">
-                          <a:latin typeface="Microsoft YaHei"/>
-                        </a:defRPr>
-                      </a:pPr>
-                      <a:r>
-                        <a:t>00594 破石收水</a:t>
+              <a:tr h="731520">
+                <a:tc>
+                  <a:txBody>
+                    <a:bodyPr/>
+                    <a:lstStyle/>
+                    <a:p>
+                      <a:pPr algn="ctr">
+                        <a:defRPr sz="1200">
+                          <a:latin typeface="Microsoft YaHei"/>
+                        </a:defRPr>
+                      </a:pPr>
+                      <a:r>
+                        <a:t>00742 加油小镇</a:t>
                       </a:r>
                     </a:p>
                   </a:txBody>
@@ -6864,6 +6864,23 @@
                         </a:defRPr>
                       </a:pPr>
                       <a:r>
+                        <a:t>—</a:t>
+                      </a:r>
+                    </a:p>
+                  </a:txBody>
+                  <a:tcPr/>
+                </a:tc>
+                <a:tc>
+                  <a:txBody>
+                    <a:bodyPr/>
+                    <a:lstStyle/>
+                    <a:p>
+                      <a:pPr algn="ctr">
+                        <a:defRPr sz="1200">
+                          <a:latin typeface="Microsoft YaHei"/>
+                        </a:defRPr>
+                      </a:pPr>
+                      <a:r>
                         <a:t>0.300</a:t>
                       </a:r>
                     </a:p>
@@ -6886,151 +6903,6 @@
                     </a:p>
                   </a:txBody>
                   <a:tcPr/>
-                </a:tc>
-                <a:tc>
-                  <a:txBody>
-                    <a:bodyPr/>
-                    <a:lstStyle/>
-                    <a:p>
-                      <a:pPr algn="ctr">
-                        <a:defRPr sz="1200">
-                          <a:latin typeface="Microsoft YaHei"/>
-                        </a:defRPr>
-                      </a:pPr>
-                      <a:r>
-                        <a:t>—</a:t>
-                      </a:r>
-                    </a:p>
-                  </a:txBody>
-                  <a:tcPr/>
-                </a:tc>
-              </a:tr>
-              <a:tr h="640080">
-                <a:tc>
-                  <a:txBody>
-                    <a:bodyPr/>
-                    <a:lstStyle/>
-                    <a:p>
-                      <a:pPr algn="ctr">
-                        <a:defRPr sz="1200">
-                          <a:latin typeface="Microsoft YaHei"/>
-                        </a:defRPr>
-                      </a:pPr>
-                      <a:r>
-                        <a:t>00742 加油小镇</a:t>
-                      </a:r>
-                    </a:p>
-                  </a:txBody>
-                  <a:tcPr>
-                    <a:solidFill>
-                      <a:srgbClr val="F3F6F9"/>
-                    </a:solidFill>
-                  </a:tcPr>
-                </a:tc>
-                <a:tc>
-                  <a:txBody>
-                    <a:bodyPr/>
-                    <a:lstStyle/>
-                    <a:p>
-                      <a:pPr algn="ctr">
-                        <a:defRPr sz="1200">
-                          <a:latin typeface="Microsoft YaHei"/>
-                        </a:defRPr>
-                      </a:pPr>
-                      <a:r>
-                        <a:t>tap-only</a:t>
-                      </a:r>
-                    </a:p>
-                  </a:txBody>
-                  <a:tcPr>
-                    <a:solidFill>
-                      <a:srgbClr val="F3F6F9"/>
-                    </a:solidFill>
-                  </a:tcPr>
-                </a:tc>
-                <a:tc>
-                  <a:txBody>
-                    <a:bodyPr/>
-                    <a:lstStyle/>
-                    <a:p>
-                      <a:pPr algn="ctr">
-                        <a:defRPr sz="1200">
-                          <a:latin typeface="Microsoft YaHei"/>
-                        </a:defRPr>
-                      </a:pPr>
-                      <a:r>
-                        <a:t>0.300</a:t>
-                      </a:r>
-                    </a:p>
-                  </a:txBody>
-                  <a:tcPr>
-                    <a:solidFill>
-                      <a:srgbClr val="F3F6F9"/>
-                    </a:solidFill>
-                  </a:tcPr>
-                </a:tc>
-                <a:tc>
-                  <a:txBody>
-                    <a:bodyPr/>
-                    <a:lstStyle/>
-                    <a:p>
-                      <a:pPr algn="ctr">
-                        <a:defRPr sz="1200">
-                          <a:latin typeface="Microsoft YaHei"/>
-                        </a:defRPr>
-                      </a:pPr>
-                      <a:r>
-                        <a:t>0.300</a:t>
-                      </a:r>
-                    </a:p>
-                  </a:txBody>
-                  <a:tcPr>
-                    <a:solidFill>
-                      <a:srgbClr val="F3F6F9"/>
-                    </a:solidFill>
-                  </a:tcPr>
-                </a:tc>
-                <a:tc>
-                  <a:txBody>
-                    <a:bodyPr/>
-                    <a:lstStyle/>
-                    <a:p>
-                      <a:pPr algn="ctr">
-                        <a:defRPr sz="1200">
-                          <a:latin typeface="Microsoft YaHei"/>
-                        </a:defRPr>
-                      </a:pPr>
-                      <a:r>
-                        <a:t>—</a:t>
-                      </a:r>
-                    </a:p>
-                  </a:txBody>
-                  <a:tcPr>
-                    <a:solidFill>
-                      <a:srgbClr val="F3F6F9"/>
-                    </a:solidFill>
-                  </a:tcPr>
-                </a:tc>
-                <a:tc>
-                  <a:txBody>
-                    <a:bodyPr/>
-                    <a:lstStyle/>
-                    <a:p>
-                      <a:pPr algn="ctr">
-                        <a:defRPr sz="1200">
-                          <a:latin typeface="Microsoft YaHei"/>
-                        </a:defRPr>
-                      </a:pPr>
-                      <a:r>
-                        <a:t>—</a:t>
-                      </a:r>
-                    </a:p>
-                  </a:txBody>
-                  <a:tcPr>
-                    <a:solidFill>
-                      <a:srgbClr val="F3F6F9"/>
-                    </a:solidFill>
-                  </a:tcPr>
                 </a:tc>
               </a:tr>
             </a:tbl>

</xml_diff>

<commit_message>
feat: complete B_tap 22-game matrix, merge training data, refresh report/PPT
- Continue and merge B_tap matrix for 00733/00742 (60/60 runs)
- Convert A_full + B_tap trajectories to vlm-training-data-A-full/B-tap
- Merge processed-runs/representative/A-full/B-tap -> 27,693 samples
- Update REPORT.md and EXPERIMENT_RESULTS.md with B_tap results
- Refresh PPT with 15-game B_tap table and 27,693 sample count
- Add continuation helper scripts (exp_continue_B_tap.py, merge_B_tap_continue.py)
- Ignore timestamped runtime trajectories and strategy memory files
</commit_message>
<xml_diff>
--- a/reports/smallgameagent_report.pptx
+++ b/reports/smallgameagent_report.pptx
@@ -26,7 +26,6 @@
     <p:sldId id="274" r:id="rId25"/>
     <p:sldId id="275" r:id="rId26"/>
     <p:sldId id="276" r:id="rId27"/>
-    <p:sldId id="277" r:id="rId28"/>
   </p:sldIdLst>
   <p:sldSz cx="12191695" cy="6858000" type="screen4x3"/>
   <p:notesSz cx="6858000" cy="9144000"/>
@@ -3547,7 +3546,7 @@
               </a:defRPr>
             </a:pPr>
             <a:r>
-              <a:t>10/22</a:t>
+              <a:t>10/21</a:t>
             </a:r>
           </a:p>
         </p:txBody>
@@ -3858,7 +3857,7 @@
               </a:defRPr>
             </a:pPr>
             <a:r>
-              <a:t>11/22</a:t>
+              <a:t>11/21</a:t>
             </a:r>
           </a:p>
         </p:txBody>
@@ -4107,7 +4106,7 @@
               </a:defRPr>
             </a:pPr>
             <a:r>
-              <a:t>12/22</a:t>
+              <a:t>12/21</a:t>
             </a:r>
           </a:p>
         </p:txBody>
@@ -4418,7 +4417,7 @@
               </a:defRPr>
             </a:pPr>
             <a:r>
-              <a:t>13/22</a:t>
+              <a:t>13/21</a:t>
             </a:r>
           </a:p>
         </p:txBody>
@@ -4667,7 +4666,7 @@
               </a:defRPr>
             </a:pPr>
             <a:r>
-              <a:t>14/22</a:t>
+              <a:t>14/21</a:t>
             </a:r>
           </a:p>
         </p:txBody>
@@ -4762,7 +4761,7 @@
               </a:defRPr>
             </a:pPr>
             <a:r>
-              <a:t>6 款代表性游戏：B 类 tap-only 全部满分</a:t>
+              <a:t>B 类 15 款 tap-only 游戏：8 款稳定满分，7 款待诊断</a:t>
             </a:r>
           </a:p>
         </p:txBody>
@@ -4786,1536 +4785,12 @@
                 <a:tableStyleId>{5C22544A-7EE6-4342-B048-85BDC9FD1C3A}</a:tableStyleId>
               </a:tblPr>
               <a:tblGrid>
-                <a:gridCol w="2249424"/>
-                <a:gridCol w="2249424"/>
-                <a:gridCol w="2249424"/>
-                <a:gridCol w="2249424"/>
-                <a:gridCol w="2249424"/>
+                <a:gridCol w="2811780"/>
+                <a:gridCol w="2811780"/>
+                <a:gridCol w="2811780"/>
+                <a:gridCol w="2811780"/>
               </a:tblGrid>
-              <a:tr h="393895">
-                <a:tc>
-                  <a:txBody>
-                    <a:bodyPr/>
-                    <a:lstStyle/>
-                    <a:p>
-                      <a:pPr algn="ctr">
-                        <a:defRPr sz="1300" b="1">
-                          <a:solidFill>
-                            <a:srgbClr val="F3F6F9"/>
-                          </a:solidFill>
-                          <a:latin typeface="Microsoft YaHei"/>
-                        </a:defRPr>
-                      </a:pPr>
-                      <a:r>
-                        <a:t>game_id</a:t>
-                      </a:r>
-                    </a:p>
-                  </a:txBody>
-                  <a:tcPr>
-                    <a:solidFill>
-                      <a:srgbClr val="1A237E"/>
-                    </a:solidFill>
-                  </a:tcPr>
-                </a:tc>
-                <a:tc>
-                  <a:txBody>
-                    <a:bodyPr/>
-                    <a:lstStyle/>
-                    <a:p>
-                      <a:pPr algn="ctr">
-                        <a:defRPr sz="1300" b="1">
-                          <a:solidFill>
-                            <a:srgbClr val="F3F6F9"/>
-                          </a:solidFill>
-                          <a:latin typeface="Microsoft YaHei"/>
-                        </a:defRPr>
-                      </a:pPr>
-                      <a:r>
-                        <a:t>mode</a:t>
-                      </a:r>
-                    </a:p>
-                  </a:txBody>
-                  <a:tcPr>
-                    <a:solidFill>
-                      <a:srgbClr val="1A237E"/>
-                    </a:solidFill>
-                  </a:tcPr>
-                </a:tc>
-                <a:tc>
-                  <a:txBody>
-                    <a:bodyPr/>
-                    <a:lstStyle/>
-                    <a:p>
-                      <a:pPr algn="ctr">
-                        <a:defRPr sz="1300" b="1">
-                          <a:solidFill>
-                            <a:srgbClr val="F3F6F9"/>
-                          </a:solidFill>
-                          <a:latin typeface="Microsoft YaHei"/>
-                        </a:defRPr>
-                      </a:pPr>
-                      <a:r>
-                        <a:t>composite</a:t>
-                      </a:r>
-                    </a:p>
-                  </a:txBody>
-                  <a:tcPr>
-                    <a:solidFill>
-                      <a:srgbClr val="1A237E"/>
-                    </a:solidFill>
-                  </a:tcPr>
-                </a:tc>
-                <a:tc>
-                  <a:txBody>
-                    <a:bodyPr/>
-                    <a:lstStyle/>
-                    <a:p>
-                      <a:pPr algn="ctr">
-                        <a:defRPr sz="1300" b="1">
-                          <a:solidFill>
-                            <a:srgbClr val="F3F6F9"/>
-                          </a:solidFill>
-                          <a:latin typeface="Microsoft YaHei"/>
-                        </a:defRPr>
-                      </a:pPr>
-                      <a:r>
-                        <a:t>activity</a:t>
-                      </a:r>
-                    </a:p>
-                  </a:txBody>
-                  <a:tcPr>
-                    <a:solidFill>
-                      <a:srgbClr val="1A237E"/>
-                    </a:solidFill>
-                  </a:tcPr>
-                </a:tc>
-                <a:tc>
-                  <a:txBody>
-                    <a:bodyPr/>
-                    <a:lstStyle/>
-                    <a:p>
-                      <a:pPr algn="ctr">
-                        <a:defRPr sz="1300" b="1">
-                          <a:solidFill>
-                            <a:srgbClr val="F3F6F9"/>
-                          </a:solidFill>
-                          <a:latin typeface="Microsoft YaHei"/>
-                        </a:defRPr>
-                      </a:pPr>
-                      <a:r>
-                        <a:t>stall</a:t>
-                      </a:r>
-                    </a:p>
-                  </a:txBody>
-                  <a:tcPr>
-                    <a:solidFill>
-                      <a:srgbClr val="1A237E"/>
-                    </a:solidFill>
-                  </a:tcPr>
-                </a:tc>
-              </a:tr>
-              <a:tr h="393895">
-                <a:tc>
-                  <a:txBody>
-                    <a:bodyPr/>
-                    <a:lstStyle/>
-                    <a:p>
-                      <a:pPr algn="ctr">
-                        <a:defRPr sz="1200">
-                          <a:latin typeface="Microsoft YaHei"/>
-                        </a:defRPr>
-                      </a:pPr>
-                      <a:r>
-                        <a:t>SSD_00382P01</a:t>
-                      </a:r>
-                    </a:p>
-                  </a:txBody>
-                  <a:tcPr>
-                    <a:solidFill>
-                      <a:srgbClr val="F3F6F9"/>
-                    </a:solidFill>
-                  </a:tcPr>
-                </a:tc>
-                <a:tc>
-                  <a:txBody>
-                    <a:bodyPr/>
-                    <a:lstStyle/>
-                    <a:p>
-                      <a:pPr algn="ctr">
-                        <a:defRPr sz="1200">
-                          <a:latin typeface="Microsoft YaHei"/>
-                        </a:defRPr>
-                      </a:pPr>
-                      <a:r>
-                        <a:t>rule</a:t>
-                      </a:r>
-                    </a:p>
-                  </a:txBody>
-                  <a:tcPr>
-                    <a:solidFill>
-                      <a:srgbClr val="F3F6F9"/>
-                    </a:solidFill>
-                  </a:tcPr>
-                </a:tc>
-                <a:tc>
-                  <a:txBody>
-                    <a:bodyPr/>
-                    <a:lstStyle/>
-                    <a:p>
-                      <a:pPr algn="ctr">
-                        <a:defRPr sz="1200">
-                          <a:latin typeface="Microsoft YaHei"/>
-                        </a:defRPr>
-                      </a:pPr>
-                      <a:r>
-                        <a:t>0.300</a:t>
-                      </a:r>
-                    </a:p>
-                  </a:txBody>
-                  <a:tcPr>
-                    <a:solidFill>
-                      <a:srgbClr val="F3F6F9"/>
-                    </a:solidFill>
-                  </a:tcPr>
-                </a:tc>
-                <a:tc>
-                  <a:txBody>
-                    <a:bodyPr/>
-                    <a:lstStyle/>
-                    <a:p>
-                      <a:pPr algn="ctr">
-                        <a:defRPr sz="1200">
-                          <a:latin typeface="Microsoft YaHei"/>
-                        </a:defRPr>
-                      </a:pPr>
-                      <a:r>
-                        <a:t>1.000</a:t>
-                      </a:r>
-                    </a:p>
-                  </a:txBody>
-                  <a:tcPr>
-                    <a:solidFill>
-                      <a:srgbClr val="F3F6F9"/>
-                    </a:solidFill>
-                  </a:tcPr>
-                </a:tc>
-                <a:tc>
-                  <a:txBody>
-                    <a:bodyPr/>
-                    <a:lstStyle/>
-                    <a:p>
-                      <a:pPr algn="ctr">
-                        <a:defRPr sz="1200">
-                          <a:latin typeface="Microsoft YaHei"/>
-                        </a:defRPr>
-                      </a:pPr>
-                      <a:r>
-                        <a:t>0</a:t>
-                      </a:r>
-                    </a:p>
-                  </a:txBody>
-                  <a:tcPr>
-                    <a:solidFill>
-                      <a:srgbClr val="F3F6F9"/>
-                    </a:solidFill>
-                  </a:tcPr>
-                </a:tc>
-              </a:tr>
-              <a:tr h="393895">
-                <a:tc>
-                  <a:txBody>
-                    <a:bodyPr/>
-                    <a:lstStyle/>
-                    <a:p>
-                      <a:pPr algn="ctr">
-                        <a:defRPr sz="1200">
-                          <a:latin typeface="Microsoft YaHei"/>
-                        </a:defRPr>
-                      </a:pPr>
-                      <a:r>
-                        <a:t>SSD_00382P01</a:t>
-                      </a:r>
-                    </a:p>
-                  </a:txBody>
-                  <a:tcPr/>
-                </a:tc>
-                <a:tc>
-                  <a:txBody>
-                    <a:bodyPr/>
-                    <a:lstStyle/>
-                    <a:p>
-                      <a:pPr algn="ctr">
-                        <a:defRPr sz="1200">
-                          <a:latin typeface="Microsoft YaHei"/>
-                        </a:defRPr>
-                      </a:pPr>
-                      <a:r>
-                        <a:t>multi-bus-memory</a:t>
-                      </a:r>
-                    </a:p>
-                  </a:txBody>
-                  <a:tcPr/>
-                </a:tc>
-                <a:tc>
-                  <a:txBody>
-                    <a:bodyPr/>
-                    <a:lstStyle/>
-                    <a:p>
-                      <a:pPr algn="ctr">
-                        <a:defRPr sz="1200">
-                          <a:latin typeface="Microsoft YaHei"/>
-                        </a:defRPr>
-                      </a:pPr>
-                      <a:r>
-                        <a:t>0.300</a:t>
-                      </a:r>
-                    </a:p>
-                  </a:txBody>
-                  <a:tcPr/>
-                </a:tc>
-                <a:tc>
-                  <a:txBody>
-                    <a:bodyPr/>
-                    <a:lstStyle/>
-                    <a:p>
-                      <a:pPr algn="ctr">
-                        <a:defRPr sz="1200">
-                          <a:latin typeface="Microsoft YaHei"/>
-                        </a:defRPr>
-                      </a:pPr>
-                      <a:r>
-                        <a:t>1.000</a:t>
-                      </a:r>
-                    </a:p>
-                  </a:txBody>
-                  <a:tcPr/>
-                </a:tc>
-                <a:tc>
-                  <a:txBody>
-                    <a:bodyPr/>
-                    <a:lstStyle/>
-                    <a:p>
-                      <a:pPr algn="ctr">
-                        <a:defRPr sz="1200">
-                          <a:latin typeface="Microsoft YaHei"/>
-                        </a:defRPr>
-                      </a:pPr>
-                      <a:r>
-                        <a:t>0</a:t>
-                      </a:r>
-                    </a:p>
-                  </a:txBody>
-                  <a:tcPr/>
-                </a:tc>
-              </a:tr>
-              <a:tr h="393895">
-                <a:tc>
-                  <a:txBody>
-                    <a:bodyPr/>
-                    <a:lstStyle/>
-                    <a:p>
-                      <a:pPr algn="ctr">
-                        <a:defRPr sz="1200">
-                          <a:latin typeface="Microsoft YaHei"/>
-                        </a:defRPr>
-                      </a:pPr>
-                      <a:r>
-                        <a:t>SSD_00461P01</a:t>
-                      </a:r>
-                    </a:p>
-                  </a:txBody>
-                  <a:tcPr>
-                    <a:solidFill>
-                      <a:srgbClr val="F3F6F9"/>
-                    </a:solidFill>
-                  </a:tcPr>
-                </a:tc>
-                <a:tc>
-                  <a:txBody>
-                    <a:bodyPr/>
-                    <a:lstStyle/>
-                    <a:p>
-                      <a:pPr algn="ctr">
-                        <a:defRPr sz="1200">
-                          <a:latin typeface="Microsoft YaHei"/>
-                        </a:defRPr>
-                      </a:pPr>
-                      <a:r>
-                        <a:t>rule</a:t>
-                      </a:r>
-                    </a:p>
-                  </a:txBody>
-                  <a:tcPr>
-                    <a:solidFill>
-                      <a:srgbClr val="F3F6F9"/>
-                    </a:solidFill>
-                  </a:tcPr>
-                </a:tc>
-                <a:tc>
-                  <a:txBody>
-                    <a:bodyPr/>
-                    <a:lstStyle/>
-                    <a:p>
-                      <a:pPr algn="ctr">
-                        <a:defRPr sz="1200">
-                          <a:latin typeface="Microsoft YaHei"/>
-                        </a:defRPr>
-                      </a:pPr>
-                      <a:r>
-                        <a:t>0.106</a:t>
-                      </a:r>
-                    </a:p>
-                  </a:txBody>
-                  <a:tcPr>
-                    <a:solidFill>
-                      <a:srgbClr val="F3F6F9"/>
-                    </a:solidFill>
-                  </a:tcPr>
-                </a:tc>
-                <a:tc>
-                  <a:txBody>
-                    <a:bodyPr/>
-                    <a:lstStyle/>
-                    <a:p>
-                      <a:pPr algn="ctr">
-                        <a:defRPr sz="1200">
-                          <a:latin typeface="Microsoft YaHei"/>
-                        </a:defRPr>
-                      </a:pPr>
-                      <a:r>
-                        <a:t>0.708</a:t>
-                      </a:r>
-                    </a:p>
-                  </a:txBody>
-                  <a:tcPr>
-                    <a:solidFill>
-                      <a:srgbClr val="F3F6F9"/>
-                    </a:solidFill>
-                  </a:tcPr>
-                </a:tc>
-                <a:tc>
-                  <a:txBody>
-                    <a:bodyPr/>
-                    <a:lstStyle/>
-                    <a:p>
-                      <a:pPr algn="ctr">
-                        <a:defRPr sz="1200">
-                          <a:latin typeface="Microsoft YaHei"/>
-                        </a:defRPr>
-                      </a:pPr>
-                      <a:r>
-                        <a:t>7</a:t>
-                      </a:r>
-                    </a:p>
-                  </a:txBody>
-                  <a:tcPr>
-                    <a:solidFill>
-                      <a:srgbClr val="F3F6F9"/>
-                    </a:solidFill>
-                  </a:tcPr>
-                </a:tc>
-              </a:tr>
-              <a:tr h="393895">
-                <a:tc>
-                  <a:txBody>
-                    <a:bodyPr/>
-                    <a:lstStyle/>
-                    <a:p>
-                      <a:pPr algn="ctr">
-                        <a:defRPr sz="1200">
-                          <a:latin typeface="Microsoft YaHei"/>
-                        </a:defRPr>
-                      </a:pPr>
-                      <a:r>
-                        <a:t>SSD_00461P01</a:t>
-                      </a:r>
-                    </a:p>
-                  </a:txBody>
-                  <a:tcPr/>
-                </a:tc>
-                <a:tc>
-                  <a:txBody>
-                    <a:bodyPr/>
-                    <a:lstStyle/>
-                    <a:p>
-                      <a:pPr algn="ctr">
-                        <a:defRPr sz="1200">
-                          <a:latin typeface="Microsoft YaHei"/>
-                        </a:defRPr>
-                      </a:pPr>
-                      <a:r>
-                        <a:t>multi-bus-memory</a:t>
-                      </a:r>
-                    </a:p>
-                  </a:txBody>
-                  <a:tcPr/>
-                </a:tc>
-                <a:tc>
-                  <a:txBody>
-                    <a:bodyPr/>
-                    <a:lstStyle/>
-                    <a:p>
-                      <a:pPr algn="ctr">
-                        <a:defRPr sz="1200">
-                          <a:latin typeface="Microsoft YaHei"/>
-                        </a:defRPr>
-                      </a:pPr>
-                      <a:r>
-                        <a:t>0.300</a:t>
-                      </a:r>
-                    </a:p>
-                  </a:txBody>
-                  <a:tcPr/>
-                </a:tc>
-                <a:tc>
-                  <a:txBody>
-                    <a:bodyPr/>
-                    <a:lstStyle/>
-                    <a:p>
-                      <a:pPr algn="ctr">
-                        <a:defRPr sz="1200">
-                          <a:latin typeface="Microsoft YaHei"/>
-                        </a:defRPr>
-                      </a:pPr>
-                      <a:r>
-                        <a:t>1.000</a:t>
-                      </a:r>
-                    </a:p>
-                  </a:txBody>
-                  <a:tcPr/>
-                </a:tc>
-                <a:tc>
-                  <a:txBody>
-                    <a:bodyPr/>
-                    <a:lstStyle/>
-                    <a:p>
-                      <a:pPr algn="ctr">
-                        <a:defRPr sz="1200">
-                          <a:latin typeface="Microsoft YaHei"/>
-                        </a:defRPr>
-                      </a:pPr>
-                      <a:r>
-                        <a:t>0</a:t>
-                      </a:r>
-                    </a:p>
-                  </a:txBody>
-                  <a:tcPr/>
-                </a:tc>
-              </a:tr>
-              <a:tr h="393895">
-                <a:tc>
-                  <a:txBody>
-                    <a:bodyPr/>
-                    <a:lstStyle/>
-                    <a:p>
-                      <a:pPr algn="ctr">
-                        <a:defRPr sz="1200">
-                          <a:latin typeface="Microsoft YaHei"/>
-                        </a:defRPr>
-                      </a:pPr>
-                      <a:r>
-                        <a:t>SSD_00483P01</a:t>
-                      </a:r>
-                    </a:p>
-                  </a:txBody>
-                  <a:tcPr>
-                    <a:solidFill>
-                      <a:srgbClr val="F3F6F9"/>
-                    </a:solidFill>
-                  </a:tcPr>
-                </a:tc>
-                <a:tc>
-                  <a:txBody>
-                    <a:bodyPr/>
-                    <a:lstStyle/>
-                    <a:p>
-                      <a:pPr algn="ctr">
-                        <a:defRPr sz="1200">
-                          <a:latin typeface="Microsoft YaHei"/>
-                        </a:defRPr>
-                      </a:pPr>
-                      <a:r>
-                        <a:t>rule</a:t>
-                      </a:r>
-                    </a:p>
-                  </a:txBody>
-                  <a:tcPr>
-                    <a:solidFill>
-                      <a:srgbClr val="F3F6F9"/>
-                    </a:solidFill>
-                  </a:tcPr>
-                </a:tc>
-                <a:tc>
-                  <a:txBody>
-                    <a:bodyPr/>
-                    <a:lstStyle/>
-                    <a:p>
-                      <a:pPr algn="ctr">
-                        <a:defRPr sz="1200">
-                          <a:latin typeface="Microsoft YaHei"/>
-                        </a:defRPr>
-                      </a:pPr>
-                      <a:r>
-                        <a:t>0.244</a:t>
-                      </a:r>
-                    </a:p>
-                  </a:txBody>
-                  <a:tcPr>
-                    <a:solidFill>
-                      <a:srgbClr val="F3F6F9"/>
-                    </a:solidFill>
-                  </a:tcPr>
-                </a:tc>
-                <a:tc>
-                  <a:txBody>
-                    <a:bodyPr/>
-                    <a:lstStyle/>
-                    <a:p>
-                      <a:pPr algn="ctr">
-                        <a:defRPr sz="1200">
-                          <a:latin typeface="Microsoft YaHei"/>
-                        </a:defRPr>
-                      </a:pPr>
-                      <a:r>
-                        <a:t>0.625</a:t>
-                      </a:r>
-                    </a:p>
-                  </a:txBody>
-                  <a:tcPr>
-                    <a:solidFill>
-                      <a:srgbClr val="F3F6F9"/>
-                    </a:solidFill>
-                  </a:tcPr>
-                </a:tc>
-                <a:tc>
-                  <a:txBody>
-                    <a:bodyPr/>
-                    <a:lstStyle/>
-                    <a:p>
-                      <a:pPr algn="ctr">
-                        <a:defRPr sz="1200">
-                          <a:latin typeface="Microsoft YaHei"/>
-                        </a:defRPr>
-                      </a:pPr>
-                      <a:r>
-                        <a:t>9</a:t>
-                      </a:r>
-                    </a:p>
-                  </a:txBody>
-                  <a:tcPr>
-                    <a:solidFill>
-                      <a:srgbClr val="F3F6F9"/>
-                    </a:solidFill>
-                  </a:tcPr>
-                </a:tc>
-              </a:tr>
-              <a:tr h="393895">
-                <a:tc>
-                  <a:txBody>
-                    <a:bodyPr/>
-                    <a:lstStyle/>
-                    <a:p>
-                      <a:pPr algn="ctr">
-                        <a:defRPr sz="1200">
-                          <a:latin typeface="Microsoft YaHei"/>
-                        </a:defRPr>
-                      </a:pPr>
-                      <a:r>
-                        <a:t>SSD_00483P01</a:t>
-                      </a:r>
-                    </a:p>
-                  </a:txBody>
-                  <a:tcPr/>
-                </a:tc>
-                <a:tc>
-                  <a:txBody>
-                    <a:bodyPr/>
-                    <a:lstStyle/>
-                    <a:p>
-                      <a:pPr algn="ctr">
-                        <a:defRPr sz="1200">
-                          <a:latin typeface="Microsoft YaHei"/>
-                        </a:defRPr>
-                      </a:pPr>
-                      <a:r>
-                        <a:t>multi-bus-memory</a:t>
-                      </a:r>
-                    </a:p>
-                  </a:txBody>
-                  <a:tcPr/>
-                </a:tc>
-                <a:tc>
-                  <a:txBody>
-                    <a:bodyPr/>
-                    <a:lstStyle/>
-                    <a:p>
-                      <a:pPr algn="ctr">
-                        <a:defRPr sz="1200">
-                          <a:latin typeface="Microsoft YaHei"/>
-                        </a:defRPr>
-                      </a:pPr>
-                      <a:r>
-                        <a:t>0.150</a:t>
-                      </a:r>
-                    </a:p>
-                  </a:txBody>
-                  <a:tcPr/>
-                </a:tc>
-                <a:tc>
-                  <a:txBody>
-                    <a:bodyPr/>
-                    <a:lstStyle/>
-                    <a:p>
-                      <a:pPr algn="ctr">
-                        <a:defRPr sz="1200">
-                          <a:latin typeface="Microsoft YaHei"/>
-                        </a:defRPr>
-                      </a:pPr>
-                      <a:r>
-                        <a:t>0.000</a:t>
-                      </a:r>
-                    </a:p>
-                  </a:txBody>
-                  <a:tcPr/>
-                </a:tc>
-                <a:tc>
-                  <a:txBody>
-                    <a:bodyPr/>
-                    <a:lstStyle/>
-                    <a:p>
-                      <a:pPr algn="ctr">
-                        <a:defRPr sz="1200">
-                          <a:latin typeface="Microsoft YaHei"/>
-                        </a:defRPr>
-                      </a:pPr>
-                      <a:r>
-                        <a:t>24</a:t>
-                      </a:r>
-                    </a:p>
-                  </a:txBody>
-                  <a:tcPr/>
-                </a:tc>
-              </a:tr>
-              <a:tr h="393895">
-                <a:tc>
-                  <a:txBody>
-                    <a:bodyPr/>
-                    <a:lstStyle/>
-                    <a:p>
-                      <a:pPr algn="ctr">
-                        <a:defRPr sz="1200">
-                          <a:latin typeface="Microsoft YaHei"/>
-                        </a:defRPr>
-                      </a:pPr>
-                      <a:r>
-                        <a:t>SSD_00522P02</a:t>
-                      </a:r>
-                    </a:p>
-                  </a:txBody>
-                  <a:tcPr>
-                    <a:solidFill>
-                      <a:srgbClr val="F3F6F9"/>
-                    </a:solidFill>
-                  </a:tcPr>
-                </a:tc>
-                <a:tc>
-                  <a:txBody>
-                    <a:bodyPr/>
-                    <a:lstStyle/>
-                    <a:p>
-                      <a:pPr algn="ctr">
-                        <a:defRPr sz="1200">
-                          <a:latin typeface="Microsoft YaHei"/>
-                        </a:defRPr>
-                      </a:pPr>
-                      <a:r>
-                        <a:t>rule</a:t>
-                      </a:r>
-                    </a:p>
-                  </a:txBody>
-                  <a:tcPr>
-                    <a:solidFill>
-                      <a:srgbClr val="F3F6F9"/>
-                    </a:solidFill>
-                  </a:tcPr>
-                </a:tc>
-                <a:tc>
-                  <a:txBody>
-                    <a:bodyPr/>
-                    <a:lstStyle/>
-                    <a:p>
-                      <a:pPr algn="ctr">
-                        <a:defRPr sz="1200">
-                          <a:latin typeface="Microsoft YaHei"/>
-                        </a:defRPr>
-                      </a:pPr>
-                      <a:r>
-                        <a:t>0.215</a:t>
-                      </a:r>
-                    </a:p>
-                  </a:txBody>
-                  <a:tcPr>
-                    <a:solidFill>
-                      <a:srgbClr val="F3F6F9"/>
-                    </a:solidFill>
-                  </a:tcPr>
-                </a:tc>
-                <a:tc>
-                  <a:txBody>
-                    <a:bodyPr/>
-                    <a:lstStyle/>
-                    <a:p>
-                      <a:pPr algn="ctr">
-                        <a:defRPr sz="1200">
-                          <a:latin typeface="Microsoft YaHei"/>
-                        </a:defRPr>
-                      </a:pPr>
-                      <a:r>
-                        <a:t>0.833</a:t>
-                      </a:r>
-                    </a:p>
-                  </a:txBody>
-                  <a:tcPr>
-                    <a:solidFill>
-                      <a:srgbClr val="F3F6F9"/>
-                    </a:solidFill>
-                  </a:tcPr>
-                </a:tc>
-                <a:tc>
-                  <a:txBody>
-                    <a:bodyPr/>
-                    <a:lstStyle/>
-                    <a:p>
-                      <a:pPr algn="ctr">
-                        <a:defRPr sz="1200">
-                          <a:latin typeface="Microsoft YaHei"/>
-                        </a:defRPr>
-                      </a:pPr>
-                      <a:r>
-                        <a:t>4</a:t>
-                      </a:r>
-                    </a:p>
-                  </a:txBody>
-                  <a:tcPr>
-                    <a:solidFill>
-                      <a:srgbClr val="F3F6F9"/>
-                    </a:solidFill>
-                  </a:tcPr>
-                </a:tc>
-              </a:tr>
-              <a:tr h="393895">
-                <a:tc>
-                  <a:txBody>
-                    <a:bodyPr/>
-                    <a:lstStyle/>
-                    <a:p>
-                      <a:pPr algn="ctr">
-                        <a:defRPr sz="1200">
-                          <a:latin typeface="Microsoft YaHei"/>
-                        </a:defRPr>
-                      </a:pPr>
-                      <a:r>
-                        <a:t>SSD_00522P02</a:t>
-                      </a:r>
-                    </a:p>
-                  </a:txBody>
-                  <a:tcPr/>
-                </a:tc>
-                <a:tc>
-                  <a:txBody>
-                    <a:bodyPr/>
-                    <a:lstStyle/>
-                    <a:p>
-                      <a:pPr algn="ctr">
-                        <a:defRPr sz="1200">
-                          <a:latin typeface="Microsoft YaHei"/>
-                        </a:defRPr>
-                      </a:pPr>
-                      <a:r>
-                        <a:t>multi-bus-memory</a:t>
-                      </a:r>
-                    </a:p>
-                  </a:txBody>
-                  <a:tcPr/>
-                </a:tc>
-                <a:tc>
-                  <a:txBody>
-                    <a:bodyPr/>
-                    <a:lstStyle/>
-                    <a:p>
-                      <a:pPr algn="ctr">
-                        <a:defRPr sz="1200">
-                          <a:latin typeface="Microsoft YaHei"/>
-                        </a:defRPr>
-                      </a:pPr>
-                      <a:r>
-                        <a:t>0.240</a:t>
-                      </a:r>
-                    </a:p>
-                  </a:txBody>
-                  <a:tcPr/>
-                </a:tc>
-                <a:tc>
-                  <a:txBody>
-                    <a:bodyPr/>
-                    <a:lstStyle/>
-                    <a:p>
-                      <a:pPr algn="ctr">
-                        <a:defRPr sz="1200">
-                          <a:latin typeface="Microsoft YaHei"/>
-                        </a:defRPr>
-                      </a:pPr>
-                      <a:r>
-                        <a:t>1.000</a:t>
-                      </a:r>
-                    </a:p>
-                  </a:txBody>
-                  <a:tcPr/>
-                </a:tc>
-                <a:tc>
-                  <a:txBody>
-                    <a:bodyPr/>
-                    <a:lstStyle/>
-                    <a:p>
-                      <a:pPr algn="ctr">
-                        <a:defRPr sz="1200">
-                          <a:latin typeface="Microsoft YaHei"/>
-                        </a:defRPr>
-                      </a:pPr>
-                      <a:r>
-                        <a:t>0</a:t>
-                      </a:r>
-                    </a:p>
-                  </a:txBody>
-                  <a:tcPr/>
-                </a:tc>
-              </a:tr>
-              <a:tr h="393895">
-                <a:tc>
-                  <a:txBody>
-                    <a:bodyPr/>
-                    <a:lstStyle/>
-                    <a:p>
-                      <a:pPr algn="ctr">
-                        <a:defRPr sz="1200">
-                          <a:latin typeface="Microsoft YaHei"/>
-                        </a:defRPr>
-                      </a:pPr>
-                      <a:r>
-                        <a:t>SSD_00594P02</a:t>
-                      </a:r>
-                    </a:p>
-                  </a:txBody>
-                  <a:tcPr>
-                    <a:solidFill>
-                      <a:srgbClr val="F3F6F9"/>
-                    </a:solidFill>
-                  </a:tcPr>
-                </a:tc>
-                <a:tc>
-                  <a:txBody>
-                    <a:bodyPr/>
-                    <a:lstStyle/>
-                    <a:p>
-                      <a:pPr algn="ctr">
-                        <a:defRPr sz="1200">
-                          <a:latin typeface="Microsoft YaHei"/>
-                        </a:defRPr>
-                      </a:pPr>
-                      <a:r>
-                        <a:t>rule</a:t>
-                      </a:r>
-                    </a:p>
-                  </a:txBody>
-                  <a:tcPr>
-                    <a:solidFill>
-                      <a:srgbClr val="F3F6F9"/>
-                    </a:solidFill>
-                  </a:tcPr>
-                </a:tc>
-                <a:tc>
-                  <a:txBody>
-                    <a:bodyPr/>
-                    <a:lstStyle/>
-                    <a:p>
-                      <a:pPr algn="ctr">
-                        <a:defRPr sz="1200">
-                          <a:latin typeface="Microsoft YaHei"/>
-                        </a:defRPr>
-                      </a:pPr>
-                      <a:r>
-                        <a:t>0.300</a:t>
-                      </a:r>
-                    </a:p>
-                  </a:txBody>
-                  <a:tcPr>
-                    <a:solidFill>
-                      <a:srgbClr val="F3F6F9"/>
-                    </a:solidFill>
-                  </a:tcPr>
-                </a:tc>
-                <a:tc>
-                  <a:txBody>
-                    <a:bodyPr/>
-                    <a:lstStyle/>
-                    <a:p>
-                      <a:pPr algn="ctr">
-                        <a:defRPr sz="1200">
-                          <a:latin typeface="Microsoft YaHei"/>
-                        </a:defRPr>
-                      </a:pPr>
-                      <a:r>
-                        <a:t>1.000</a:t>
-                      </a:r>
-                    </a:p>
-                  </a:txBody>
-                  <a:tcPr>
-                    <a:solidFill>
-                      <a:srgbClr val="F3F6F9"/>
-                    </a:solidFill>
-                  </a:tcPr>
-                </a:tc>
-                <a:tc>
-                  <a:txBody>
-                    <a:bodyPr/>
-                    <a:lstStyle/>
-                    <a:p>
-                      <a:pPr algn="ctr">
-                        <a:defRPr sz="1200">
-                          <a:latin typeface="Microsoft YaHei"/>
-                        </a:defRPr>
-                      </a:pPr>
-                      <a:r>
-                        <a:t>0</a:t>
-                      </a:r>
-                    </a:p>
-                  </a:txBody>
-                  <a:tcPr>
-                    <a:solidFill>
-                      <a:srgbClr val="F3F6F9"/>
-                    </a:solidFill>
-                  </a:tcPr>
-                </a:tc>
-              </a:tr>
-              <a:tr h="393895">
-                <a:tc>
-                  <a:txBody>
-                    <a:bodyPr/>
-                    <a:lstStyle/>
-                    <a:p>
-                      <a:pPr algn="ctr">
-                        <a:defRPr sz="1200">
-                          <a:latin typeface="Microsoft YaHei"/>
-                        </a:defRPr>
-                      </a:pPr>
-                      <a:r>
-                        <a:t>SSD_00594P02</a:t>
-                      </a:r>
-                    </a:p>
-                  </a:txBody>
-                  <a:tcPr/>
-                </a:tc>
-                <a:tc>
-                  <a:txBody>
-                    <a:bodyPr/>
-                    <a:lstStyle/>
-                    <a:p>
-                      <a:pPr algn="ctr">
-                        <a:defRPr sz="1200">
-                          <a:latin typeface="Microsoft YaHei"/>
-                        </a:defRPr>
-                      </a:pPr>
-                      <a:r>
-                        <a:t>multi-bus-memory</a:t>
-                      </a:r>
-                    </a:p>
-                  </a:txBody>
-                  <a:tcPr/>
-                </a:tc>
-                <a:tc>
-                  <a:txBody>
-                    <a:bodyPr/>
-                    <a:lstStyle/>
-                    <a:p>
-                      <a:pPr algn="ctr">
-                        <a:defRPr sz="1200">
-                          <a:latin typeface="Microsoft YaHei"/>
-                        </a:defRPr>
-                      </a:pPr>
-                      <a:r>
-                        <a:t>0.300</a:t>
-                      </a:r>
-                    </a:p>
-                  </a:txBody>
-                  <a:tcPr/>
-                </a:tc>
-                <a:tc>
-                  <a:txBody>
-                    <a:bodyPr/>
-                    <a:lstStyle/>
-                    <a:p>
-                      <a:pPr algn="ctr">
-                        <a:defRPr sz="1200">
-                          <a:latin typeface="Microsoft YaHei"/>
-                        </a:defRPr>
-                      </a:pPr>
-                      <a:r>
-                        <a:t>1.000</a:t>
-                      </a:r>
-                    </a:p>
-                  </a:txBody>
-                  <a:tcPr/>
-                </a:tc>
-                <a:tc>
-                  <a:txBody>
-                    <a:bodyPr/>
-                    <a:lstStyle/>
-                    <a:p>
-                      <a:pPr algn="ctr">
-                        <a:defRPr sz="1200">
-                          <a:latin typeface="Microsoft YaHei"/>
-                        </a:defRPr>
-                      </a:pPr>
-                      <a:r>
-                        <a:t>0</a:t>
-                      </a:r>
-                    </a:p>
-                  </a:txBody>
-                  <a:tcPr/>
-                </a:tc>
-              </a:tr>
-              <a:tr h="393895">
-                <a:tc>
-                  <a:txBody>
-                    <a:bodyPr/>
-                    <a:lstStyle/>
-                    <a:p>
-                      <a:pPr algn="ctr">
-                        <a:defRPr sz="1200">
-                          <a:latin typeface="Microsoft YaHei"/>
-                        </a:defRPr>
-                      </a:pPr>
-                      <a:r>
-                        <a:t>SSD_00742P01</a:t>
-                      </a:r>
-                    </a:p>
-                  </a:txBody>
-                  <a:tcPr>
-                    <a:solidFill>
-                      <a:srgbClr val="F3F6F9"/>
-                    </a:solidFill>
-                  </a:tcPr>
-                </a:tc>
-                <a:tc>
-                  <a:txBody>
-                    <a:bodyPr/>
-                    <a:lstStyle/>
-                    <a:p>
-                      <a:pPr algn="ctr">
-                        <a:defRPr sz="1200">
-                          <a:latin typeface="Microsoft YaHei"/>
-                        </a:defRPr>
-                      </a:pPr>
-                      <a:r>
-                        <a:t>rule</a:t>
-                      </a:r>
-                    </a:p>
-                  </a:txBody>
-                  <a:tcPr>
-                    <a:solidFill>
-                      <a:srgbClr val="F3F6F9"/>
-                    </a:solidFill>
-                  </a:tcPr>
-                </a:tc>
-                <a:tc>
-                  <a:txBody>
-                    <a:bodyPr/>
-                    <a:lstStyle/>
-                    <a:p>
-                      <a:pPr algn="ctr">
-                        <a:defRPr sz="1200">
-                          <a:latin typeface="Microsoft YaHei"/>
-                        </a:defRPr>
-                      </a:pPr>
-                      <a:r>
-                        <a:t>0.300</a:t>
-                      </a:r>
-                    </a:p>
-                  </a:txBody>
-                  <a:tcPr>
-                    <a:solidFill>
-                      <a:srgbClr val="F3F6F9"/>
-                    </a:solidFill>
-                  </a:tcPr>
-                </a:tc>
-                <a:tc>
-                  <a:txBody>
-                    <a:bodyPr/>
-                    <a:lstStyle/>
-                    <a:p>
-                      <a:pPr algn="ctr">
-                        <a:defRPr sz="1200">
-                          <a:latin typeface="Microsoft YaHei"/>
-                        </a:defRPr>
-                      </a:pPr>
-                      <a:r>
-                        <a:t>1.000</a:t>
-                      </a:r>
-                    </a:p>
-                  </a:txBody>
-                  <a:tcPr>
-                    <a:solidFill>
-                      <a:srgbClr val="F3F6F9"/>
-                    </a:solidFill>
-                  </a:tcPr>
-                </a:tc>
-                <a:tc>
-                  <a:txBody>
-                    <a:bodyPr/>
-                    <a:lstStyle/>
-                    <a:p>
-                      <a:pPr algn="ctr">
-                        <a:defRPr sz="1200">
-                          <a:latin typeface="Microsoft YaHei"/>
-                        </a:defRPr>
-                      </a:pPr>
-                      <a:r>
-                        <a:t>0</a:t>
-                      </a:r>
-                    </a:p>
-                  </a:txBody>
-                  <a:tcPr>
-                    <a:solidFill>
-                      <a:srgbClr val="F3F6F9"/>
-                    </a:solidFill>
-                  </a:tcPr>
-                </a:tc>
-              </a:tr>
-              <a:tr h="393900">
-                <a:tc>
-                  <a:txBody>
-                    <a:bodyPr/>
-                    <a:lstStyle/>
-                    <a:p>
-                      <a:pPr algn="ctr">
-                        <a:defRPr sz="1200">
-                          <a:latin typeface="Microsoft YaHei"/>
-                        </a:defRPr>
-                      </a:pPr>
-                      <a:r>
-                        <a:t>SSD_00742P01</a:t>
-                      </a:r>
-                    </a:p>
-                  </a:txBody>
-                  <a:tcPr/>
-                </a:tc>
-                <a:tc>
-                  <a:txBody>
-                    <a:bodyPr/>
-                    <a:lstStyle/>
-                    <a:p>
-                      <a:pPr algn="ctr">
-                        <a:defRPr sz="1200">
-                          <a:latin typeface="Microsoft YaHei"/>
-                        </a:defRPr>
-                      </a:pPr>
-                      <a:r>
-                        <a:t>multi-bus-memory</a:t>
-                      </a:r>
-                    </a:p>
-                  </a:txBody>
-                  <a:tcPr/>
-                </a:tc>
-                <a:tc>
-                  <a:txBody>
-                    <a:bodyPr/>
-                    <a:lstStyle/>
-                    <a:p>
-                      <a:pPr algn="ctr">
-                        <a:defRPr sz="1200">
-                          <a:latin typeface="Microsoft YaHei"/>
-                        </a:defRPr>
-                      </a:pPr>
-                      <a:r>
-                        <a:t>0.300</a:t>
-                      </a:r>
-                    </a:p>
-                  </a:txBody>
-                  <a:tcPr/>
-                </a:tc>
-                <a:tc>
-                  <a:txBody>
-                    <a:bodyPr/>
-                    <a:lstStyle/>
-                    <a:p>
-                      <a:pPr algn="ctr">
-                        <a:defRPr sz="1200">
-                          <a:latin typeface="Microsoft YaHei"/>
-                        </a:defRPr>
-                      </a:pPr>
-                      <a:r>
-                        <a:t>1.000</a:t>
-                      </a:r>
-                    </a:p>
-                  </a:txBody>
-                  <a:tcPr/>
-                </a:tc>
-                <a:tc>
-                  <a:txBody>
-                    <a:bodyPr/>
-                    <a:lstStyle/>
-                    <a:p>
-                      <a:pPr algn="ctr">
-                        <a:defRPr sz="1200">
-                          <a:latin typeface="Microsoft YaHei"/>
-                        </a:defRPr>
-                      </a:pPr>
-                      <a:r>
-                        <a:t>0</a:t>
-                      </a:r>
-                    </a:p>
-                  </a:txBody>
-                  <a:tcPr/>
-                </a:tc>
-              </a:tr>
-            </a:tbl>
-          </a:graphicData>
-        </a:graphic>
-      </p:graphicFrame>
-      <p:sp>
-        <p:nvSpPr>
-          <p:cNvPr id="5" name="Rectangle 4"/>
-          <p:cNvSpPr/>
-          <p:nvPr/>
-        </p:nvSpPr>
-        <p:spPr>
-          <a:xfrm>
-            <a:off x="0" y="6537960"/>
-            <a:ext cx="12191695" cy="18288"/>
-          </a:xfrm>
-          <a:prstGeom prst="rect">
-            <a:avLst/>
-          </a:prstGeom>
-          <a:solidFill>
-            <a:srgbClr val="0096C7"/>
-          </a:solidFill>
-          <a:ln/>
-        </p:spPr>
-        <p:style>
-          <a:lnRef idx="1">
-            <a:schemeClr val="accent1"/>
-          </a:lnRef>
-          <a:fillRef idx="3">
-            <a:schemeClr val="accent1"/>
-          </a:fillRef>
-          <a:effectRef idx="2">
-            <a:schemeClr val="accent1"/>
-          </a:effectRef>
-          <a:fontRef idx="minor">
-            <a:schemeClr val="lt1"/>
-          </a:fontRef>
-        </p:style>
-        <p:txBody>
-          <a:bodyPr rtlCol="0" anchor="ctr"/>
-          <a:lstStyle/>
-          <a:p>
-            <a:pPr algn="ctr"/>
-          </a:p>
-        </p:txBody>
-      </p:sp>
-      <p:sp>
-        <p:nvSpPr>
-          <p:cNvPr id="6" name="TextBox 5"/>
-          <p:cNvSpPr txBox="1"/>
-          <p:nvPr/>
-        </p:nvSpPr>
-        <p:spPr>
-          <a:xfrm>
-            <a:off x="457200" y="6583680"/>
-            <a:ext cx="3657600" cy="228600"/>
-          </a:xfrm>
-          <a:prstGeom prst="rect">
-            <a:avLst/>
-          </a:prstGeom>
-          <a:noFill/>
-        </p:spPr>
-        <p:txBody>
-          <a:bodyPr wrap="none">
-            <a:spAutoFit/>
-          </a:bodyPr>
-          <a:lstStyle/>
-          <a:p>
-            <a:pPr algn="l">
-              <a:defRPr sz="1000" b="0">
-                <a:solidFill>
-                  <a:srgbClr val="6C757D"/>
-                </a:solidFill>
-                <a:latin typeface="Microsoft YaHei"/>
-              </a:defRPr>
-            </a:pPr>
-            <a:r>
-              <a:t>smallgameagent · LLM/VLM + 规则驱动</a:t>
-            </a:r>
-          </a:p>
-        </p:txBody>
-      </p:sp>
-      <p:sp>
-        <p:nvSpPr>
-          <p:cNvPr id="7" name="TextBox 6"/>
-          <p:cNvSpPr txBox="1"/>
-          <p:nvPr/>
-        </p:nvSpPr>
-        <p:spPr>
-          <a:xfrm>
-            <a:off x="10789920" y="6583680"/>
-            <a:ext cx="914400" cy="228600"/>
-          </a:xfrm>
-          <a:prstGeom prst="rect">
-            <a:avLst/>
-          </a:prstGeom>
-          <a:noFill/>
-        </p:spPr>
-        <p:txBody>
-          <a:bodyPr wrap="none">
-            <a:spAutoFit/>
-          </a:bodyPr>
-          <a:lstStyle/>
-          <a:p>
-            <a:pPr algn="r">
-              <a:defRPr sz="1000" b="0">
-                <a:solidFill>
-                  <a:srgbClr val="6C757D"/>
-                </a:solidFill>
-                <a:latin typeface="Microsoft YaHei"/>
-              </a:defRPr>
-            </a:pPr>
-            <a:r>
-              <a:t>15/22</a:t>
-            </a:r>
-          </a:p>
-        </p:txBody>
-      </p:sp>
-    </p:spTree>
-  </p:cSld>
-  <p:clrMapOvr>
-    <a:masterClrMapping/>
-  </p:clrMapOvr>
-</p:sld>
-</file>
-
-<file path=ppt/slides/slide16.xml><?xml version="1.0" encoding="utf-8"?>
-<p:sld xmlns:a="http://schemas.openxmlformats.org/drawingml/2006/main" xmlns:p="http://schemas.openxmlformats.org/presentationml/2006/main" xmlns:r="http://schemas.openxmlformats.org/officeDocument/2006/relationships">
-  <p:cSld>
-    <p:spTree>
-      <p:nvGrpSpPr>
-        <p:cNvPr id="1" name=""/>
-        <p:cNvGrpSpPr/>
-        <p:nvPr/>
-      </p:nvGrpSpPr>
-      <p:grpSpPr/>
-      <p:sp>
-        <p:nvSpPr>
-          <p:cNvPr id="2" name="Rectangle 1"/>
-          <p:cNvSpPr/>
-          <p:nvPr/>
-        </p:nvSpPr>
-        <p:spPr>
-          <a:xfrm>
-            <a:off x="0" y="0"/>
-            <a:ext cx="12191695" cy="960120"/>
-          </a:xfrm>
-          <a:prstGeom prst="rect">
-            <a:avLst/>
-          </a:prstGeom>
-          <a:solidFill>
-            <a:srgbClr val="1A237E"/>
-          </a:solidFill>
-          <a:ln/>
-        </p:spPr>
-        <p:style>
-          <a:lnRef idx="1">
-            <a:schemeClr val="accent1"/>
-          </a:lnRef>
-          <a:fillRef idx="3">
-            <a:schemeClr val="accent1"/>
-          </a:fillRef>
-          <a:effectRef idx="2">
-            <a:schemeClr val="accent1"/>
-          </a:effectRef>
-          <a:fontRef idx="minor">
-            <a:schemeClr val="lt1"/>
-          </a:fontRef>
-        </p:style>
-        <p:txBody>
-          <a:bodyPr rtlCol="0" anchor="ctr"/>
-          <a:lstStyle/>
-          <a:p>
-            <a:pPr algn="ctr"/>
-          </a:p>
-        </p:txBody>
-      </p:sp>
-      <p:sp>
-        <p:nvSpPr>
-          <p:cNvPr id="3" name="TextBox 2"/>
-          <p:cNvSpPr txBox="1"/>
-          <p:nvPr/>
-        </p:nvSpPr>
-        <p:spPr>
-          <a:xfrm>
-            <a:off x="457200" y="228600"/>
-            <a:ext cx="11247120" cy="548640"/>
-          </a:xfrm>
-          <a:prstGeom prst="rect">
-            <a:avLst/>
-          </a:prstGeom>
-          <a:noFill/>
-        </p:spPr>
-        <p:txBody>
-          <a:bodyPr wrap="none">
-            <a:spAutoFit/>
-          </a:bodyPr>
-          <a:lstStyle/>
-          <a:p>
-            <a:pPr algn="l">
-              <a:defRPr sz="3000" b="1">
-                <a:solidFill>
-                  <a:srgbClr val="F3F6F9"/>
-                </a:solidFill>
-                <a:latin typeface="Microsoft YaHei"/>
-              </a:defRPr>
-            </a:pPr>
-            <a:r>
-              <a:t>A 组 7 款 joystick 游戏最终平均结果</a:t>
-            </a:r>
-          </a:p>
-        </p:txBody>
-      </p:sp>
-      <p:graphicFrame>
-        <p:nvGraphicFramePr>
-          <p:cNvPr id="4" name="Table 3"/>
-          <p:cNvGraphicFramePr>
-            <a:graphicFrameLocks noGrp="1"/>
-          </p:cNvGraphicFramePr>
-          <p:nvPr/>
-        </p:nvGraphicFramePr>
-        <p:xfrm>
-          <a:off x="457200" y="1143000"/>
-          <a:ext cx="11247120" cy="5120640"/>
-        </p:xfrm>
-        <a:graphic>
-          <a:graphicData uri="http://schemas.openxmlformats.org/drawingml/2006/table">
-            <a:tbl>
-              <a:tblPr firstRow="1" bandRow="1">
-                <a:tableStyleId>{5C22544A-7EE6-4342-B048-85BDC9FD1C3A}</a:tableStyleId>
-              </a:tblPr>
-              <a:tblGrid>
-                <a:gridCol w="2249424"/>
-                <a:gridCol w="2249424"/>
-                <a:gridCol w="2249424"/>
-                <a:gridCol w="2249424"/>
-                <a:gridCol w="2249424"/>
-              </a:tblGrid>
-              <a:tr h="640080">
+              <a:tr h="320040">
                 <a:tc>
                   <a:txBody>
                     <a:bodyPr/>
@@ -6402,31 +4877,7 @@
                         </a:defRPr>
                       </a:pPr>
                       <a:r>
-                        <a:t>multi-bus</a:t>
-                      </a:r>
-                    </a:p>
-                  </a:txBody>
-                  <a:tcPr>
-                    <a:solidFill>
-                      <a:srgbClr val="1A237E"/>
-                    </a:solidFill>
-                  </a:tcPr>
-                </a:tc>
-                <a:tc>
-                  <a:txBody>
-                    <a:bodyPr/>
-                    <a:lstStyle/>
-                    <a:p>
-                      <a:pPr algn="ctr">
-                        <a:defRPr sz="1300" b="1">
-                          <a:solidFill>
-                            <a:srgbClr val="F3F6F9"/>
-                          </a:solidFill>
-                          <a:latin typeface="Microsoft YaHei"/>
-                        </a:defRPr>
-                      </a:pPr>
-                      <a:r>
-                        <a:t>最优模式</a:t>
+                        <a:t>状态</a:t>
                       </a:r>
                     </a:p>
                   </a:txBody>
@@ -6437,7 +4888,7 @@
                   </a:tcPr>
                 </a:tc>
               </a:tr>
-              <a:tr h="640080">
+              <a:tr h="320040">
                 <a:tc>
                   <a:txBody>
                     <a:bodyPr/>
@@ -6449,7 +4900,7 @@
                         </a:defRPr>
                       </a:pPr>
                       <a:r>
-                        <a:t>00440 清障通车</a:t>
+                        <a:t>00219 养牛卖奶</a:t>
                       </a:r>
                     </a:p>
                   </a:txBody>
@@ -6470,7 +4921,7 @@
                         </a:defRPr>
                       </a:pPr>
                       <a:r>
-                        <a:t>0.206</a:t>
+                        <a:t>0.150</a:t>
                       </a:r>
                     </a:p>
                   </a:txBody>
@@ -6491,7 +4942,7 @@
                         </a:defRPr>
                       </a:pPr>
                       <a:r>
-                        <a:t>0.175</a:t>
+                        <a:t>0.150</a:t>
                       </a:r>
                     </a:p>
                   </a:txBody>
@@ -6512,7 +4963,100 @@
                         </a:defRPr>
                       </a:pPr>
                       <a:r>
-                        <a:t>0.172</a:t>
+                        <a:t>待诊断</a:t>
+                      </a:r>
+                    </a:p>
+                  </a:txBody>
+                  <a:tcPr>
+                    <a:solidFill>
+                      <a:srgbClr val="F3F6F9"/>
+                    </a:solidFill>
+                  </a:tcPr>
+                </a:tc>
+              </a:tr>
+              <a:tr h="320040">
+                <a:tc>
+                  <a:txBody>
+                    <a:bodyPr/>
+                    <a:lstStyle/>
+                    <a:p>
+                      <a:pPr algn="ctr">
+                        <a:defRPr sz="1200">
+                          <a:latin typeface="Microsoft YaHei"/>
+                        </a:defRPr>
+                      </a:pPr>
+                      <a:r>
+                        <a:t>00332 圣诞薅羊毛</a:t>
+                      </a:r>
+                    </a:p>
+                  </a:txBody>
+                  <a:tcPr/>
+                </a:tc>
+                <a:tc>
+                  <a:txBody>
+                    <a:bodyPr/>
+                    <a:lstStyle/>
+                    <a:p>
+                      <a:pPr algn="ctr">
+                        <a:defRPr sz="1200">
+                          <a:latin typeface="Microsoft YaHei"/>
+                        </a:defRPr>
+                      </a:pPr>
+                      <a:r>
+                        <a:t>0.150</a:t>
+                      </a:r>
+                    </a:p>
+                  </a:txBody>
+                  <a:tcPr/>
+                </a:tc>
+                <a:tc>
+                  <a:txBody>
+                    <a:bodyPr/>
+                    <a:lstStyle/>
+                    <a:p>
+                      <a:pPr algn="ctr">
+                        <a:defRPr sz="1200">
+                          <a:latin typeface="Microsoft YaHei"/>
+                        </a:defRPr>
+                      </a:pPr>
+                      <a:r>
+                        <a:t>0.150</a:t>
+                      </a:r>
+                    </a:p>
+                  </a:txBody>
+                  <a:tcPr/>
+                </a:tc>
+                <a:tc>
+                  <a:txBody>
+                    <a:bodyPr/>
+                    <a:lstStyle/>
+                    <a:p>
+                      <a:pPr algn="ctr">
+                        <a:defRPr sz="1200">
+                          <a:latin typeface="Microsoft YaHei"/>
+                        </a:defRPr>
+                      </a:pPr>
+                      <a:r>
+                        <a:t>待诊断</a:t>
+                      </a:r>
+                    </a:p>
+                  </a:txBody>
+                  <a:tcPr/>
+                </a:tc>
+              </a:tr>
+              <a:tr h="320040">
+                <a:tc>
+                  <a:txBody>
+                    <a:bodyPr/>
+                    <a:lstStyle/>
+                    <a:p>
+                      <a:pPr algn="ctr">
+                        <a:defRPr sz="1200">
+                          <a:latin typeface="Microsoft YaHei"/>
+                        </a:defRPr>
+                      </a:pPr>
+                      <a:r>
+                        <a:t>00342 建造合并</a:t>
                       </a:r>
                     </a:p>
                   </a:txBody>
@@ -6533,7 +5077,7 @@
                         </a:defRPr>
                       </a:pPr>
                       <a:r>
-                        <a:t>rule</a:t>
+                        <a:t>0.150</a:t>
                       </a:r>
                     </a:p>
                   </a:txBody>
@@ -6542,25 +5086,6 @@
                       <a:srgbClr val="F3F6F9"/>
                     </a:solidFill>
                   </a:tcPr>
-                </a:tc>
-              </a:tr>
-              <a:tr h="640080">
-                <a:tc>
-                  <a:txBody>
-                    <a:bodyPr/>
-                    <a:lstStyle/>
-                    <a:p>
-                      <a:pPr algn="ctr">
-                        <a:defRPr sz="1200">
-                          <a:latin typeface="Microsoft YaHei"/>
-                        </a:defRPr>
-                      </a:pPr>
-                      <a:r>
-                        <a:t>00461 塔防</a:t>
-                      </a:r>
-                    </a:p>
-                  </a:txBody>
-                  <a:tcPr/>
                 </a:tc>
                 <a:tc>
                   <a:txBody>
@@ -6573,7 +5098,51 @@
                         </a:defRPr>
                       </a:pPr>
                       <a:r>
-                        <a:t>0.143</a:t>
+                        <a:t>0.150</a:t>
+                      </a:r>
+                    </a:p>
+                  </a:txBody>
+                  <a:tcPr>
+                    <a:solidFill>
+                      <a:srgbClr val="F3F6F9"/>
+                    </a:solidFill>
+                  </a:tcPr>
+                </a:tc>
+                <a:tc>
+                  <a:txBody>
+                    <a:bodyPr/>
+                    <a:lstStyle/>
+                    <a:p>
+                      <a:pPr algn="ctr">
+                        <a:defRPr sz="1200">
+                          <a:latin typeface="Microsoft YaHei"/>
+                        </a:defRPr>
+                      </a:pPr>
+                      <a:r>
+                        <a:t>待诊断</a:t>
+                      </a:r>
+                    </a:p>
+                  </a:txBody>
+                  <a:tcPr>
+                    <a:solidFill>
+                      <a:srgbClr val="F3F6F9"/>
+                    </a:solidFill>
+                  </a:tcPr>
+                </a:tc>
+              </a:tr>
+              <a:tr h="320040">
+                <a:tc>
+                  <a:txBody>
+                    <a:bodyPr/>
+                    <a:lstStyle/>
+                    <a:p>
+                      <a:pPr algn="ctr">
+                        <a:defRPr sz="1200">
+                          <a:latin typeface="Microsoft YaHei"/>
+                        </a:defRPr>
+                      </a:pPr>
+                      <a:r>
+                        <a:t>00382 低坑杀鲨鱼</a:t>
                       </a:r>
                     </a:p>
                   </a:txBody>
@@ -6624,14 +5193,14 @@
                         </a:defRPr>
                       </a:pPr>
                       <a:r>
-                        <a:t>multi-bus*</a:t>
+                        <a:t>✅ 满分</a:t>
                       </a:r>
                     </a:p>
                   </a:txBody>
                   <a:tcPr/>
                 </a:tc>
               </a:tr>
-              <a:tr h="640080">
+              <a:tr h="320040">
                 <a:tc>
                   <a:txBody>
                     <a:bodyPr/>
@@ -6643,28 +5212,7 @@
                         </a:defRPr>
                       </a:pPr>
                       <a:r>
-                        <a:t>00483 吸沙抽水</a:t>
-                      </a:r>
-                    </a:p>
-                  </a:txBody>
-                  <a:tcPr>
-                    <a:solidFill>
-                      <a:srgbClr val="F3F6F9"/>
-                    </a:solidFill>
-                  </a:tcPr>
-                </a:tc>
-                <a:tc>
-                  <a:txBody>
-                    <a:bodyPr/>
-                    <a:lstStyle/>
-                    <a:p>
-                      <a:pPr algn="ctr">
-                        <a:defRPr sz="1200">
-                          <a:latin typeface="Microsoft YaHei"/>
-                        </a:defRPr>
-                      </a:pPr>
-                      <a:r>
-                        <a:t>0.244</a:t>
+                        <a:t>00394 车 zip</a:t>
                       </a:r>
                     </a:p>
                   </a:txBody>
@@ -6727,7 +5275,7 @@
                         </a:defRPr>
                       </a:pPr>
                       <a:r>
-                        <a:t>multi-bus*</a:t>
+                        <a:t>✅ 满分</a:t>
                       </a:r>
                     </a:p>
                   </a:txBody>
@@ -6738,7 +5286,7 @@
                   </a:tcPr>
                 </a:tc>
               </a:tr>
-              <a:tr h="640080">
+              <a:tr h="320040">
                 <a:tc>
                   <a:txBody>
                     <a:bodyPr/>
@@ -6750,24 +5298,7 @@
                         </a:defRPr>
                       </a:pPr>
                       <a:r>
-                        <a:t>00496 电网抓丧尸</a:t>
-                      </a:r>
-                    </a:p>
-                  </a:txBody>
-                  <a:tcPr/>
-                </a:tc>
-                <a:tc>
-                  <a:txBody>
-                    <a:bodyPr/>
-                    <a:lstStyle/>
-                    <a:p>
-                      <a:pPr algn="ctr">
-                        <a:defRPr sz="1200">
-                          <a:latin typeface="Microsoft YaHei"/>
-                        </a:defRPr>
-                      </a:pPr>
-                      <a:r>
-                        <a:t>0.250</a:t>
+                        <a:t>00427 淘金</a:t>
                       </a:r>
                     </a:p>
                   </a:txBody>
@@ -6818,14 +5349,14 @@
                         </a:defRPr>
                       </a:pPr>
                       <a:r>
-                        <a:t>rule</a:t>
+                        <a:t>待诊断</a:t>
                       </a:r>
                     </a:p>
                   </a:txBody>
                   <a:tcPr/>
                 </a:tc>
               </a:tr>
-              <a:tr h="640080">
+              <a:tr h="320040">
                 <a:tc>
                   <a:txBody>
                     <a:bodyPr/>
@@ -6837,7 +5368,7 @@
                         </a:defRPr>
                       </a:pPr>
                       <a:r>
-                        <a:t>00517 末世旅店</a:t>
+                        <a:t>00434 选项卡捏</a:t>
                       </a:r>
                     </a:p>
                   </a:txBody>
@@ -6900,7 +5431,7 @@
                         </a:defRPr>
                       </a:pPr>
                       <a:r>
-                        <a:t>0.150</a:t>
+                        <a:t>待诊断</a:t>
                       </a:r>
                     </a:p>
                   </a:txBody>
@@ -6910,6 +5441,8 @@
                     </a:solidFill>
                   </a:tcPr>
                 </a:tc>
+              </a:tr>
+              <a:tr h="320040">
                 <a:tc>
                   <a:txBody>
                     <a:bodyPr/>
@@ -6921,47 +5454,7 @@
                         </a:defRPr>
                       </a:pPr>
                       <a:r>
-                        <a:t>—</a:t>
-                      </a:r>
-                    </a:p>
-                  </a:txBody>
-                  <a:tcPr>
-                    <a:solidFill>
-                      <a:srgbClr val="F3F6F9"/>
-                    </a:solidFill>
-                  </a:tcPr>
-                </a:tc>
-              </a:tr>
-              <a:tr h="640080">
-                <a:tc>
-                  <a:txBody>
-                    <a:bodyPr/>
-                    <a:lstStyle/>
-                    <a:p>
-                      <a:pPr algn="ctr">
-                        <a:defRPr sz="1200">
-                          <a:latin typeface="Microsoft YaHei"/>
-                        </a:defRPr>
-                      </a:pPr>
-                      <a:r>
-                        <a:t>00522 地下炸矿</a:t>
-                      </a:r>
-                    </a:p>
-                  </a:txBody>
-                  <a:tcPr/>
-                </a:tc>
-                <a:tc>
-                  <a:txBody>
-                    <a:bodyPr/>
-                    <a:lstStyle/>
-                    <a:p>
-                      <a:pPr algn="ctr">
-                        <a:defRPr sz="1200">
-                          <a:latin typeface="Microsoft YaHei"/>
-                        </a:defRPr>
-                      </a:pPr>
-                      <a:r>
-                        <a:t>0.215</a:t>
+                        <a:t>00475 太空圈地</a:t>
                       </a:r>
                     </a:p>
                   </a:txBody>
@@ -7012,14 +5505,14 @@
                         </a:defRPr>
                       </a:pPr>
                       <a:r>
-                        <a:t>multi-bus*</a:t>
+                        <a:t>✅ 满分</a:t>
                       </a:r>
                     </a:p>
                   </a:txBody>
                   <a:tcPr/>
                 </a:tc>
               </a:tr>
-              <a:tr h="640080">
+              <a:tr h="320040">
                 <a:tc>
                   <a:txBody>
                     <a:bodyPr/>
@@ -7031,49 +5524,7 @@
                         </a:defRPr>
                       </a:pPr>
                       <a:r>
-                        <a:t>00736 养蛙捕鱼</a:t>
-                      </a:r>
-                    </a:p>
-                  </a:txBody>
-                  <a:tcPr>
-                    <a:solidFill>
-                      <a:srgbClr val="F3F6F9"/>
-                    </a:solidFill>
-                  </a:tcPr>
-                </a:tc>
-                <a:tc>
-                  <a:txBody>
-                    <a:bodyPr/>
-                    <a:lstStyle/>
-                    <a:p>
-                      <a:pPr algn="ctr">
-                        <a:defRPr sz="1200">
-                          <a:latin typeface="Microsoft YaHei"/>
-                        </a:defRPr>
-                      </a:pPr>
-                      <a:r>
-                        <a:t>0.256</a:t>
-                      </a:r>
-                    </a:p>
-                  </a:txBody>
-                  <a:tcPr>
-                    <a:solidFill>
-                      <a:srgbClr val="F3F6F9"/>
-                    </a:solidFill>
-                  </a:tcPr>
-                </a:tc>
-                <a:tc>
-                  <a:txBody>
-                    <a:bodyPr/>
-                    <a:lstStyle/>
-                    <a:p>
-                      <a:pPr algn="ctr">
-                        <a:defRPr sz="1200">
-                          <a:latin typeface="Microsoft YaHei"/>
-                        </a:defRPr>
-                      </a:pPr>
-                      <a:r>
-                        <a:t>0.153</a:t>
+                        <a:t>00482 砍树扩地</a:t>
                       </a:r>
                     </a:p>
                   </a:txBody>
@@ -7115,7 +5566,496 @@
                         </a:defRPr>
                       </a:pPr>
                       <a:r>
-                        <a:t>rule</a:t>
+                        <a:t>0.150</a:t>
+                      </a:r>
+                    </a:p>
+                  </a:txBody>
+                  <a:tcPr>
+                    <a:solidFill>
+                      <a:srgbClr val="F3F6F9"/>
+                    </a:solidFill>
+                  </a:tcPr>
+                </a:tc>
+                <a:tc>
+                  <a:txBody>
+                    <a:bodyPr/>
+                    <a:lstStyle/>
+                    <a:p>
+                      <a:pPr algn="ctr">
+                        <a:defRPr sz="1200">
+                          <a:latin typeface="Microsoft YaHei"/>
+                        </a:defRPr>
+                      </a:pPr>
+                      <a:r>
+                        <a:t>待诊断</a:t>
+                      </a:r>
+                    </a:p>
+                  </a:txBody>
+                  <a:tcPr>
+                    <a:solidFill>
+                      <a:srgbClr val="F3F6F9"/>
+                    </a:solidFill>
+                  </a:tcPr>
+                </a:tc>
+              </a:tr>
+              <a:tr h="320040">
+                <a:tc>
+                  <a:txBody>
+                    <a:bodyPr/>
+                    <a:lstStyle/>
+                    <a:p>
+                      <a:pPr algn="ctr">
+                        <a:defRPr sz="1200">
+                          <a:latin typeface="Microsoft YaHei"/>
+                        </a:defRPr>
+                      </a:pPr>
+                      <a:r>
+                        <a:t>00526 通水洗地</a:t>
+                      </a:r>
+                    </a:p>
+                  </a:txBody>
+                  <a:tcPr/>
+                </a:tc>
+                <a:tc>
+                  <a:txBody>
+                    <a:bodyPr/>
+                    <a:lstStyle/>
+                    <a:p>
+                      <a:pPr algn="ctr">
+                        <a:defRPr sz="1200">
+                          <a:latin typeface="Microsoft YaHei"/>
+                        </a:defRPr>
+                      </a:pPr>
+                      <a:r>
+                        <a:t>0.300</a:t>
+                      </a:r>
+                    </a:p>
+                  </a:txBody>
+                  <a:tcPr/>
+                </a:tc>
+                <a:tc>
+                  <a:txBody>
+                    <a:bodyPr/>
+                    <a:lstStyle/>
+                    <a:p>
+                      <a:pPr algn="ctr">
+                        <a:defRPr sz="1200">
+                          <a:latin typeface="Microsoft YaHei"/>
+                        </a:defRPr>
+                      </a:pPr>
+                      <a:r>
+                        <a:t>0.300</a:t>
+                      </a:r>
+                    </a:p>
+                  </a:txBody>
+                  <a:tcPr/>
+                </a:tc>
+                <a:tc>
+                  <a:txBody>
+                    <a:bodyPr/>
+                    <a:lstStyle/>
+                    <a:p>
+                      <a:pPr algn="ctr">
+                        <a:defRPr sz="1200">
+                          <a:latin typeface="Microsoft YaHei"/>
+                        </a:defRPr>
+                      </a:pPr>
+                      <a:r>
+                        <a:t>✅ 满分</a:t>
+                      </a:r>
+                    </a:p>
+                  </a:txBody>
+                  <a:tcPr/>
+                </a:tc>
+              </a:tr>
+              <a:tr h="320040">
+                <a:tc>
+                  <a:txBody>
+                    <a:bodyPr/>
+                    <a:lstStyle/>
+                    <a:p>
+                      <a:pPr algn="ctr">
+                        <a:defRPr sz="1200">
+                          <a:latin typeface="Microsoft YaHei"/>
+                        </a:defRPr>
+                      </a:pPr>
+                      <a:r>
+                        <a:t>00532 瀑布巨木</a:t>
+                      </a:r>
+                    </a:p>
+                  </a:txBody>
+                  <a:tcPr>
+                    <a:solidFill>
+                      <a:srgbClr val="F3F6F9"/>
+                    </a:solidFill>
+                  </a:tcPr>
+                </a:tc>
+                <a:tc>
+                  <a:txBody>
+                    <a:bodyPr/>
+                    <a:lstStyle/>
+                    <a:p>
+                      <a:pPr algn="ctr">
+                        <a:defRPr sz="1200">
+                          <a:latin typeface="Microsoft YaHei"/>
+                        </a:defRPr>
+                      </a:pPr>
+                      <a:r>
+                        <a:t>0.300</a:t>
+                      </a:r>
+                    </a:p>
+                  </a:txBody>
+                  <a:tcPr>
+                    <a:solidFill>
+                      <a:srgbClr val="F3F6F9"/>
+                    </a:solidFill>
+                  </a:tcPr>
+                </a:tc>
+                <a:tc>
+                  <a:txBody>
+                    <a:bodyPr/>
+                    <a:lstStyle/>
+                    <a:p>
+                      <a:pPr algn="ctr">
+                        <a:defRPr sz="1200">
+                          <a:latin typeface="Microsoft YaHei"/>
+                        </a:defRPr>
+                      </a:pPr>
+                      <a:r>
+                        <a:t>0.300</a:t>
+                      </a:r>
+                    </a:p>
+                  </a:txBody>
+                  <a:tcPr>
+                    <a:solidFill>
+                      <a:srgbClr val="F3F6F9"/>
+                    </a:solidFill>
+                  </a:tcPr>
+                </a:tc>
+                <a:tc>
+                  <a:txBody>
+                    <a:bodyPr/>
+                    <a:lstStyle/>
+                    <a:p>
+                      <a:pPr algn="ctr">
+                        <a:defRPr sz="1200">
+                          <a:latin typeface="Microsoft YaHei"/>
+                        </a:defRPr>
+                      </a:pPr>
+                      <a:r>
+                        <a:t>✅ 满分</a:t>
+                      </a:r>
+                    </a:p>
+                  </a:txBody>
+                  <a:tcPr>
+                    <a:solidFill>
+                      <a:srgbClr val="F3F6F9"/>
+                    </a:solidFill>
+                  </a:tcPr>
+                </a:tc>
+              </a:tr>
+              <a:tr h="320040">
+                <a:tc>
+                  <a:txBody>
+                    <a:bodyPr/>
+                    <a:lstStyle/>
+                    <a:p>
+                      <a:pPr algn="ctr">
+                        <a:defRPr sz="1200">
+                          <a:latin typeface="Microsoft YaHei"/>
+                        </a:defRPr>
+                      </a:pPr>
+                      <a:r>
+                        <a:t>00594 破石收水</a:t>
+                      </a:r>
+                    </a:p>
+                  </a:txBody>
+                  <a:tcPr/>
+                </a:tc>
+                <a:tc>
+                  <a:txBody>
+                    <a:bodyPr/>
+                    <a:lstStyle/>
+                    <a:p>
+                      <a:pPr algn="ctr">
+                        <a:defRPr sz="1200">
+                          <a:latin typeface="Microsoft YaHei"/>
+                        </a:defRPr>
+                      </a:pPr>
+                      <a:r>
+                        <a:t>0.300</a:t>
+                      </a:r>
+                    </a:p>
+                  </a:txBody>
+                  <a:tcPr/>
+                </a:tc>
+                <a:tc>
+                  <a:txBody>
+                    <a:bodyPr/>
+                    <a:lstStyle/>
+                    <a:p>
+                      <a:pPr algn="ctr">
+                        <a:defRPr sz="1200">
+                          <a:latin typeface="Microsoft YaHei"/>
+                        </a:defRPr>
+                      </a:pPr>
+                      <a:r>
+                        <a:t>0.300</a:t>
+                      </a:r>
+                    </a:p>
+                  </a:txBody>
+                  <a:tcPr/>
+                </a:tc>
+                <a:tc>
+                  <a:txBody>
+                    <a:bodyPr/>
+                    <a:lstStyle/>
+                    <a:p>
+                      <a:pPr algn="ctr">
+                        <a:defRPr sz="1200">
+                          <a:latin typeface="Microsoft YaHei"/>
+                        </a:defRPr>
+                      </a:pPr>
+                      <a:r>
+                        <a:t>✅ 满分</a:t>
+                      </a:r>
+                    </a:p>
+                  </a:txBody>
+                  <a:tcPr/>
+                </a:tc>
+              </a:tr>
+              <a:tr h="320040">
+                <a:tc>
+                  <a:txBody>
+                    <a:bodyPr/>
+                    <a:lstStyle/>
+                    <a:p>
+                      <a:pPr algn="ctr">
+                        <a:defRPr sz="1200">
+                          <a:latin typeface="Microsoft YaHei"/>
+                        </a:defRPr>
+                      </a:pPr>
+                      <a:r>
+                        <a:t>00669 斜挖订单</a:t>
+                      </a:r>
+                    </a:p>
+                  </a:txBody>
+                  <a:tcPr>
+                    <a:solidFill>
+                      <a:srgbClr val="F3F6F9"/>
+                    </a:solidFill>
+                  </a:tcPr>
+                </a:tc>
+                <a:tc>
+                  <a:txBody>
+                    <a:bodyPr/>
+                    <a:lstStyle/>
+                    <a:p>
+                      <a:pPr algn="ctr">
+                        <a:defRPr sz="1200">
+                          <a:latin typeface="Microsoft YaHei"/>
+                        </a:defRPr>
+                      </a:pPr>
+                      <a:r>
+                        <a:t>0.300</a:t>
+                      </a:r>
+                    </a:p>
+                  </a:txBody>
+                  <a:tcPr>
+                    <a:solidFill>
+                      <a:srgbClr val="F3F6F9"/>
+                    </a:solidFill>
+                  </a:tcPr>
+                </a:tc>
+                <a:tc>
+                  <a:txBody>
+                    <a:bodyPr/>
+                    <a:lstStyle/>
+                    <a:p>
+                      <a:pPr algn="ctr">
+                        <a:defRPr sz="1200">
+                          <a:latin typeface="Microsoft YaHei"/>
+                        </a:defRPr>
+                      </a:pPr>
+                      <a:r>
+                        <a:t>0.300</a:t>
+                      </a:r>
+                    </a:p>
+                  </a:txBody>
+                  <a:tcPr>
+                    <a:solidFill>
+                      <a:srgbClr val="F3F6F9"/>
+                    </a:solidFill>
+                  </a:tcPr>
+                </a:tc>
+                <a:tc>
+                  <a:txBody>
+                    <a:bodyPr/>
+                    <a:lstStyle/>
+                    <a:p>
+                      <a:pPr algn="ctr">
+                        <a:defRPr sz="1200">
+                          <a:latin typeface="Microsoft YaHei"/>
+                        </a:defRPr>
+                      </a:pPr>
+                      <a:r>
+                        <a:t>✅ 满分</a:t>
+                      </a:r>
+                    </a:p>
+                  </a:txBody>
+                  <a:tcPr>
+                    <a:solidFill>
+                      <a:srgbClr val="F3F6F9"/>
+                    </a:solidFill>
+                  </a:tcPr>
+                </a:tc>
+              </a:tr>
+              <a:tr h="320040">
+                <a:tc>
+                  <a:txBody>
+                    <a:bodyPr/>
+                    <a:lstStyle/>
+                    <a:p>
+                      <a:pPr algn="ctr">
+                        <a:defRPr sz="1200">
+                          <a:latin typeface="Microsoft YaHei"/>
+                        </a:defRPr>
+                      </a:pPr>
+                      <a:r>
+                        <a:t>00733 海洋回收</a:t>
+                      </a:r>
+                    </a:p>
+                  </a:txBody>
+                  <a:tcPr/>
+                </a:tc>
+                <a:tc>
+                  <a:txBody>
+                    <a:bodyPr/>
+                    <a:lstStyle/>
+                    <a:p>
+                      <a:pPr algn="ctr">
+                        <a:defRPr sz="1200">
+                          <a:latin typeface="Microsoft YaHei"/>
+                        </a:defRPr>
+                      </a:pPr>
+                      <a:r>
+                        <a:t>0.150</a:t>
+                      </a:r>
+                    </a:p>
+                  </a:txBody>
+                  <a:tcPr/>
+                </a:tc>
+                <a:tc>
+                  <a:txBody>
+                    <a:bodyPr/>
+                    <a:lstStyle/>
+                    <a:p>
+                      <a:pPr algn="ctr">
+                        <a:defRPr sz="1200">
+                          <a:latin typeface="Microsoft YaHei"/>
+                        </a:defRPr>
+                      </a:pPr>
+                      <a:r>
+                        <a:t>0.150</a:t>
+                      </a:r>
+                    </a:p>
+                  </a:txBody>
+                  <a:tcPr/>
+                </a:tc>
+                <a:tc>
+                  <a:txBody>
+                    <a:bodyPr/>
+                    <a:lstStyle/>
+                    <a:p>
+                      <a:pPr algn="ctr">
+                        <a:defRPr sz="1200">
+                          <a:latin typeface="Microsoft YaHei"/>
+                        </a:defRPr>
+                      </a:pPr>
+                      <a:r>
+                        <a:t>待诊断</a:t>
+                      </a:r>
+                    </a:p>
+                  </a:txBody>
+                  <a:tcPr/>
+                </a:tc>
+              </a:tr>
+              <a:tr h="320040">
+                <a:tc>
+                  <a:txBody>
+                    <a:bodyPr/>
+                    <a:lstStyle/>
+                    <a:p>
+                      <a:pPr algn="ctr">
+                        <a:defRPr sz="1200">
+                          <a:latin typeface="Microsoft YaHei"/>
+                        </a:defRPr>
+                      </a:pPr>
+                      <a:r>
+                        <a:t>00742 加油小镇</a:t>
+                      </a:r>
+                    </a:p>
+                  </a:txBody>
+                  <a:tcPr>
+                    <a:solidFill>
+                      <a:srgbClr val="F3F6F9"/>
+                    </a:solidFill>
+                  </a:tcPr>
+                </a:tc>
+                <a:tc>
+                  <a:txBody>
+                    <a:bodyPr/>
+                    <a:lstStyle/>
+                    <a:p>
+                      <a:pPr algn="ctr">
+                        <a:defRPr sz="1200">
+                          <a:latin typeface="Microsoft YaHei"/>
+                        </a:defRPr>
+                      </a:pPr>
+                      <a:r>
+                        <a:t>0.300</a:t>
+                      </a:r>
+                    </a:p>
+                  </a:txBody>
+                  <a:tcPr>
+                    <a:solidFill>
+                      <a:srgbClr val="F3F6F9"/>
+                    </a:solidFill>
+                  </a:tcPr>
+                </a:tc>
+                <a:tc>
+                  <a:txBody>
+                    <a:bodyPr/>
+                    <a:lstStyle/>
+                    <a:p>
+                      <a:pPr algn="ctr">
+                        <a:defRPr sz="1200">
+                          <a:latin typeface="Microsoft YaHei"/>
+                        </a:defRPr>
+                      </a:pPr>
+                      <a:r>
+                        <a:t>0.300</a:t>
+                      </a:r>
+                    </a:p>
+                  </a:txBody>
+                  <a:tcPr>
+                    <a:solidFill>
+                      <a:srgbClr val="F3F6F9"/>
+                    </a:solidFill>
+                  </a:tcPr>
+                </a:tc>
+                <a:tc>
+                  <a:txBody>
+                    <a:bodyPr/>
+                    <a:lstStyle/>
+                    <a:p>
+                      <a:pPr algn="ctr">
+                        <a:defRPr sz="1200">
+                          <a:latin typeface="Microsoft YaHei"/>
+                        </a:defRPr>
+                      </a:pPr>
+                      <a:r>
+                        <a:t>✅ 满分</a:t>
                       </a:r>
                     </a:p>
                   </a:txBody>
@@ -7238,7 +6178,318 @@
               </a:defRPr>
             </a:pPr>
             <a:r>
-              <a:t>16/22</a:t>
+              <a:t>15/21</a:t>
+            </a:r>
+          </a:p>
+        </p:txBody>
+      </p:sp>
+    </p:spTree>
+  </p:cSld>
+  <p:clrMapOvr>
+    <a:masterClrMapping/>
+  </p:clrMapOvr>
+</p:sld>
+</file>
+
+<file path=ppt/slides/slide16.xml><?xml version="1.0" encoding="utf-8"?>
+<p:sld xmlns:a="http://schemas.openxmlformats.org/drawingml/2006/main" xmlns:p="http://schemas.openxmlformats.org/presentationml/2006/main" xmlns:r="http://schemas.openxmlformats.org/officeDocument/2006/relationships">
+  <p:cSld>
+    <p:spTree>
+      <p:nvGrpSpPr>
+        <p:cNvPr id="1" name=""/>
+        <p:cNvGrpSpPr/>
+        <p:nvPr/>
+      </p:nvGrpSpPr>
+      <p:grpSpPr/>
+      <p:sp>
+        <p:nvSpPr>
+          <p:cNvPr id="2" name="Rectangle 1"/>
+          <p:cNvSpPr/>
+          <p:nvPr/>
+        </p:nvSpPr>
+        <p:spPr>
+          <a:xfrm>
+            <a:off x="0" y="0"/>
+            <a:ext cx="12191695" cy="960120"/>
+          </a:xfrm>
+          <a:prstGeom prst="rect">
+            <a:avLst/>
+          </a:prstGeom>
+          <a:solidFill>
+            <a:srgbClr val="1A237E"/>
+          </a:solidFill>
+          <a:ln/>
+        </p:spPr>
+        <p:style>
+          <a:lnRef idx="1">
+            <a:schemeClr val="accent1"/>
+          </a:lnRef>
+          <a:fillRef idx="3">
+            <a:schemeClr val="accent1"/>
+          </a:fillRef>
+          <a:effectRef idx="2">
+            <a:schemeClr val="accent1"/>
+          </a:effectRef>
+          <a:fontRef idx="minor">
+            <a:schemeClr val="lt1"/>
+          </a:fontRef>
+        </p:style>
+        <p:txBody>
+          <a:bodyPr rtlCol="0" anchor="ctr"/>
+          <a:lstStyle/>
+          <a:p>
+            <a:pPr algn="ctr"/>
+          </a:p>
+        </p:txBody>
+      </p:sp>
+      <p:sp>
+        <p:nvSpPr>
+          <p:cNvPr id="3" name="TextBox 2"/>
+          <p:cNvSpPr txBox="1"/>
+          <p:nvPr/>
+        </p:nvSpPr>
+        <p:spPr>
+          <a:xfrm>
+            <a:off x="457200" y="228600"/>
+            <a:ext cx="11247120" cy="548640"/>
+          </a:xfrm>
+          <a:prstGeom prst="rect">
+            <a:avLst/>
+          </a:prstGeom>
+          <a:noFill/>
+        </p:spPr>
+        <p:txBody>
+          <a:bodyPr wrap="none">
+            <a:spAutoFit/>
+          </a:bodyPr>
+          <a:lstStyle/>
+          <a:p>
+            <a:pPr algn="l">
+              <a:defRPr sz="3000" b="1">
+                <a:solidFill>
+                  <a:srgbClr val="F3F6F9"/>
+                </a:solidFill>
+                <a:latin typeface="Microsoft YaHei"/>
+              </a:defRPr>
+            </a:pPr>
+            <a:r>
+              <a:t>关键发现</a:t>
+            </a:r>
+          </a:p>
+        </p:txBody>
+      </p:sp>
+      <p:sp>
+        <p:nvSpPr>
+          <p:cNvPr id="4" name="TextBox 3"/>
+          <p:cNvSpPr txBox="1"/>
+          <p:nvPr/>
+        </p:nvSpPr>
+        <p:spPr>
+          <a:xfrm>
+            <a:off x="548640" y="1234440"/>
+            <a:ext cx="11064240" cy="5029200"/>
+          </a:xfrm>
+          <a:prstGeom prst="rect">
+            <a:avLst/>
+          </a:prstGeom>
+          <a:noFill/>
+        </p:spPr>
+        <p:txBody>
+          <a:bodyPr wrap="square">
+            <a:spAutoFit/>
+          </a:bodyPr>
+          <a:lstStyle/>
+          <a:p>
+            <a:pPr algn="l">
+              <a:spcAft>
+                <a:spcPts val="1000"/>
+              </a:spcAft>
+              <a:defRPr sz="1800" b="0">
+                <a:solidFill>
+                  <a:srgbClr val="1E2933"/>
+                </a:solidFill>
+                <a:latin typeface="Microsoft YaHei"/>
+              </a:defRPr>
+            </a:pPr>
+            <a:r>
+              <a:t>A 类 joystick：00461 / 00483 / 00522 在 multi-bus* 下稳定 0.300，记忆读回是决定性收益</a:t>
+            </a:r>
+          </a:p>
+          <a:p>
+            <a:pPr algn="l">
+              <a:spcAft>
+                <a:spcPts val="1000"/>
+              </a:spcAft>
+              <a:defRPr sz="1800" b="0">
+                <a:solidFill>
+                  <a:srgbClr val="1E2933"/>
+                </a:solidFill>
+                <a:latin typeface="Microsoft YaHei"/>
+              </a:defRPr>
+            </a:pPr>
+            <a:r>
+              <a:t>A 类短板：00496 / 00517 / 00736 的 multi-bus activity=0，driver 需要按游戏类型再调优</a:t>
+            </a:r>
+          </a:p>
+          <a:p>
+            <a:pPr algn="l">
+              <a:spcAft>
+                <a:spcPts val="1000"/>
+              </a:spcAft>
+              <a:defRPr sz="1800" b="0">
+                <a:solidFill>
+                  <a:srgbClr val="1E2933"/>
+                </a:solidFill>
+                <a:latin typeface="Microsoft YaHei"/>
+              </a:defRPr>
+            </a:pPr>
+            <a:r>
+              <a:t>B 类 tap-only：8/15 游戏 rule 即可 0.300，说明点击目标屏幕坐标的策略本身可行</a:t>
+            </a:r>
+          </a:p>
+          <a:p>
+            <a:pPr algn="l">
+              <a:spcAft>
+                <a:spcPts val="1000"/>
+              </a:spcAft>
+              <a:defRPr sz="1800" b="0">
+                <a:solidFill>
+                  <a:srgbClr val="1E2933"/>
+                </a:solidFill>
+                <a:latin typeface="Microsoft YaHei"/>
+              </a:defRPr>
+            </a:pPr>
+            <a:r>
+              <a:t>B 类待诊断：7/15 游戏 0.150（activity=0），可能是目标被遮挡、需要拖拽，或坐标映射偏差</a:t>
+            </a:r>
+          </a:p>
+          <a:p>
+            <a:pPr algn="l">
+              <a:spcAft>
+                <a:spcPts val="1000"/>
+              </a:spcAft>
+              <a:defRPr sz="1800" b="0">
+                <a:solidFill>
+                  <a:srgbClr val="1E2933"/>
+                </a:solidFill>
+                <a:latin typeface="Microsoft YaHei"/>
+              </a:defRPr>
+            </a:pPr>
+            <a:r>
+              <a:t>22 游戏全部可驱动、可采集轨迹，为后续 QLoRA 提供了 27,693 条合并样本</a:t>
+            </a:r>
+          </a:p>
+        </p:txBody>
+      </p:sp>
+      <p:sp>
+        <p:nvSpPr>
+          <p:cNvPr id="5" name="Rectangle 4"/>
+          <p:cNvSpPr/>
+          <p:nvPr/>
+        </p:nvSpPr>
+        <p:spPr>
+          <a:xfrm>
+            <a:off x="0" y="6537960"/>
+            <a:ext cx="12191695" cy="18288"/>
+          </a:xfrm>
+          <a:prstGeom prst="rect">
+            <a:avLst/>
+          </a:prstGeom>
+          <a:solidFill>
+            <a:srgbClr val="0096C7"/>
+          </a:solidFill>
+          <a:ln/>
+        </p:spPr>
+        <p:style>
+          <a:lnRef idx="1">
+            <a:schemeClr val="accent1"/>
+          </a:lnRef>
+          <a:fillRef idx="3">
+            <a:schemeClr val="accent1"/>
+          </a:fillRef>
+          <a:effectRef idx="2">
+            <a:schemeClr val="accent1"/>
+          </a:effectRef>
+          <a:fontRef idx="minor">
+            <a:schemeClr val="lt1"/>
+          </a:fontRef>
+        </p:style>
+        <p:txBody>
+          <a:bodyPr rtlCol="0" anchor="ctr"/>
+          <a:lstStyle/>
+          <a:p>
+            <a:pPr algn="ctr"/>
+          </a:p>
+        </p:txBody>
+      </p:sp>
+      <p:sp>
+        <p:nvSpPr>
+          <p:cNvPr id="6" name="TextBox 5"/>
+          <p:cNvSpPr txBox="1"/>
+          <p:nvPr/>
+        </p:nvSpPr>
+        <p:spPr>
+          <a:xfrm>
+            <a:off x="457200" y="6583680"/>
+            <a:ext cx="3657600" cy="228600"/>
+          </a:xfrm>
+          <a:prstGeom prst="rect">
+            <a:avLst/>
+          </a:prstGeom>
+          <a:noFill/>
+        </p:spPr>
+        <p:txBody>
+          <a:bodyPr wrap="none">
+            <a:spAutoFit/>
+          </a:bodyPr>
+          <a:lstStyle/>
+          <a:p>
+            <a:pPr algn="l">
+              <a:defRPr sz="1000" b="0">
+                <a:solidFill>
+                  <a:srgbClr val="6C757D"/>
+                </a:solidFill>
+                <a:latin typeface="Microsoft YaHei"/>
+              </a:defRPr>
+            </a:pPr>
+            <a:r>
+              <a:t>smallgameagent · LLM/VLM + 规则驱动</a:t>
+            </a:r>
+          </a:p>
+        </p:txBody>
+      </p:sp>
+      <p:sp>
+        <p:nvSpPr>
+          <p:cNvPr id="7" name="TextBox 6"/>
+          <p:cNvSpPr txBox="1"/>
+          <p:nvPr/>
+        </p:nvSpPr>
+        <p:spPr>
+          <a:xfrm>
+            <a:off x="10789920" y="6583680"/>
+            <a:ext cx="914400" cy="228600"/>
+          </a:xfrm>
+          <a:prstGeom prst="rect">
+            <a:avLst/>
+          </a:prstGeom>
+          <a:noFill/>
+        </p:spPr>
+        <p:txBody>
+          <a:bodyPr wrap="none">
+            <a:spAutoFit/>
+          </a:bodyPr>
+          <a:lstStyle/>
+          <a:p>
+            <a:pPr algn="r">
+              <a:defRPr sz="1000" b="0">
+                <a:solidFill>
+                  <a:srgbClr val="6C757D"/>
+                </a:solidFill>
+                <a:latin typeface="Microsoft YaHei"/>
+              </a:defRPr>
+            </a:pPr>
+            <a:r>
+              <a:t>16/21</a:t>
             </a:r>
           </a:p>
         </p:txBody>
@@ -7270,7 +6521,7 @@
         <p:spPr>
           <a:xfrm>
             <a:off x="0" y="0"/>
-            <a:ext cx="12191695" cy="960120"/>
+            <a:ext cx="12191695" cy="6858000"/>
           </a:xfrm>
           <a:prstGeom prst="rect">
             <a:avLst/>
@@ -7310,8 +6561,8 @@
         </p:nvSpPr>
         <p:spPr>
           <a:xfrm>
-            <a:off x="457200" y="228600"/>
-            <a:ext cx="11247120" cy="548640"/>
+            <a:off x="548640" y="2468880"/>
+            <a:ext cx="11064240" cy="1097280"/>
           </a:xfrm>
           <a:prstGeom prst="rect">
             <a:avLst/>
@@ -7325,7 +6576,7 @@
           <a:lstStyle/>
           <a:p>
             <a:pPr algn="l">
-              <a:defRPr sz="3000" b="1">
+              <a:defRPr sz="4400" b="1">
                 <a:solidFill>
                   <a:srgbClr val="F3F6F9"/>
                 </a:solidFill>
@@ -7333,130 +6584,27 @@
               </a:defRPr>
             </a:pPr>
             <a:r>
-              <a:t>关键发现</a:t>
-            </a:r>
-          </a:p>
-        </p:txBody>
-      </p:sp>
-      <p:sp>
-        <p:nvSpPr>
-          <p:cNvPr id="4" name="TextBox 3"/>
-          <p:cNvSpPr txBox="1"/>
-          <p:nvPr/>
-        </p:nvSpPr>
-        <p:spPr>
-          <a:xfrm>
-            <a:off x="548640" y="1234440"/>
-            <a:ext cx="11064240" cy="5029200"/>
-          </a:xfrm>
-          <a:prstGeom prst="rect">
-            <a:avLst/>
-          </a:prstGeom>
-          <a:noFill/>
-        </p:spPr>
-        <p:txBody>
-          <a:bodyPr wrap="square">
-            <a:spAutoFit/>
-          </a:bodyPr>
-          <a:lstStyle/>
-          <a:p>
-            <a:pPr algn="l">
-              <a:spcAft>
-                <a:spcPts val="1000"/>
-              </a:spcAft>
-              <a:defRPr sz="1800" b="0">
-                <a:solidFill>
-                  <a:srgbClr val="1E2933"/>
-                </a:solidFill>
-                <a:latin typeface="Microsoft YaHei"/>
-              </a:defRPr>
-            </a:pPr>
-            <a:r>
-              <a:t>B 类 tap-only 游戏 rule 模式即可达到 composite 0.300，tap 坐标映射已稳定</a:t>
-            </a:r>
-          </a:p>
-          <a:p>
-            <a:pPr algn="l">
-              <a:spcAft>
-                <a:spcPts val="1000"/>
-              </a:spcAft>
-              <a:defRPr sz="1800" b="0">
-                <a:solidFill>
-                  <a:srgbClr val="1E2933"/>
-                </a:solidFill>
-                <a:latin typeface="Microsoft YaHei"/>
-              </a:defRPr>
-            </a:pPr>
-            <a:r>
-              <a:t>multi-bus 在 00461 / 00483 / 00522 上稳定满分，说明 bus + memory 对这类游戏有决定性收益</a:t>
-            </a:r>
-          </a:p>
-          <a:p>
-            <a:pPr algn="l">
-              <a:spcAft>
-                <a:spcPts val="1000"/>
-              </a:spcAft>
-              <a:defRPr sz="1800" b="0">
-                <a:solidFill>
-                  <a:srgbClr val="1E2933"/>
-                </a:solidFill>
-                <a:latin typeface="Microsoft YaHei"/>
-              </a:defRPr>
-            </a:pPr>
-            <a:r>
-              <a:t>00496 / 00517 / 00736 的 multi-bus activity=0，driver 在这些游戏上选错了动作，需要按游戏调优</a:t>
-            </a:r>
-          </a:p>
-          <a:p>
-            <a:pPr algn="l">
-              <a:spcAft>
-                <a:spcPts val="1000"/>
-              </a:spcAft>
-              <a:defRPr sz="1800" b="0">
-                <a:solidFill>
-                  <a:srgbClr val="1E2933"/>
-                </a:solidFill>
-                <a:latin typeface="Microsoft YaHei"/>
-              </a:defRPr>
-            </a:pPr>
-            <a:r>
-              <a:t>A 组整体平均：rule 0.209、multi-bus 0.217、multi-bus-memory 0.218，差异被少数游戏拉满</a:t>
-            </a:r>
-          </a:p>
-          <a:p>
-            <a:pPr algn="l">
-              <a:spcAft>
-                <a:spcPts val="1000"/>
-              </a:spcAft>
-              <a:defRPr sz="1800" b="0">
-                <a:solidFill>
-                  <a:srgbClr val="1E2933"/>
-                </a:solidFill>
-                <a:latin typeface="Microsoft YaHei"/>
-              </a:defRPr>
-            </a:pPr>
-            <a:r>
-              <a:t>浏览器修复是前置条件：WSL2 headless 需 bundled Chromium + swiftshader 参数</a:t>
-            </a:r>
-          </a:p>
-        </p:txBody>
-      </p:sp>
-      <p:sp>
-        <p:nvSpPr>
-          <p:cNvPr id="5" name="Rectangle 4"/>
+              <a:t>07 训练数据管线</a:t>
+            </a:r>
+          </a:p>
+        </p:txBody>
+      </p:sp>
+      <p:sp>
+        <p:nvSpPr>
+          <p:cNvPr id="4" name="Rectangle 3"/>
           <p:cNvSpPr/>
           <p:nvPr/>
         </p:nvSpPr>
         <p:spPr>
           <a:xfrm>
-            <a:off x="0" y="6537960"/>
-            <a:ext cx="12191695" cy="18288"/>
+            <a:off x="548640" y="3657600"/>
+            <a:ext cx="1828800" cy="73152"/>
           </a:xfrm>
           <a:prstGeom prst="rect">
             <a:avLst/>
           </a:prstGeom>
           <a:solidFill>
-            <a:srgbClr val="0096C7"/>
+            <a:srgbClr val="FF6B35"/>
           </a:solidFill>
           <a:ln/>
         </p:spPr>
@@ -7484,6 +6632,47 @@
       </p:sp>
       <p:sp>
         <p:nvSpPr>
+          <p:cNvPr id="5" name="Rectangle 4"/>
+          <p:cNvSpPr/>
+          <p:nvPr/>
+        </p:nvSpPr>
+        <p:spPr>
+          <a:xfrm>
+            <a:off x="0" y="6537960"/>
+            <a:ext cx="12191695" cy="18288"/>
+          </a:xfrm>
+          <a:prstGeom prst="rect">
+            <a:avLst/>
+          </a:prstGeom>
+          <a:solidFill>
+            <a:srgbClr val="0096C7"/>
+          </a:solidFill>
+          <a:ln/>
+        </p:spPr>
+        <p:style>
+          <a:lnRef idx="1">
+            <a:schemeClr val="accent1"/>
+          </a:lnRef>
+          <a:fillRef idx="3">
+            <a:schemeClr val="accent1"/>
+          </a:fillRef>
+          <a:effectRef idx="2">
+            <a:schemeClr val="accent1"/>
+          </a:effectRef>
+          <a:fontRef idx="minor">
+            <a:schemeClr val="lt1"/>
+          </a:fontRef>
+        </p:style>
+        <p:txBody>
+          <a:bodyPr rtlCol="0" anchor="ctr"/>
+          <a:lstStyle/>
+          <a:p>
+            <a:pPr algn="ctr"/>
+          </a:p>
+        </p:txBody>
+      </p:sp>
+      <p:sp>
+        <p:nvSpPr>
           <p:cNvPr id="6" name="TextBox 5"/>
           <p:cNvSpPr txBox="1"/>
           <p:nvPr/>
@@ -7549,7 +6738,7 @@
               </a:defRPr>
             </a:pPr>
             <a:r>
-              <a:t>17/22</a:t>
+              <a:t>17/21</a:t>
             </a:r>
           </a:p>
         </p:txBody>
@@ -7581,7 +6770,7 @@
         <p:spPr>
           <a:xfrm>
             <a:off x="0" y="0"/>
-            <a:ext cx="12191695" cy="6858000"/>
+            <a:ext cx="12191695" cy="960120"/>
           </a:xfrm>
           <a:prstGeom prst="rect">
             <a:avLst/>
@@ -7621,8 +6810,8 @@
         </p:nvSpPr>
         <p:spPr>
           <a:xfrm>
-            <a:off x="548640" y="2468880"/>
-            <a:ext cx="11064240" cy="1097280"/>
+            <a:off x="457200" y="228600"/>
+            <a:ext cx="11247120" cy="548640"/>
           </a:xfrm>
           <a:prstGeom prst="rect">
             <a:avLst/>
@@ -7636,7 +6825,7 @@
           <a:lstStyle/>
           <a:p>
             <a:pPr algn="l">
-              <a:defRPr sz="4400" b="1">
+              <a:defRPr sz="3000" b="1">
                 <a:solidFill>
                   <a:srgbClr val="F3F6F9"/>
                 </a:solidFill>
@@ -7644,27 +6833,114 @@
               </a:defRPr>
             </a:pPr>
             <a:r>
-              <a:t>07 训练数据管线</a:t>
-            </a:r>
-          </a:p>
-        </p:txBody>
-      </p:sp>
-      <p:sp>
-        <p:nvSpPr>
-          <p:cNvPr id="4" name="Rectangle 3"/>
+              <a:t>跑过的轨迹 = 可复用的训练数据</a:t>
+            </a:r>
+          </a:p>
+        </p:txBody>
+      </p:sp>
+      <p:sp>
+        <p:nvSpPr>
+          <p:cNvPr id="4" name="TextBox 3"/>
+          <p:cNvSpPr txBox="1"/>
+          <p:nvPr/>
+        </p:nvSpPr>
+        <p:spPr>
+          <a:xfrm>
+            <a:off x="548640" y="1234440"/>
+            <a:ext cx="11064240" cy="5029200"/>
+          </a:xfrm>
+          <a:prstGeom prst="rect">
+            <a:avLst/>
+          </a:prstGeom>
+          <a:noFill/>
+        </p:spPr>
+        <p:txBody>
+          <a:bodyPr wrap="square">
+            <a:spAutoFit/>
+          </a:bodyPr>
+          <a:lstStyle/>
+          <a:p>
+            <a:pPr algn="l">
+              <a:spcAft>
+                <a:spcPts val="1000"/>
+              </a:spcAft>
+              <a:defRPr sz="1800" b="0">
+                <a:solidFill>
+                  <a:srgbClr val="1E2933"/>
+                </a:solidFill>
+                <a:latin typeface="Microsoft YaHei"/>
+              </a:defRPr>
+            </a:pPr>
+            <a:r>
+              <a:t>batch_runner 每步记录 state / action / keyNumbers / reason</a:t>
+            </a:r>
+          </a:p>
+          <a:p>
+            <a:pPr algn="l">
+              <a:spcAft>
+                <a:spcPts val="1000"/>
+              </a:spcAft>
+              <a:defRPr sz="1800" b="0">
+                <a:solidFill>
+                  <a:srgbClr val="1E2933"/>
+                </a:solidFill>
+                <a:latin typeface="Microsoft YaHei"/>
+              </a:defRPr>
+            </a:pPr>
+            <a:r>
+              <a:t>trajectory_converter 离线生成 7 任务样本：next_probe_action、information_gain_judgment 等</a:t>
+            </a:r>
+          </a:p>
+          <a:p>
+            <a:pPr algn="l">
+              <a:spcAft>
+                <a:spcPts val="1000"/>
+              </a:spcAft>
+              <a:defRPr sz="1800" b="0">
+                <a:solidFill>
+                  <a:srgbClr val="1E2933"/>
+                </a:solidFill>
+                <a:latin typeface="Microsoft YaHei"/>
+              </a:defRPr>
+            </a:pPr>
+            <a:r>
+              <a:t>已累积 27,693 条合并样本（去重后），覆盖 22 个游戏、rule / multi-bus-memory / multi-bus</a:t>
+            </a:r>
+          </a:p>
+          <a:p>
+            <a:pPr algn="l">
+              <a:spcAft>
+                <a:spcPts val="1000"/>
+              </a:spcAft>
+              <a:defRPr sz="1800" b="0">
+                <a:solidFill>
+                  <a:srgbClr val="1E2933"/>
+                </a:solidFill>
+                <a:latin typeface="Microsoft YaHei"/>
+              </a:defRPr>
+            </a:pPr>
+            <a:r>
+              <a:t>可直接喂给 Qwen3.5-4B/9B 与 Gemma-4-E4B 的 QLoRA 微调脚本</a:t>
+            </a:r>
+          </a:p>
+        </p:txBody>
+      </p:sp>
+      <p:sp>
+        <p:nvSpPr>
+          <p:cNvPr id="5" name="Rectangle 4"/>
           <p:cNvSpPr/>
           <p:nvPr/>
         </p:nvSpPr>
         <p:spPr>
           <a:xfrm>
-            <a:off x="548640" y="3657600"/>
-            <a:ext cx="1828800" cy="73152"/>
+            <a:off x="0" y="6537960"/>
+            <a:ext cx="12191695" cy="18288"/>
           </a:xfrm>
           <a:prstGeom prst="rect">
             <a:avLst/>
           </a:prstGeom>
           <a:solidFill>
-            <a:srgbClr val="FF6B35"/>
+            <a:srgbClr val="0096C7"/>
           </a:solidFill>
           <a:ln/>
         </p:spPr>
@@ -7692,47 +6968,6 @@
       </p:sp>
       <p:sp>
         <p:nvSpPr>
-          <p:cNvPr id="5" name="Rectangle 4"/>
-          <p:cNvSpPr/>
-          <p:nvPr/>
-        </p:nvSpPr>
-        <p:spPr>
-          <a:xfrm>
-            <a:off x="0" y="6537960"/>
-            <a:ext cx="12191695" cy="18288"/>
-          </a:xfrm>
-          <a:prstGeom prst="rect">
-            <a:avLst/>
-          </a:prstGeom>
-          <a:solidFill>
-            <a:srgbClr val="0096C7"/>
-          </a:solidFill>
-          <a:ln/>
-        </p:spPr>
-        <p:style>
-          <a:lnRef idx="1">
-            <a:schemeClr val="accent1"/>
-          </a:lnRef>
-          <a:fillRef idx="3">
-            <a:schemeClr val="accent1"/>
-          </a:fillRef>
-          <a:effectRef idx="2">
-            <a:schemeClr val="accent1"/>
-          </a:effectRef>
-          <a:fontRef idx="minor">
-            <a:schemeClr val="lt1"/>
-          </a:fontRef>
-        </p:style>
-        <p:txBody>
-          <a:bodyPr rtlCol="0" anchor="ctr"/>
-          <a:lstStyle/>
-          <a:p>
-            <a:pPr algn="ctr"/>
-          </a:p>
-        </p:txBody>
-      </p:sp>
-      <p:sp>
-        <p:nvSpPr>
           <p:cNvPr id="6" name="TextBox 5"/>
           <p:cNvSpPr txBox="1"/>
           <p:nvPr/>
@@ -7798,7 +7033,7 @@
               </a:defRPr>
             </a:pPr>
             <a:r>
-              <a:t>18/22</a:t>
+              <a:t>18/21</a:t>
             </a:r>
           </a:p>
         </p:txBody>
@@ -7830,7 +7065,7 @@
         <p:spPr>
           <a:xfrm>
             <a:off x="0" y="0"/>
-            <a:ext cx="12191695" cy="960120"/>
+            <a:ext cx="12191695" cy="6858000"/>
           </a:xfrm>
           <a:prstGeom prst="rect">
             <a:avLst/>
@@ -7870,8 +7105,8 @@
         </p:nvSpPr>
         <p:spPr>
           <a:xfrm>
-            <a:off x="457200" y="228600"/>
-            <a:ext cx="11247120" cy="548640"/>
+            <a:off x="548640" y="2468880"/>
+            <a:ext cx="11064240" cy="1097280"/>
           </a:xfrm>
           <a:prstGeom prst="rect">
             <a:avLst/>
@@ -7885,7 +7120,7 @@
           <a:lstStyle/>
           <a:p>
             <a:pPr algn="l">
-              <a:defRPr sz="3000" b="1">
+              <a:defRPr sz="4400" b="1">
                 <a:solidFill>
                   <a:srgbClr val="F3F6F9"/>
                 </a:solidFill>
@@ -7893,114 +7128,27 @@
               </a:defRPr>
             </a:pPr>
             <a:r>
-              <a:t>跑过的轨迹 = 可复用的训练数据</a:t>
-            </a:r>
-          </a:p>
-        </p:txBody>
-      </p:sp>
-      <p:sp>
-        <p:nvSpPr>
-          <p:cNvPr id="4" name="TextBox 3"/>
-          <p:cNvSpPr txBox="1"/>
-          <p:nvPr/>
-        </p:nvSpPr>
-        <p:spPr>
-          <a:xfrm>
-            <a:off x="548640" y="1234440"/>
-            <a:ext cx="11064240" cy="5029200"/>
-          </a:xfrm>
-          <a:prstGeom prst="rect">
-            <a:avLst/>
-          </a:prstGeom>
-          <a:noFill/>
-        </p:spPr>
-        <p:txBody>
-          <a:bodyPr wrap="square">
-            <a:spAutoFit/>
-          </a:bodyPr>
-          <a:lstStyle/>
-          <a:p>
-            <a:pPr algn="l">
-              <a:spcAft>
-                <a:spcPts val="1000"/>
-              </a:spcAft>
-              <a:defRPr sz="1800" b="0">
-                <a:solidFill>
-                  <a:srgbClr val="1E2933"/>
-                </a:solidFill>
-                <a:latin typeface="Microsoft YaHei"/>
-              </a:defRPr>
-            </a:pPr>
-            <a:r>
-              <a:t>batch_runner 每步记录 state / action / keyNumbers / reason</a:t>
-            </a:r>
-          </a:p>
-          <a:p>
-            <a:pPr algn="l">
-              <a:spcAft>
-                <a:spcPts val="1000"/>
-              </a:spcAft>
-              <a:defRPr sz="1800" b="0">
-                <a:solidFill>
-                  <a:srgbClr val="1E2933"/>
-                </a:solidFill>
-                <a:latin typeface="Microsoft YaHei"/>
-              </a:defRPr>
-            </a:pPr>
-            <a:r>
-              <a:t>trajectory_converter 离线生成 7 任务样本：next_probe_action、information_gain_judgment 等</a:t>
-            </a:r>
-          </a:p>
-          <a:p>
-            <a:pPr algn="l">
-              <a:spcAft>
-                <a:spcPts val="1000"/>
-              </a:spcAft>
-              <a:defRPr sz="1800" b="0">
-                <a:solidFill>
-                  <a:srgbClr val="1E2933"/>
-                </a:solidFill>
-                <a:latin typeface="Microsoft YaHei"/>
-              </a:defRPr>
-            </a:pPr>
-            <a:r>
-              <a:t>已累积 33,250 条样本，覆盖 rule / multi-bus-memory / hierarchical</a:t>
-            </a:r>
-          </a:p>
-          <a:p>
-            <a:pPr algn="l">
-              <a:spcAft>
-                <a:spcPts val="1000"/>
-              </a:spcAft>
-              <a:defRPr sz="1800" b="0">
-                <a:solidFill>
-                  <a:srgbClr val="1E2933"/>
-                </a:solidFill>
-                <a:latin typeface="Microsoft YaHei"/>
-              </a:defRPr>
-            </a:pPr>
-            <a:r>
-              <a:t>可直接喂给 Qwen3.5-4B/9B 与 Gemma-4-E4B 的 QLoRA 微调脚本</a:t>
-            </a:r>
-          </a:p>
-        </p:txBody>
-      </p:sp>
-      <p:sp>
-        <p:nvSpPr>
-          <p:cNvPr id="5" name="Rectangle 4"/>
+              <a:t>08 下一步</a:t>
+            </a:r>
+          </a:p>
+        </p:txBody>
+      </p:sp>
+      <p:sp>
+        <p:nvSpPr>
+          <p:cNvPr id="4" name="Rectangle 3"/>
           <p:cNvSpPr/>
           <p:nvPr/>
         </p:nvSpPr>
         <p:spPr>
           <a:xfrm>
-            <a:off x="0" y="6537960"/>
-            <a:ext cx="12191695" cy="18288"/>
+            <a:off x="548640" y="3657600"/>
+            <a:ext cx="1828800" cy="73152"/>
           </a:xfrm>
           <a:prstGeom prst="rect">
             <a:avLst/>
           </a:prstGeom>
           <a:solidFill>
-            <a:srgbClr val="0096C7"/>
+            <a:srgbClr val="FF6B35"/>
           </a:solidFill>
           <a:ln/>
         </p:spPr>
@@ -8028,6 +7176,47 @@
       </p:sp>
       <p:sp>
         <p:nvSpPr>
+          <p:cNvPr id="5" name="Rectangle 4"/>
+          <p:cNvSpPr/>
+          <p:nvPr/>
+        </p:nvSpPr>
+        <p:spPr>
+          <a:xfrm>
+            <a:off x="0" y="6537960"/>
+            <a:ext cx="12191695" cy="18288"/>
+          </a:xfrm>
+          <a:prstGeom prst="rect">
+            <a:avLst/>
+          </a:prstGeom>
+          <a:solidFill>
+            <a:srgbClr val="0096C7"/>
+          </a:solidFill>
+          <a:ln/>
+        </p:spPr>
+        <p:style>
+          <a:lnRef idx="1">
+            <a:schemeClr val="accent1"/>
+          </a:lnRef>
+          <a:fillRef idx="3">
+            <a:schemeClr val="accent1"/>
+          </a:fillRef>
+          <a:effectRef idx="2">
+            <a:schemeClr val="accent1"/>
+          </a:effectRef>
+          <a:fontRef idx="minor">
+            <a:schemeClr val="lt1"/>
+          </a:fontRef>
+        </p:style>
+        <p:txBody>
+          <a:bodyPr rtlCol="0" anchor="ctr"/>
+          <a:lstStyle/>
+          <a:p>
+            <a:pPr algn="ctr"/>
+          </a:p>
+        </p:txBody>
+      </p:sp>
+      <p:sp>
+        <p:nvSpPr>
           <p:cNvPr id="6" name="TextBox 5"/>
           <p:cNvSpPr txBox="1"/>
           <p:nvPr/>
@@ -8093,7 +7282,7 @@
               </a:defRPr>
             </a:pPr>
             <a:r>
-              <a:t>19/22</a:t>
+              <a:t>19/21</a:t>
             </a:r>
           </a:p>
         </p:txBody>
@@ -8420,7 +7609,7 @@
               </a:defRPr>
             </a:pPr>
             <a:r>
-              <a:t>2/22</a:t>
+              <a:t>2/21</a:t>
             </a:r>
           </a:p>
         </p:txBody>
@@ -8452,7 +7641,7 @@
         <p:spPr>
           <a:xfrm>
             <a:off x="0" y="0"/>
-            <a:ext cx="12191695" cy="6858000"/>
+            <a:ext cx="12191695" cy="960120"/>
           </a:xfrm>
           <a:prstGeom prst="rect">
             <a:avLst/>
@@ -8492,8 +7681,8 @@
         </p:nvSpPr>
         <p:spPr>
           <a:xfrm>
-            <a:off x="548640" y="2468880"/>
-            <a:ext cx="11064240" cy="1097280"/>
+            <a:off x="457200" y="228600"/>
+            <a:ext cx="11247120" cy="548640"/>
           </a:xfrm>
           <a:prstGeom prst="rect">
             <a:avLst/>
@@ -8507,7 +7696,7 @@
           <a:lstStyle/>
           <a:p>
             <a:pPr algn="l">
-              <a:defRPr sz="4400" b="1">
+              <a:defRPr sz="3000" b="1">
                 <a:solidFill>
                   <a:srgbClr val="F3F6F9"/>
                 </a:solidFill>
@@ -8515,27 +7704,114 @@
               </a:defRPr>
             </a:pPr>
             <a:r>
-              <a:t>08 下一步</a:t>
-            </a:r>
-          </a:p>
-        </p:txBody>
-      </p:sp>
-      <p:sp>
-        <p:nvSpPr>
-          <p:cNvPr id="4" name="Rectangle 3"/>
+              <a:t>接下来要攻的几件事</a:t>
+            </a:r>
+          </a:p>
+        </p:txBody>
+      </p:sp>
+      <p:sp>
+        <p:nvSpPr>
+          <p:cNvPr id="4" name="TextBox 3"/>
+          <p:cNvSpPr txBox="1"/>
+          <p:nvPr/>
+        </p:nvSpPr>
+        <p:spPr>
+          <a:xfrm>
+            <a:off x="548640" y="1234440"/>
+            <a:ext cx="11064240" cy="5029200"/>
+          </a:xfrm>
+          <a:prstGeom prst="rect">
+            <a:avLst/>
+          </a:prstGeom>
+          <a:noFill/>
+        </p:spPr>
+        <p:txBody>
+          <a:bodyPr wrap="square">
+            <a:spAutoFit/>
+          </a:bodyPr>
+          <a:lstStyle/>
+          <a:p>
+            <a:pPr algn="l">
+              <a:spcAft>
+                <a:spcPts val="1000"/>
+              </a:spcAft>
+              <a:defRPr sz="1800" b="0">
+                <a:solidFill>
+                  <a:srgbClr val="1E2933"/>
+                </a:solidFill>
+                <a:latin typeface="Microsoft YaHei"/>
+              </a:defRPr>
+            </a:pPr>
+            <a:r>
+              <a:t>跑完 B 组 15 游戏 × 2 模式 × 2 seeds，拿到完整 22 游戏矩阵</a:t>
+            </a:r>
+          </a:p>
+          <a:p>
+            <a:pPr algn="l">
+              <a:spcAft>
+                <a:spcPts val="1000"/>
+              </a:spcAft>
+              <a:defRPr sz="1800" b="0">
+                <a:solidFill>
+                  <a:srgbClr val="1E2933"/>
+                </a:solidFill>
+                <a:latin typeface="Microsoft YaHei"/>
+              </a:defRPr>
+            </a:pPr>
+            <a:r>
+              <a:t>定位并修复 00483 multi-bus / multi-bus-memory activity=0 的问题</a:t>
+            </a:r>
+          </a:p>
+          <a:p>
+            <a:pPr algn="l">
+              <a:spcAft>
+                <a:spcPts val="1000"/>
+              </a:spcAft>
+              <a:defRPr sz="1800" b="0">
+                <a:solidFill>
+                  <a:srgbClr val="1E2933"/>
+                </a:solidFill>
+                <a:latin typeface="Microsoft YaHei"/>
+              </a:defRPr>
+            </a:pPr>
+            <a:r>
+              <a:t>让本地 VLM 常驻，验证 hierarchical 三层协同的真实收益</a:t>
+            </a:r>
+          </a:p>
+          <a:p>
+            <a:pPr algn="l">
+              <a:spcAft>
+                <a:spcPts val="1000"/>
+              </a:spcAft>
+              <a:defRPr sz="1800" b="0">
+                <a:solidFill>
+                  <a:srgbClr val="1E2933"/>
+                </a:solidFill>
+                <a:latin typeface="Microsoft YaHei"/>
+              </a:defRPr>
+            </a:pPr>
+            <a:r>
+              <a:t>在 5090 服务器上跑 QLoRA 微调，把 VLM 变成专用的画面理解器</a:t>
+            </a:r>
+          </a:p>
+        </p:txBody>
+      </p:sp>
+      <p:sp>
+        <p:nvSpPr>
+          <p:cNvPr id="5" name="Rectangle 4"/>
           <p:cNvSpPr/>
           <p:nvPr/>
         </p:nvSpPr>
         <p:spPr>
           <a:xfrm>
-            <a:off x="548640" y="3657600"/>
-            <a:ext cx="1828800" cy="73152"/>
+            <a:off x="0" y="6537960"/>
+            <a:ext cx="12191695" cy="18288"/>
           </a:xfrm>
           <a:prstGeom prst="rect">
             <a:avLst/>
           </a:prstGeom>
           <a:solidFill>
-            <a:srgbClr val="FF6B35"/>
+            <a:srgbClr val="0096C7"/>
           </a:solidFill>
           <a:ln/>
         </p:spPr>
@@ -8563,47 +7839,6 @@
       </p:sp>
       <p:sp>
         <p:nvSpPr>
-          <p:cNvPr id="5" name="Rectangle 4"/>
-          <p:cNvSpPr/>
-          <p:nvPr/>
-        </p:nvSpPr>
-        <p:spPr>
-          <a:xfrm>
-            <a:off x="0" y="6537960"/>
-            <a:ext cx="12191695" cy="18288"/>
-          </a:xfrm>
-          <a:prstGeom prst="rect">
-            <a:avLst/>
-          </a:prstGeom>
-          <a:solidFill>
-            <a:srgbClr val="0096C7"/>
-          </a:solidFill>
-          <a:ln/>
-        </p:spPr>
-        <p:style>
-          <a:lnRef idx="1">
-            <a:schemeClr val="accent1"/>
-          </a:lnRef>
-          <a:fillRef idx="3">
-            <a:schemeClr val="accent1"/>
-          </a:fillRef>
-          <a:effectRef idx="2">
-            <a:schemeClr val="accent1"/>
-          </a:effectRef>
-          <a:fontRef idx="minor">
-            <a:schemeClr val="lt1"/>
-          </a:fontRef>
-        </p:style>
-        <p:txBody>
-          <a:bodyPr rtlCol="0" anchor="ctr"/>
-          <a:lstStyle/>
-          <a:p>
-            <a:pPr algn="ctr"/>
-          </a:p>
-        </p:txBody>
-      </p:sp>
-      <p:sp>
-        <p:nvSpPr>
           <p:cNvPr id="6" name="TextBox 5"/>
           <p:cNvSpPr txBox="1"/>
           <p:nvPr/>
@@ -8669,7 +7904,7 @@
               </a:defRPr>
             </a:pPr>
             <a:r>
-              <a:t>20/22</a:t>
+              <a:t>20/21</a:t>
             </a:r>
           </a:p>
         </p:txBody>
@@ -8701,7 +7936,7 @@
         <p:spPr>
           <a:xfrm>
             <a:off x="0" y="0"/>
-            <a:ext cx="12191695" cy="960120"/>
+            <a:ext cx="12191695" cy="6858000"/>
           </a:xfrm>
           <a:prstGeom prst="rect">
             <a:avLst/>
@@ -8741,8 +7976,8 @@
         </p:nvSpPr>
         <p:spPr>
           <a:xfrm>
-            <a:off x="457200" y="228600"/>
-            <a:ext cx="11247120" cy="548640"/>
+            <a:off x="457200" y="2651760"/>
+            <a:ext cx="11247120" cy="1280160"/>
           </a:xfrm>
           <a:prstGeom prst="rect">
             <a:avLst/>
@@ -8755,8 +7990,8 @@
           </a:bodyPr>
           <a:lstStyle/>
           <a:p>
-            <a:pPr algn="l">
-              <a:defRPr sz="3000" b="1">
+            <a:pPr algn="ctr">
+              <a:defRPr sz="4800" b="1">
                 <a:solidFill>
                   <a:srgbClr val="F3F6F9"/>
                 </a:solidFill>
@@ -8764,114 +7999,27 @@
               </a:defRPr>
             </a:pPr>
             <a:r>
-              <a:t>接下来要攻的几件事</a:t>
-            </a:r>
-          </a:p>
-        </p:txBody>
-      </p:sp>
-      <p:sp>
-        <p:nvSpPr>
-          <p:cNvPr id="4" name="TextBox 3"/>
-          <p:cNvSpPr txBox="1"/>
-          <p:nvPr/>
-        </p:nvSpPr>
-        <p:spPr>
-          <a:xfrm>
-            <a:off x="548640" y="1234440"/>
-            <a:ext cx="11064240" cy="5029200"/>
-          </a:xfrm>
-          <a:prstGeom prst="rect">
-            <a:avLst/>
-          </a:prstGeom>
-          <a:noFill/>
-        </p:spPr>
-        <p:txBody>
-          <a:bodyPr wrap="square">
-            <a:spAutoFit/>
-          </a:bodyPr>
-          <a:lstStyle/>
-          <a:p>
-            <a:pPr algn="l">
-              <a:spcAft>
-                <a:spcPts val="1000"/>
-              </a:spcAft>
-              <a:defRPr sz="1800" b="0">
-                <a:solidFill>
-                  <a:srgbClr val="1E2933"/>
-                </a:solidFill>
-                <a:latin typeface="Microsoft YaHei"/>
-              </a:defRPr>
-            </a:pPr>
-            <a:r>
-              <a:t>跑完 B 组 15 游戏 × 2 模式 × 2 seeds，拿到完整 22 游戏矩阵</a:t>
-            </a:r>
-          </a:p>
-          <a:p>
-            <a:pPr algn="l">
-              <a:spcAft>
-                <a:spcPts val="1000"/>
-              </a:spcAft>
-              <a:defRPr sz="1800" b="0">
-                <a:solidFill>
-                  <a:srgbClr val="1E2933"/>
-                </a:solidFill>
-                <a:latin typeface="Microsoft YaHei"/>
-              </a:defRPr>
-            </a:pPr>
-            <a:r>
-              <a:t>定位并修复 00483 multi-bus / multi-bus-memory activity=0 的问题</a:t>
-            </a:r>
-          </a:p>
-          <a:p>
-            <a:pPr algn="l">
-              <a:spcAft>
-                <a:spcPts val="1000"/>
-              </a:spcAft>
-              <a:defRPr sz="1800" b="0">
-                <a:solidFill>
-                  <a:srgbClr val="1E2933"/>
-                </a:solidFill>
-                <a:latin typeface="Microsoft YaHei"/>
-              </a:defRPr>
-            </a:pPr>
-            <a:r>
-              <a:t>让本地 VLM 常驻，验证 hierarchical 三层协同的真实收益</a:t>
-            </a:r>
-          </a:p>
-          <a:p>
-            <a:pPr algn="l">
-              <a:spcAft>
-                <a:spcPts val="1000"/>
-              </a:spcAft>
-              <a:defRPr sz="1800" b="0">
-                <a:solidFill>
-                  <a:srgbClr val="1E2933"/>
-                </a:solidFill>
-                <a:latin typeface="Microsoft YaHei"/>
-              </a:defRPr>
-            </a:pPr>
-            <a:r>
-              <a:t>在 5090 服务器上跑 QLoRA 微调，把 VLM 变成专用的画面理解器</a:t>
-            </a:r>
-          </a:p>
-        </p:txBody>
-      </p:sp>
-      <p:sp>
-        <p:nvSpPr>
-          <p:cNvPr id="5" name="Rectangle 4"/>
+              <a:t>谢谢，欢迎讨论</a:t>
+            </a:r>
+          </a:p>
+        </p:txBody>
+      </p:sp>
+      <p:sp>
+        <p:nvSpPr>
+          <p:cNvPr id="4" name="Rectangle 3"/>
           <p:cNvSpPr/>
           <p:nvPr/>
         </p:nvSpPr>
         <p:spPr>
           <a:xfrm>
-            <a:off x="0" y="6537960"/>
-            <a:ext cx="12191695" cy="18288"/>
+            <a:off x="5184648" y="3931920"/>
+            <a:ext cx="1828800" cy="73152"/>
           </a:xfrm>
           <a:prstGeom prst="rect">
             <a:avLst/>
           </a:prstGeom>
           <a:solidFill>
-            <a:srgbClr val="0096C7"/>
+            <a:srgbClr val="FF6B35"/>
           </a:solidFill>
           <a:ln/>
         </p:spPr>
@@ -8899,110 +8047,20 @@
       </p:sp>
       <p:sp>
         <p:nvSpPr>
-          <p:cNvPr id="6" name="TextBox 5"/>
-          <p:cNvSpPr txBox="1"/>
-          <p:nvPr/>
-        </p:nvSpPr>
-        <p:spPr>
-          <a:xfrm>
-            <a:off x="457200" y="6583680"/>
-            <a:ext cx="3657600" cy="228600"/>
-          </a:xfrm>
-          <a:prstGeom prst="rect">
-            <a:avLst/>
-          </a:prstGeom>
-          <a:noFill/>
-        </p:spPr>
-        <p:txBody>
-          <a:bodyPr wrap="none">
-            <a:spAutoFit/>
-          </a:bodyPr>
-          <a:lstStyle/>
-          <a:p>
-            <a:pPr algn="l">
-              <a:defRPr sz="1000" b="0">
-                <a:solidFill>
-                  <a:srgbClr val="6C757D"/>
-                </a:solidFill>
-                <a:latin typeface="Microsoft YaHei"/>
-              </a:defRPr>
-            </a:pPr>
-            <a:r>
-              <a:t>smallgameagent · LLM/VLM + 规则驱动</a:t>
-            </a:r>
-          </a:p>
-        </p:txBody>
-      </p:sp>
-      <p:sp>
-        <p:nvSpPr>
-          <p:cNvPr id="7" name="TextBox 6"/>
-          <p:cNvSpPr txBox="1"/>
-          <p:nvPr/>
-        </p:nvSpPr>
-        <p:spPr>
-          <a:xfrm>
-            <a:off x="10789920" y="6583680"/>
-            <a:ext cx="914400" cy="228600"/>
-          </a:xfrm>
-          <a:prstGeom prst="rect">
-            <a:avLst/>
-          </a:prstGeom>
-          <a:noFill/>
-        </p:spPr>
-        <p:txBody>
-          <a:bodyPr wrap="none">
-            <a:spAutoFit/>
-          </a:bodyPr>
-          <a:lstStyle/>
-          <a:p>
-            <a:pPr algn="r">
-              <a:defRPr sz="1000" b="0">
-                <a:solidFill>
-                  <a:srgbClr val="6C757D"/>
-                </a:solidFill>
-                <a:latin typeface="Microsoft YaHei"/>
-              </a:defRPr>
-            </a:pPr>
-            <a:r>
-              <a:t>21/22</a:t>
-            </a:r>
-          </a:p>
-        </p:txBody>
-      </p:sp>
-    </p:spTree>
-  </p:cSld>
-  <p:clrMapOvr>
-    <a:masterClrMapping/>
-  </p:clrMapOvr>
-</p:sld>
-</file>
-
-<file path=ppt/slides/slide22.xml><?xml version="1.0" encoding="utf-8"?>
-<p:sld xmlns:a="http://schemas.openxmlformats.org/drawingml/2006/main" xmlns:p="http://schemas.openxmlformats.org/presentationml/2006/main" xmlns:r="http://schemas.openxmlformats.org/officeDocument/2006/relationships">
-  <p:cSld>
-    <p:spTree>
-      <p:nvGrpSpPr>
-        <p:cNvPr id="1" name=""/>
-        <p:cNvGrpSpPr/>
-        <p:nvPr/>
-      </p:nvGrpSpPr>
-      <p:grpSpPr/>
-      <p:sp>
-        <p:nvSpPr>
-          <p:cNvPr id="2" name="Rectangle 1"/>
+          <p:cNvPr id="5" name="Rectangle 4"/>
           <p:cNvSpPr/>
           <p:nvPr/>
         </p:nvSpPr>
         <p:spPr>
           <a:xfrm>
-            <a:off x="0" y="0"/>
-            <a:ext cx="12191695" cy="6858000"/>
+            <a:off x="0" y="6537960"/>
+            <a:ext cx="12191695" cy="18288"/>
           </a:xfrm>
           <a:prstGeom prst="rect">
             <a:avLst/>
           </a:prstGeom>
           <a:solidFill>
-            <a:srgbClr val="1A237E"/>
+            <a:srgbClr val="0096C7"/>
           </a:solidFill>
           <a:ln/>
         </p:spPr>
@@ -9030,14 +8088,14 @@
       </p:sp>
       <p:sp>
         <p:nvSpPr>
-          <p:cNvPr id="3" name="TextBox 2"/>
+          <p:cNvPr id="6" name="TextBox 5"/>
           <p:cNvSpPr txBox="1"/>
           <p:nvPr/>
         </p:nvSpPr>
         <p:spPr>
           <a:xfrm>
-            <a:off x="457200" y="2651760"/>
-            <a:ext cx="11247120" cy="1280160"/>
+            <a:off x="457200" y="6583680"/>
+            <a:ext cx="3657600" cy="228600"/>
           </a:xfrm>
           <a:prstGeom prst="rect">
             <a:avLst/>
@@ -9050,112 +8108,30 @@
           </a:bodyPr>
           <a:lstStyle/>
           <a:p>
-            <a:pPr algn="ctr">
-              <a:defRPr sz="4800" b="1">
-                <a:solidFill>
-                  <a:srgbClr val="F3F6F9"/>
-                </a:solidFill>
-                <a:latin typeface="Microsoft YaHei"/>
-              </a:defRPr>
-            </a:pPr>
-            <a:r>
-              <a:t>谢谢，欢迎讨论</a:t>
-            </a:r>
-          </a:p>
-        </p:txBody>
-      </p:sp>
-      <p:sp>
-        <p:nvSpPr>
-          <p:cNvPr id="4" name="Rectangle 3"/>
-          <p:cNvSpPr/>
-          <p:nvPr/>
-        </p:nvSpPr>
-        <p:spPr>
-          <a:xfrm>
-            <a:off x="5184648" y="3931920"/>
-            <a:ext cx="1828800" cy="73152"/>
-          </a:xfrm>
-          <a:prstGeom prst="rect">
-            <a:avLst/>
-          </a:prstGeom>
-          <a:solidFill>
-            <a:srgbClr val="FF6B35"/>
-          </a:solidFill>
-          <a:ln/>
-        </p:spPr>
-        <p:style>
-          <a:lnRef idx="1">
-            <a:schemeClr val="accent1"/>
-          </a:lnRef>
-          <a:fillRef idx="3">
-            <a:schemeClr val="accent1"/>
-          </a:fillRef>
-          <a:effectRef idx="2">
-            <a:schemeClr val="accent1"/>
-          </a:effectRef>
-          <a:fontRef idx="minor">
-            <a:schemeClr val="lt1"/>
-          </a:fontRef>
-        </p:style>
-        <p:txBody>
-          <a:bodyPr rtlCol="0" anchor="ctr"/>
-          <a:lstStyle/>
-          <a:p>
-            <a:pPr algn="ctr"/>
-          </a:p>
-        </p:txBody>
-      </p:sp>
-      <p:sp>
-        <p:nvSpPr>
-          <p:cNvPr id="5" name="Rectangle 4"/>
-          <p:cNvSpPr/>
-          <p:nvPr/>
-        </p:nvSpPr>
-        <p:spPr>
-          <a:xfrm>
-            <a:off x="0" y="6537960"/>
-            <a:ext cx="12191695" cy="18288"/>
-          </a:xfrm>
-          <a:prstGeom prst="rect">
-            <a:avLst/>
-          </a:prstGeom>
-          <a:solidFill>
-            <a:srgbClr val="0096C7"/>
-          </a:solidFill>
-          <a:ln/>
-        </p:spPr>
-        <p:style>
-          <a:lnRef idx="1">
-            <a:schemeClr val="accent1"/>
-          </a:lnRef>
-          <a:fillRef idx="3">
-            <a:schemeClr val="accent1"/>
-          </a:fillRef>
-          <a:effectRef idx="2">
-            <a:schemeClr val="accent1"/>
-          </a:effectRef>
-          <a:fontRef idx="minor">
-            <a:schemeClr val="lt1"/>
-          </a:fontRef>
-        </p:style>
-        <p:txBody>
-          <a:bodyPr rtlCol="0" anchor="ctr"/>
-          <a:lstStyle/>
-          <a:p>
-            <a:pPr algn="ctr"/>
-          </a:p>
-        </p:txBody>
-      </p:sp>
-      <p:sp>
-        <p:nvSpPr>
-          <p:cNvPr id="6" name="TextBox 5"/>
+            <a:pPr algn="l">
+              <a:defRPr sz="1000" b="0">
+                <a:solidFill>
+                  <a:srgbClr val="6C757D"/>
+                </a:solidFill>
+                <a:latin typeface="Microsoft YaHei"/>
+              </a:defRPr>
+            </a:pPr>
+            <a:r>
+              <a:t>smallgameagent · LLM/VLM + 规则驱动</a:t>
+            </a:r>
+          </a:p>
+        </p:txBody>
+      </p:sp>
+      <p:sp>
+        <p:nvSpPr>
+          <p:cNvPr id="7" name="TextBox 6"/>
           <p:cNvSpPr txBox="1"/>
           <p:nvPr/>
         </p:nvSpPr>
         <p:spPr>
           <a:xfrm>
-            <a:off x="457200" y="6583680"/>
-            <a:ext cx="3657600" cy="228600"/>
+            <a:off x="10789920" y="6583680"/>
+            <a:ext cx="914400" cy="228600"/>
           </a:xfrm>
           <a:prstGeom prst="rect">
             <a:avLst/>
@@ -9168,42 +8144,6 @@
           </a:bodyPr>
           <a:lstStyle/>
           <a:p>
-            <a:pPr algn="l">
-              <a:defRPr sz="1000" b="0">
-                <a:solidFill>
-                  <a:srgbClr val="6C757D"/>
-                </a:solidFill>
-                <a:latin typeface="Microsoft YaHei"/>
-              </a:defRPr>
-            </a:pPr>
-            <a:r>
-              <a:t>smallgameagent · LLM/VLM + 规则驱动</a:t>
-            </a:r>
-          </a:p>
-        </p:txBody>
-      </p:sp>
-      <p:sp>
-        <p:nvSpPr>
-          <p:cNvPr id="7" name="TextBox 6"/>
-          <p:cNvSpPr txBox="1"/>
-          <p:nvPr/>
-        </p:nvSpPr>
-        <p:spPr>
-          <a:xfrm>
-            <a:off x="10789920" y="6583680"/>
-            <a:ext cx="914400" cy="228600"/>
-          </a:xfrm>
-          <a:prstGeom prst="rect">
-            <a:avLst/>
-          </a:prstGeom>
-          <a:noFill/>
-        </p:spPr>
-        <p:txBody>
-          <a:bodyPr wrap="none">
-            <a:spAutoFit/>
-          </a:bodyPr>
-          <a:lstStyle/>
-          <a:p>
             <a:pPr algn="r">
               <a:defRPr sz="1000" b="0">
                 <a:solidFill>
@@ -9213,7 +8153,7 @@
               </a:defRPr>
             </a:pPr>
             <a:r>
-              <a:t>22/22</a:t>
+              <a:t>21/21</a:t>
             </a:r>
           </a:p>
         </p:txBody>
@@ -9462,7 +8402,7 @@
               </a:defRPr>
             </a:pPr>
             <a:r>
-              <a:t>3/22</a:t>
+              <a:t>3/21</a:t>
             </a:r>
           </a:p>
         </p:txBody>
@@ -9773,7 +8713,7 @@
               </a:defRPr>
             </a:pPr>
             <a:r>
-              <a:t>4/22</a:t>
+              <a:t>4/21</a:t>
             </a:r>
           </a:p>
         </p:txBody>
@@ -10022,7 +8962,7 @@
               </a:defRPr>
             </a:pPr>
             <a:r>
-              <a:t>5/22</a:t>
+              <a:t>5/21</a:t>
             </a:r>
           </a:p>
         </p:txBody>
@@ -11076,7 +10016,7 @@
               </a:defRPr>
             </a:pPr>
             <a:r>
-              <a:t>6/22</a:t>
+              <a:t>6/21</a:t>
             </a:r>
           </a:p>
         </p:txBody>
@@ -11371,7 +10311,7 @@
               </a:defRPr>
             </a:pPr>
             <a:r>
-              <a:t>7/22</a:t>
+              <a:t>7/21</a:t>
             </a:r>
           </a:p>
         </p:txBody>
@@ -11620,7 +10560,7 @@
               </a:defRPr>
             </a:pPr>
             <a:r>
-              <a:t>8/22</a:t>
+              <a:t>8/21</a:t>
             </a:r>
           </a:p>
         </p:txBody>
@@ -11931,7 +10871,7 @@
               </a:defRPr>
             </a:pPr>
             <a:r>
-              <a:t>9/22</a:t>
+              <a:t>9/21</a:t>
             </a:r>
           </a:p>
         </p:txBody>

</xml_diff>

<commit_message>
feat: fix Kimi/Qwen provider configs and add multi-provider smoke test
- Update Kimi base_url to /coding/v1 and default model to kimi-k2.5
- Update Qwen default model to qwen3.7-max (discovered via models.list())
- Add scripts/test_cloud_providers.py for automated provider smoke tests
- Smoke results: Kimi/Xiaomi text+vision available, Qwen text available,
  OpenCodeGo/DeepSeek blocked by balance
- Update api_client tests and regenerate report/PPT
</commit_message>
<xml_diff>
--- a/reports/smallgameagent_report.pptx
+++ b/reports/smallgameagent_report.pptx
@@ -10726,7 +10726,7 @@
               </a:defRPr>
             </a:pPr>
             <a:r>
-              <a:t>当前实测可用：Xiaomi / mimo-v2.5（文本 + 多模态）</a:t>
+              <a:t>当前实测可用：Kimi / xiaomi 文本+多模态；Qwen 文本可用；OpenCodeGo / DeepSeek 余额不足</a:t>
             </a:r>
           </a:p>
           <a:p>
@@ -10742,7 +10742,7 @@
               </a:defRPr>
             </a:pPr>
             <a:r>
-              <a:t>OpenCodeGo、DeepSeek 余额不足；Kimi、Qwen 需确认模型名后重测</a:t>
+              <a:t>修复 Kimi base_url 需加 /v1，Qwen 默认模型改为 qwen3.7-max</a:t>
             </a:r>
           </a:p>
           <a:p>

</xml_diff>

<commit_message>
docs: add VLM training dataset generation and 5090 training prep
- Generate vlm-training-data-processed-runs/ (15,083 samples, 22 games, 7 tasks)
  using src/training/processed_runs_converter.py.
- Validate VLMColdStartDataset loads images and messages correctly.
- Document dataset stats and exact 5090 QLoRA commands in REPORT.md and
  EXPERIMENT_RESULTS.md.
- Update PPT data-pipeline slide with new sample counts and next steps.
- Regenerate PDF/PPT.
</commit_message>
<xml_diff>
--- a/reports/smallgameagent_report.pptx
+++ b/reports/smallgameagent_report.pptx
@@ -9674,7 +9674,7 @@
               </a:defRPr>
             </a:pPr>
             <a:r>
-              <a:t>trajectory_converter 离线生成 7 任务样本：next_probe_action、information_gain_judgment 等</a:t>
+              <a:t>processed_runs_converter 从 22 个游戏的 processed-runs 生成 7 任务样本</a:t>
             </a:r>
           </a:p>
           <a:p>
@@ -9690,7 +9690,7 @@
               </a:defRPr>
             </a:pPr>
             <a:r>
-              <a:t>已累积 27,693 条合并样本（去重后），覆盖 22 个游戏、rule / multi-bus-memory / multi-bus</a:t>
+              <a:t>当前数据集：15,083 条样本，覆盖 next_probe_action / information_gain_judgment 等任务</a:t>
             </a:r>
           </a:p>
           <a:p>
@@ -9706,7 +9706,7 @@
               </a:defRPr>
             </a:pPr>
             <a:r>
-              <a:t>可直接喂给 Qwen3.5-4B/9B 与 Gemma-4-E4B 的 QLoRA 微调脚本</a:t>
+              <a:t>可直接喂给 Qwen3.5-4B/9B 与 Gemma-4-E4B 的 QLoRA 微调脚本（在 5090 服务器执行）</a:t>
             </a:r>
           </a:p>
         </p:txBody>
@@ -10202,7 +10202,7 @@
               </a:defRPr>
             </a:pPr>
             <a:r>
-              <a:t>把离线回放扩展到 multi-bus / multi-bus-memory，量化 Agent 通信与记忆的真实收益</a:t>
+              <a:t>在更多游戏上跑真实 Qwen multi-bus-memory，量化通信/记忆成本与收益</a:t>
             </a:r>
           </a:p>
           <a:p>
@@ -10218,7 +10218,7 @@
               </a:defRPr>
             </a:pPr>
             <a:r>
-              <a:t>在更多游戏上跑 Qwen L2，测试规则更新对 composite 的泛化提升</a:t>
+              <a:t>尝试 L2 规则更新的 code_file 模式（allowlist + 高置信度 + 自动备份）</a:t>
             </a:r>
           </a:p>
           <a:p>
@@ -10250,7 +10250,7 @@
               </a:defRPr>
             </a:pPr>
             <a:r>
-              <a:t>在 5090 服务器上跑 QLoRA 微调，把 VLM 变成专用画面理解器</a:t>
+              <a:t>在 5090 服务器上跑 QLoRA 微调，把本地 VLM 变成专用画面理解器</a:t>
             </a:r>
           </a:p>
           <a:p>
@@ -10266,7 +10266,7 @@
               </a:defRPr>
             </a:pPr>
             <a:r>
-              <a:t>完善 Critic → MemoryCurator 的闭环：规则更新提议需经评估再落地</a:t>
+              <a:t>把离线回放集成到 CI：每次规则改动自动跑 5 游戏回归</a:t>
             </a:r>
           </a:p>
         </p:txBody>

</xml_diff>

<commit_message>
feat: real-cloud L2 code-file rule updates across qwen/kimi/xiaomi
- Configure .env with all provided cloud API keys and model overrides
  (KIMI_TEXT_MODEL=kimi-k2.7-code). .env remains gitignored.
- Add src/experiments/exp_code_file_rule_update_real.py: direct L2 prompt
  for code_file updates on qwen/kimi/xiaomi.
- qwen/kimi succeed with open JSON schema; xiaomi/mimo-v2.5 needs a
  few-shot JSON template to avoid truncation/empty output.
- Update REPORT.md / EXPERIMENT_RESULTS.md / PPT with provider comparison
  table and prompt-engineering findings.
- Regenerate PDF/PPT.
- Tests: ruff clean; existing pytest 47 passed.
</commit_message>
<xml_diff>
--- a/reports/smallgameagent_report.pptx
+++ b/reports/smallgameagent_report.pptx
@@ -5103,16 +5103,384 @@
           </a:p>
         </p:txBody>
       </p:sp>
-      <p:sp>
-        <p:nvSpPr>
-          <p:cNvPr id="12" name="Rounded Rectangle 11"/>
+      <p:graphicFrame>
+        <p:nvGraphicFramePr>
+          <p:cNvPr id="12" name="Table 11"/>
+          <p:cNvGraphicFramePr>
+            <a:graphicFrameLocks noGrp="1"/>
+          </p:cNvGraphicFramePr>
+          <p:nvPr/>
+        </p:nvGraphicFramePr>
+        <p:xfrm>
+          <a:off x="457200" y="3886200"/>
+          <a:ext cx="11247120" cy="1463040"/>
+        </p:xfrm>
+        <a:graphic>
+          <a:graphicData uri="http://schemas.openxmlformats.org/drawingml/2006/table">
+            <a:tbl>
+              <a:tblPr firstRow="1" bandRow="1">
+                <a:tableStyleId>{5C22544A-7EE6-4342-B048-85BDC9FD1C3A}</a:tableStyleId>
+              </a:tblPr>
+              <a:tblGrid>
+                <a:gridCol w="2811780"/>
+                <a:gridCol w="2811780"/>
+                <a:gridCol w="2811780"/>
+                <a:gridCol w="2811780"/>
+              </a:tblGrid>
+              <a:tr h="365760">
+                <a:tc>
+                  <a:txBody>
+                    <a:bodyPr/>
+                    <a:lstStyle/>
+                    <a:p>
+                      <a:pPr algn="ctr">
+                        <a:defRPr sz="1100" b="1">
+                          <a:solidFill>
+                            <a:srgbClr val="F3F6F9"/>
+                          </a:solidFill>
+                          <a:latin typeface="Microsoft YaHei"/>
+                        </a:defRPr>
+                      </a:pPr>
+                      <a:r>
+                        <a:t>Provider</a:t>
+                      </a:r>
+                    </a:p>
+                  </a:txBody>
+                  <a:tcPr>
+                    <a:solidFill>
+                      <a:srgbClr val="1A237E"/>
+                    </a:solidFill>
+                  </a:tcPr>
+                </a:tc>
+                <a:tc>
+                  <a:txBody>
+                    <a:bodyPr/>
+                    <a:lstStyle/>
+                    <a:p>
+                      <a:pPr algn="ctr">
+                        <a:defRPr sz="1100" b="1">
+                          <a:solidFill>
+                            <a:srgbClr val="F3F6F9"/>
+                          </a:solidFill>
+                          <a:latin typeface="Microsoft YaHei"/>
+                        </a:defRPr>
+                      </a:pPr>
+                      <a:r>
+                        <a:t>模型</a:t>
+                      </a:r>
+                    </a:p>
+                  </a:txBody>
+                  <a:tcPr>
+                    <a:solidFill>
+                      <a:srgbClr val="1A237E"/>
+                    </a:solidFill>
+                  </a:tcPr>
+                </a:tc>
+                <a:tc>
+                  <a:txBody>
+                    <a:bodyPr/>
+                    <a:lstStyle/>
+                    <a:p>
+                      <a:pPr algn="ctr">
+                        <a:defRPr sz="1100" b="1">
+                          <a:solidFill>
+                            <a:srgbClr val="F3F6F9"/>
+                          </a:solidFill>
+                          <a:latin typeface="Microsoft YaHei"/>
+                        </a:defRPr>
+                      </a:pPr>
+                      <a:r>
+                        <a:t>延迟</a:t>
+                      </a:r>
+                    </a:p>
+                  </a:txBody>
+                  <a:tcPr>
+                    <a:solidFill>
+                      <a:srgbClr val="1A237E"/>
+                    </a:solidFill>
+                  </a:tcPr>
+                </a:tc>
+                <a:tc>
+                  <a:txBody>
+                    <a:bodyPr/>
+                    <a:lstStyle/>
+                    <a:p>
+                      <a:pPr algn="ctr">
+                        <a:defRPr sz="1100" b="1">
+                          <a:solidFill>
+                            <a:srgbClr val="F3F6F9"/>
+                          </a:solidFill>
+                          <a:latin typeface="Microsoft YaHei"/>
+                        </a:defRPr>
+                      </a:pPr>
+                      <a:r>
+                        <a:t>结果</a:t>
+                      </a:r>
+                    </a:p>
+                  </a:txBody>
+                  <a:tcPr>
+                    <a:solidFill>
+                      <a:srgbClr val="1A237E"/>
+                    </a:solidFill>
+                  </a:tcPr>
+                </a:tc>
+              </a:tr>
+              <a:tr h="365760">
+                <a:tc>
+                  <a:txBody>
+                    <a:bodyPr/>
+                    <a:lstStyle/>
+                    <a:p>
+                      <a:pPr algn="ctr">
+                        <a:defRPr sz="1100">
+                          <a:latin typeface="Microsoft YaHei"/>
+                        </a:defRPr>
+                      </a:pPr>
+                      <a:r>
+                        <a:t>qwen</a:t>
+                      </a:r>
+                    </a:p>
+                  </a:txBody>
+                  <a:tcPr>
+                    <a:solidFill>
+                      <a:srgbClr val="F3F6F9"/>
+                    </a:solidFill>
+                  </a:tcPr>
+                </a:tc>
+                <a:tc>
+                  <a:txBody>
+                    <a:bodyPr/>
+                    <a:lstStyle/>
+                    <a:p>
+                      <a:pPr algn="ctr">
+                        <a:defRPr sz="1100">
+                          <a:latin typeface="Microsoft YaHei"/>
+                        </a:defRPr>
+                      </a:pPr>
+                      <a:r>
+                        <a:t>qwen3.7-max</a:t>
+                      </a:r>
+                    </a:p>
+                  </a:txBody>
+                  <a:tcPr>
+                    <a:solidFill>
+                      <a:srgbClr val="F3F6F9"/>
+                    </a:solidFill>
+                  </a:tcPr>
+                </a:tc>
+                <a:tc>
+                  <a:txBody>
+                    <a:bodyPr/>
+                    <a:lstStyle/>
+                    <a:p>
+                      <a:pPr algn="ctr">
+                        <a:defRPr sz="1100">
+                          <a:latin typeface="Microsoft YaHei"/>
+                        </a:defRPr>
+                      </a:pPr>
+                      <a:r>
+                        <a:t>7.83s</a:t>
+                      </a:r>
+                    </a:p>
+                  </a:txBody>
+                  <a:tcPr>
+                    <a:solidFill>
+                      <a:srgbClr val="F3F6F9"/>
+                    </a:solidFill>
+                  </a:tcPr>
+                </a:tc>
+                <a:tc>
+                  <a:txBody>
+                    <a:bodyPr/>
+                    <a:lstStyle/>
+                    <a:p>
+                      <a:pPr algn="ctr">
+                        <a:defRPr sz="1100">
+                          <a:latin typeface="Microsoft YaHei"/>
+                        </a:defRPr>
+                      </a:pPr>
+                      <a:r>
+                        <a:t>✅ 应用成功</a:t>
+                      </a:r>
+                    </a:p>
+                  </a:txBody>
+                  <a:tcPr>
+                    <a:solidFill>
+                      <a:srgbClr val="F3F6F9"/>
+                    </a:solidFill>
+                  </a:tcPr>
+                </a:tc>
+              </a:tr>
+              <a:tr h="365760">
+                <a:tc>
+                  <a:txBody>
+                    <a:bodyPr/>
+                    <a:lstStyle/>
+                    <a:p>
+                      <a:pPr algn="ctr">
+                        <a:defRPr sz="1100">
+                          <a:latin typeface="Microsoft YaHei"/>
+                        </a:defRPr>
+                      </a:pPr>
+                      <a:r>
+                        <a:t>kimi</a:t>
+                      </a:r>
+                    </a:p>
+                  </a:txBody>
+                  <a:tcPr/>
+                </a:tc>
+                <a:tc>
+                  <a:txBody>
+                    <a:bodyPr/>
+                    <a:lstStyle/>
+                    <a:p>
+                      <a:pPr algn="ctr">
+                        <a:defRPr sz="1100">
+                          <a:latin typeface="Microsoft YaHei"/>
+                        </a:defRPr>
+                      </a:pPr>
+                      <a:r>
+                        <a:t>kimi-k2.7-code</a:t>
+                      </a:r>
+                    </a:p>
+                  </a:txBody>
+                  <a:tcPr/>
+                </a:tc>
+                <a:tc>
+                  <a:txBody>
+                    <a:bodyPr/>
+                    <a:lstStyle/>
+                    <a:p>
+                      <a:pPr algn="ctr">
+                        <a:defRPr sz="1100">
+                          <a:latin typeface="Microsoft YaHei"/>
+                        </a:defRPr>
+                      </a:pPr>
+                      <a:r>
+                        <a:t>3.32s</a:t>
+                      </a:r>
+                    </a:p>
+                  </a:txBody>
+                  <a:tcPr/>
+                </a:tc>
+                <a:tc>
+                  <a:txBody>
+                    <a:bodyPr/>
+                    <a:lstStyle/>
+                    <a:p>
+                      <a:pPr algn="ctr">
+                        <a:defRPr sz="1100">
+                          <a:latin typeface="Microsoft YaHei"/>
+                        </a:defRPr>
+                      </a:pPr>
+                      <a:r>
+                        <a:t>✅ 应用成功</a:t>
+                      </a:r>
+                    </a:p>
+                  </a:txBody>
+                  <a:tcPr/>
+                </a:tc>
+              </a:tr>
+              <a:tr h="365760">
+                <a:tc>
+                  <a:txBody>
+                    <a:bodyPr/>
+                    <a:lstStyle/>
+                    <a:p>
+                      <a:pPr algn="ctr">
+                        <a:defRPr sz="1100">
+                          <a:latin typeface="Microsoft YaHei"/>
+                        </a:defRPr>
+                      </a:pPr>
+                      <a:r>
+                        <a:t>xiaomi</a:t>
+                      </a:r>
+                    </a:p>
+                  </a:txBody>
+                  <a:tcPr>
+                    <a:solidFill>
+                      <a:srgbClr val="F3F6F9"/>
+                    </a:solidFill>
+                  </a:tcPr>
+                </a:tc>
+                <a:tc>
+                  <a:txBody>
+                    <a:bodyPr/>
+                    <a:lstStyle/>
+                    <a:p>
+                      <a:pPr algn="ctr">
+                        <a:defRPr sz="1100">
+                          <a:latin typeface="Microsoft YaHei"/>
+                        </a:defRPr>
+                      </a:pPr>
+                      <a:r>
+                        <a:t>mimo-v2.5</a:t>
+                      </a:r>
+                    </a:p>
+                  </a:txBody>
+                  <a:tcPr>
+                    <a:solidFill>
+                      <a:srgbClr val="F3F6F9"/>
+                    </a:solidFill>
+                  </a:tcPr>
+                </a:tc>
+                <a:tc>
+                  <a:txBody>
+                    <a:bodyPr/>
+                    <a:lstStyle/>
+                    <a:p>
+                      <a:pPr algn="ctr">
+                        <a:defRPr sz="1100">
+                          <a:latin typeface="Microsoft YaHei"/>
+                        </a:defRPr>
+                      </a:pPr>
+                      <a:r>
+                        <a:t>6.18s</a:t>
+                      </a:r>
+                    </a:p>
+                  </a:txBody>
+                  <a:tcPr>
+                    <a:solidFill>
+                      <a:srgbClr val="F3F6F9"/>
+                    </a:solidFill>
+                  </a:tcPr>
+                </a:tc>
+                <a:tc>
+                  <a:txBody>
+                    <a:bodyPr/>
+                    <a:lstStyle/>
+                    <a:p>
+                      <a:pPr algn="ctr">
+                        <a:defRPr sz="1100">
+                          <a:latin typeface="Microsoft YaHei"/>
+                        </a:defRPr>
+                      </a:pPr>
+                      <a:r>
+                        <a:t>✅ 应用成功</a:t>
+                      </a:r>
+                    </a:p>
+                  </a:txBody>
+                  <a:tcPr>
+                    <a:solidFill>
+                      <a:srgbClr val="F3F6F9"/>
+                    </a:solidFill>
+                  </a:tcPr>
+                </a:tc>
+              </a:tr>
+            </a:tbl>
+          </a:graphicData>
+        </a:graphic>
+      </p:graphicFrame>
+      <p:sp>
+        <p:nvSpPr>
+          <p:cNvPr id="13" name="Rounded Rectangle 12"/>
           <p:cNvSpPr/>
           <p:nvPr/>
         </p:nvSpPr>
         <p:spPr>
           <a:xfrm>
-            <a:off x="457200" y="3840480"/>
-            <a:ext cx="11247120" cy="914400"/>
+            <a:off x="457200" y="5486400"/>
+            <a:ext cx="11247120" cy="548640"/>
           </a:xfrm>
           <a:prstGeom prst="roundRect">
             <a:avLst/>
@@ -5141,7 +5509,7 @@
           <a:lstStyle/>
           <a:p>
             <a:pPr algn="ctr">
-              <a:defRPr sz="1400" b="0">
+              <a:defRPr sz="1200" b="0">
                 <a:solidFill>
                   <a:srgbClr val="1E2933"/>
                 </a:solidFill>
@@ -5149,14 +5517,14 @@
               </a:defRPr>
             </a:pPr>
             <a:r>
-              <a:t>意义：云端模型不仅能改内存参数，还能持久化地调整规则引擎的「旋钮」。重启后仍然生效，且风险被限制在单一配置文件中。</a:t>
-            </a:r>
-          </a:p>
-        </p:txBody>
-      </p:sp>
-      <p:sp>
-        <p:nvSpPr>
-          <p:cNvPr id="13" name="Rectangle 12"/>
+              <a:t>意义：云端模型不仅能改内存参数，还能持久化地调整规则引擎的「旋钮」，且 qwen/kimi/xiaomi 三家都能正确生成可应用的 JSON patch。</a:t>
+            </a:r>
+          </a:p>
+        </p:txBody>
+      </p:sp>
+      <p:sp>
+        <p:nvSpPr>
+          <p:cNvPr id="14" name="Rectangle 13"/>
           <p:cNvSpPr/>
           <p:nvPr/>
         </p:nvSpPr>
@@ -5197,7 +5565,7 @@
       </p:sp>
       <p:sp>
         <p:nvSpPr>
-          <p:cNvPr id="14" name="TextBox 13"/>
+          <p:cNvPr id="15" name="TextBox 14"/>
           <p:cNvSpPr txBox="1"/>
           <p:nvPr/>
         </p:nvSpPr>
@@ -5233,7 +5601,7 @@
       </p:sp>
       <p:sp>
         <p:nvSpPr>
-          <p:cNvPr id="15" name="TextBox 14"/>
+          <p:cNvPr id="16" name="TextBox 15"/>
           <p:cNvSpPr txBox="1"/>
           <p:nvPr/>
         </p:nvSpPr>

</xml_diff>

<commit_message>
feat: local Qwen3.5-4B VLM visual context + cloud strategy comparison
- Start llama.cpp CUDA12 server with Qwen3.5-4B-Q4_K_M.gguf + mmproj on
  RTX 5060 Laptop 8 GB.
- Add src/experiments/exp_local_vlm_cloud_context.py: local VLM describes
  screenshot, then qwen3.7-max predicts action with/without the summary.
- 9 evaluated steps: text-only 5/9 match, with-visual 3/9 match.
- Finding: default 4-bit Qwen3.5-4B summaries are unstable (CoT drafts,
  truncation) and can mislead cloud API direction; QLoRA fine-tuning is
  needed for reliable L1 visual context.
- Update REPORT.md / EXPERIMENT_RESULTS.md / PPT with §23 local VLM
  experiment and results.
- ruff clean.
</commit_message>
<xml_diff>
--- a/reports/smallgameagent_report.pptx
+++ b/reports/smallgameagent_report.pptx
@@ -8069,7 +8069,7 @@
               </a:defRPr>
             </a:pPr>
             <a:r>
-              <a:t>当前本地测试：Gemma-4-E4B 输出最稳定，3/3 帧可解析</a:t>
+              <a:t>当前本地测试：Qwen3.5-4B 在 RTX 5060 8GB 上约 7s/帧可跑通</a:t>
             </a:r>
           </a:p>
           <a:p>
@@ -8085,7 +8085,7 @@
               </a:defRPr>
             </a:pPr>
             <a:r>
-              <a:t>Qwen 系列速度更快，但需要更强的「只输出 JSON」系统提示约束</a:t>
+              <a:t>但默认模型的视觉摘要不稳定，有时输出大量草稿/截断，反而带偏云端策略</a:t>
             </a:r>
           </a:p>
           <a:p>
@@ -8101,7 +8101,23 @@
               </a:defRPr>
             </a:pPr>
             <a:r>
-              <a:t>未来：离线标注 → QLoRA 微调 → 给云端 API 提供视觉上下文</a:t>
+              <a:t>实验：text-only 5/9 动作匹配，加本地 VLM 上下文后 3/9</a:t>
+            </a:r>
+          </a:p>
+          <a:p>
+            <a:pPr algn="l">
+              <a:spcAft>
+                <a:spcPts val="1000"/>
+              </a:spcAft>
+              <a:defRPr sz="1800" b="0">
+                <a:solidFill>
+                  <a:srgbClr val="1E2933"/>
+                </a:solidFill>
+                <a:latin typeface="Microsoft YaHei"/>
+              </a:defRPr>
+            </a:pPr>
+            <a:r>
+              <a:t>未来：离线标注 → QLoRA 微调 → 给云端 API 提供结构化视觉上下文</a:t>
             </a:r>
           </a:p>
         </p:txBody>

</xml_diff>

<commit_message>
fix(strategy_memory): session isolation for online self-reinforcement; update representative subset results
- Add run_id to StrategyMemory record/lookup to exclude current session.
- Update DecisionAnalyst, Orchestrator, HybridAgent to pass run_id.
- Re-run 6-game representative subset with per-mode isolated memory.
- Update REPORT.md \u00a727/\u00a728/\u00a729 with new rule/multi-bus/multi-bus-memory scores.
- Regenerate PDF/PPTX deliverables.
- Quality gates: ruff clean, pytest 707 passed 58 skipped.
</commit_message>
<xml_diff>
--- a/reports/smallgameagent_report.pptx
+++ b/reports/smallgameagent_report.pptx
@@ -12956,7 +12956,7 @@
               </a:defRPr>
             </a:pPr>
             <a:r>
-              <a:t>multi-bus-memory 在 representative subset 上 mean composite 0.275，5/6 游戏优于或持平 rule。</a:t>
+              <a:t>rule 在 6 游戏 representative subset 上 mean composite=0.251，仍是当前最稳短程基线。</a:t>
             </a:r>
           </a:p>
         </p:txBody>
@@ -13043,7 +13043,7 @@
               </a:defRPr>
             </a:pPr>
             <a:r>
-              <a:t>L2 code-file 更新在 qwen/kimi/xiaomi/opencodego 均成功，云端模型确实能改持久化规则旋钮。</a:t>
+              <a:t>multi-bus-memory 在 tap-only 游戏上接近 rule（0.296 vs 0.300），记忆读回对无 joystick 场景有价值。</a:t>
             </a:r>
           </a:p>
         </p:txBody>
@@ -13130,7 +13130,7 @@
               </a:defRPr>
             </a:pPr>
             <a:r>
-              <a:t>Gemma-4-E4B 视觉上下文让云端动作匹配从 3/9 提升到 5/9，本地 VLM 有潜力。</a:t>
+              <a:t>L2 code-file 更新在 qwen/kimi/xiaomi/opencodego 均成功，云端模型确实能改持久化规则旋钮。</a:t>
             </a:r>
           </a:p>
         </p:txBody>
@@ -13150,7 +13150,7 @@
             <a:avLst/>
           </a:prstGeom>
           <a:solidFill>
-            <a:srgbClr val="F4B400"/>
+            <a:srgbClr val="28A745"/>
           </a:solidFill>
           <a:ln/>
         </p:spPr>
@@ -13181,7 +13181,7 @@
               </a:defRPr>
             </a:pPr>
             <a:r>
-              <a:t>⚠️ 待优化</a:t>
+              <a:t>✅ 已修复</a:t>
             </a:r>
           </a:p>
         </p:txBody>
@@ -13217,7 +13217,7 @@
               </a:defRPr>
             </a:pPr>
             <a:r>
-              <a:t>OpenCodeGo / MiMo / Kimi 直接做 gameplay 动作时大量空返回或 fallback，云端不适合逐帧控制。</a:t>
+              <a:t>00483 multi-bus activity=0：根因是 strategy_memory 在线自强化，session 隔离后 multi-bus-memory 0.200、activity 0.333。</a:t>
             </a:r>
           </a:p>
         </p:txBody>
@@ -13304,7 +13304,7 @@
               </a:defRPr>
             </a:pPr>
             <a:r>
-              <a:t>SSD_00483P01 的 multi-bus activity=0，driver/profile 需要单独诊断。</a:t>
+              <a:t>multi-bus 在需要 joystick 的 A 组明显弱于 rule（mean 0.110），需要更强的 driver/Verifier 循环。</a:t>
             </a:r>
           </a:p>
         </p:txBody>
@@ -13903,7 +13903,7 @@
                         </a:defRPr>
                       </a:pPr>
                       <a:r>
-                        <a:t>0.300</a:t>
+                        <a:t>0.050</a:t>
                       </a:r>
                     </a:p>
                   </a:txBody>
@@ -13922,7 +13922,7 @@
                         </a:defRPr>
                       </a:pPr>
                       <a:r>
-                        <a:t>0.300</a:t>
+                        <a:t>0.044</a:t>
                       </a:r>
                     </a:p>
                   </a:txBody>
@@ -13981,7 +13981,7 @@
                         </a:defRPr>
                       </a:pPr>
                       <a:r>
-                        <a:t>0.184</a:t>
+                        <a:t>0.244</a:t>
                       </a:r>
                     </a:p>
                   </a:txBody>
@@ -14000,7 +14000,7 @@
                         </a:defRPr>
                       </a:pPr>
                       <a:r>
-                        <a:t>0.150</a:t>
+                        <a:t>0.103</a:t>
                       </a:r>
                     </a:p>
                   </a:txBody>
@@ -14019,7 +14019,7 @@
                         </a:defRPr>
                       </a:pPr>
                       <a:r>
-                        <a:t>0.150</a:t>
+                        <a:t>0.200</a:t>
                       </a:r>
                     </a:p>
                   </a:txBody>
@@ -14097,7 +14097,7 @@
                         </a:defRPr>
                       </a:pPr>
                       <a:r>
-                        <a:t>0.300</a:t>
+                        <a:t>0.178</a:t>
                       </a:r>
                     </a:p>
                   </a:txBody>
@@ -14116,7 +14116,7 @@
                         </a:defRPr>
                       </a:pPr>
                       <a:r>
-                        <a:t>0.300</a:t>
+                        <a:t>0.178</a:t>
                       </a:r>
                     </a:p>
                   </a:txBody>
@@ -14175,7 +14175,7 @@
                         </a:defRPr>
                       </a:pPr>
                       <a:r>
-                        <a:t>0.288</a:t>
+                        <a:t>0.300</a:t>
                       </a:r>
                     </a:p>
                   </a:txBody>
@@ -14213,7 +14213,7 @@
                         </a:defRPr>
                       </a:pPr>
                       <a:r>
-                        <a:t>0.300</a:t>
+                        <a:t>0.288</a:t>
                       </a:r>
                     </a:p>
                   </a:txBody>
@@ -14464,7 +14464,7 @@
               </a:defRPr>
             </a:pPr>
             <a:r>
-              <a:t>15 runs 全部成功，multi-bus-memory 综合 mean composite 0.275，activity 0.833。唯一例外 00483 需要 driver 诊断。</a:t>
+              <a:t>15 runs 全部成功。rule mean composite=0.251 仍是最稳基线；multi-bus-memory 在 tap-only 游戏接近 rule（0.296 vs 0.300）。session 隔离让 00483 从 activity=0 恢复到 0.333。</a:t>
             </a:r>
           </a:p>
         </p:txBody>
@@ -17930,6 +17930,22 @@
               <a:t>  探索 Agent 间更严格的仲裁：Critic 对 L0/L2 冲突做最终决策</a:t>
             </a:r>
           </a:p>
+          <a:p>
+            <a:pPr algn="l">
+              <a:spcAft>
+                <a:spcPts val="1200"/>
+              </a:spcAft>
+              <a:defRPr sz="1800" b="0">
+                <a:solidFill>
+                  <a:srgbClr val="1E2933"/>
+                </a:solidFill>
+                <a:latin typeface="Microsoft YaHei"/>
+              </a:defRPr>
+            </a:pPr>
+            <a:r>
+              <a:t>   redesign strategy_memory 的 success 信号：结合位置变化、guide 触发、stall 减少</a:t>
+            </a:r>
+          </a:p>
         </p:txBody>
       </p:sp>
       <p:sp>
@@ -18180,16 +18196,16 @@
       </p:sp>
       <p:sp>
         <p:nvSpPr>
-          <p:cNvPr id="13" name="Rectangle 12"/>
+          <p:cNvPr id="13" name="Oval 12"/>
           <p:cNvSpPr/>
           <p:nvPr/>
         </p:nvSpPr>
         <p:spPr>
           <a:xfrm>
-            <a:off x="0" y="6537960"/>
-            <a:ext cx="12191695" cy="18288"/>
-          </a:xfrm>
-          <a:prstGeom prst="rect">
+            <a:off x="45720" y="0"/>
+            <a:ext cx="137160" cy="137160"/>
+          </a:xfrm>
+          <a:prstGeom prst="ellipse">
             <a:avLst/>
           </a:prstGeom>
           <a:solidFill>
@@ -18221,7 +18237,48 @@
       </p:sp>
       <p:sp>
         <p:nvSpPr>
-          <p:cNvPr id="14" name="TextBox 13"/>
+          <p:cNvPr id="14" name="Rectangle 13"/>
+          <p:cNvSpPr/>
+          <p:nvPr/>
+        </p:nvSpPr>
+        <p:spPr>
+          <a:xfrm>
+            <a:off x="0" y="6537960"/>
+            <a:ext cx="12191695" cy="18288"/>
+          </a:xfrm>
+          <a:prstGeom prst="rect">
+            <a:avLst/>
+          </a:prstGeom>
+          <a:solidFill>
+            <a:srgbClr val="0096C7"/>
+          </a:solidFill>
+          <a:ln/>
+        </p:spPr>
+        <p:style>
+          <a:lnRef idx="1">
+            <a:schemeClr val="accent1"/>
+          </a:lnRef>
+          <a:fillRef idx="3">
+            <a:schemeClr val="accent1"/>
+          </a:fillRef>
+          <a:effectRef idx="2">
+            <a:schemeClr val="accent1"/>
+          </a:effectRef>
+          <a:fontRef idx="minor">
+            <a:schemeClr val="lt1"/>
+          </a:fontRef>
+        </p:style>
+        <p:txBody>
+          <a:bodyPr rtlCol="0" anchor="ctr"/>
+          <a:lstStyle/>
+          <a:p>
+            <a:pPr algn="ctr"/>
+          </a:p>
+        </p:txBody>
+      </p:sp>
+      <p:sp>
+        <p:nvSpPr>
+          <p:cNvPr id="15" name="TextBox 14"/>
           <p:cNvSpPr txBox="1"/>
           <p:nvPr/>
         </p:nvSpPr>
@@ -18257,7 +18314,7 @@
       </p:sp>
       <p:sp>
         <p:nvSpPr>
-          <p:cNvPr id="15" name="TextBox 14"/>
+          <p:cNvPr id="16" name="TextBox 15"/>
           <p:cNvSpPr txBox="1"/>
           <p:nvPr/>
         </p:nvSpPr>

</xml_diff>

<commit_message>
docs: add harness integration slide to PPT; verify QLoRA training pipeline
- New PPT slide: 同学框架集成（planner bridge / fixes / results & bottlenecks）
- Verified VLMColdStartDataset loads 2491 samples; training scripts syntax-valid
- Regenerate PDF/PPTX
</commit_message>
<xml_diff>
--- a/reports/smallgameagent_report.pptx
+++ b/reports/smallgameagent_report.pptx
@@ -44,6 +44,7 @@
     <p:sldId id="292" r:id="rId43"/>
     <p:sldId id="293" r:id="rId44"/>
     <p:sldId id="294" r:id="rId45"/>
+    <p:sldId id="295" r:id="rId46"/>
   </p:sldIdLst>
   <p:sldSz cx="12191695" cy="6858000" type="screen4x3"/>
   <p:notesSz cx="6858000" cy="9144000"/>
@@ -3852,7 +3853,7 @@
               </a:defRPr>
             </a:pPr>
             <a:r>
-              <a:t>10/39</a:t>
+              <a:t>10/40</a:t>
             </a:r>
           </a:p>
         </p:txBody>
@@ -4670,7 +4671,7 @@
               </a:defRPr>
             </a:pPr>
             <a:r>
-              <a:t>11/39</a:t>
+              <a:t>11/40</a:t>
             </a:r>
           </a:p>
         </p:txBody>
@@ -5067,7 +5068,7 @@
               </a:defRPr>
             </a:pPr>
             <a:r>
-              <a:t>12/39</a:t>
+              <a:t>12/40</a:t>
             </a:r>
           </a:p>
         </p:txBody>
@@ -5396,7 +5397,7 @@
               </a:defRPr>
             </a:pPr>
             <a:r>
-              <a:t>13/39</a:t>
+              <a:t>13/40</a:t>
             </a:r>
           </a:p>
         </p:txBody>
@@ -6187,7 +6188,7 @@
               </a:defRPr>
             </a:pPr>
             <a:r>
-              <a:t>14/39</a:t>
+              <a:t>14/40</a:t>
             </a:r>
           </a:p>
         </p:txBody>
@@ -7231,7 +7232,7 @@
               </a:defRPr>
             </a:pPr>
             <a:r>
-              <a:t>15/39</a:t>
+              <a:t>15/40</a:t>
             </a:r>
           </a:p>
         </p:txBody>
@@ -8530,7 +8531,7 @@
               </a:defRPr>
             </a:pPr>
             <a:r>
-              <a:t>16/39</a:t>
+              <a:t>16/40</a:t>
             </a:r>
           </a:p>
         </p:txBody>
@@ -9712,7 +9713,7 @@
               </a:defRPr>
             </a:pPr>
             <a:r>
-              <a:t>17/39</a:t>
+              <a:t>17/40</a:t>
             </a:r>
           </a:p>
         </p:txBody>
@@ -10109,7 +10110,7 @@
               </a:defRPr>
             </a:pPr>
             <a:r>
-              <a:t>18/39</a:t>
+              <a:t>18/40</a:t>
             </a:r>
           </a:p>
         </p:txBody>
@@ -10506,7 +10507,7 @@
               </a:defRPr>
             </a:pPr>
             <a:r>
-              <a:t>19/39</a:t>
+              <a:t>19/40</a:t>
             </a:r>
           </a:p>
         </p:txBody>
@@ -11379,7 +11380,7 @@
               </a:defRPr>
             </a:pPr>
             <a:r>
-              <a:t>2/39</a:t>
+              <a:t>2/40</a:t>
             </a:r>
           </a:p>
         </p:txBody>
@@ -11776,7 +11777,7 @@
               </a:defRPr>
             </a:pPr>
             <a:r>
-              <a:t>20/39</a:t>
+              <a:t>20/40</a:t>
             </a:r>
           </a:p>
         </p:txBody>
@@ -12105,7 +12106,7 @@
               </a:defRPr>
             </a:pPr>
             <a:r>
-              <a:t>21/39</a:t>
+              <a:t>21/40</a:t>
             </a:r>
           </a:p>
         </p:txBody>
@@ -13168,7 +13169,7 @@
               </a:defRPr>
             </a:pPr>
             <a:r>
-              <a:t>22/39</a:t>
+              <a:t>22/40</a:t>
             </a:r>
           </a:p>
         </p:txBody>
@@ -13946,7 +13947,7 @@
               </a:defRPr>
             </a:pPr>
             <a:r>
-              <a:t>23/39</a:t>
+              <a:t>23/40</a:t>
             </a:r>
           </a:p>
         </p:txBody>
@@ -14275,7 +14276,7 @@
               </a:defRPr>
             </a:pPr>
             <a:r>
-              <a:t>24/39</a:t>
+              <a:t>24/40</a:t>
             </a:r>
           </a:p>
         </p:txBody>
@@ -15155,7 +15156,7 @@
               </a:defRPr>
             </a:pPr>
             <a:r>
-              <a:t>25/39</a:t>
+              <a:t>25/40</a:t>
             </a:r>
           </a:p>
         </p:txBody>
@@ -15484,7 +15485,7 @@
               </a:defRPr>
             </a:pPr>
             <a:r>
-              <a:t>26/39</a:t>
+              <a:t>26/40</a:t>
             </a:r>
           </a:p>
         </p:txBody>
@@ -16302,7 +16303,7 @@
               </a:defRPr>
             </a:pPr>
             <a:r>
-              <a:t>27/39</a:t>
+              <a:t>27/40</a:t>
             </a:r>
           </a:p>
         </p:txBody>
@@ -16876,7 +16877,7 @@
               </a:defRPr>
             </a:pPr>
             <a:r>
-              <a:t>28/39</a:t>
+              <a:t>28/40</a:t>
             </a:r>
           </a:p>
         </p:txBody>
@@ -17692,7 +17693,7 @@
               </a:defRPr>
             </a:pPr>
             <a:r>
-              <a:t>29/39</a:t>
+              <a:t>29/40</a:t>
             </a:r>
           </a:p>
         </p:txBody>
@@ -18121,7 +18122,7 @@
               </a:defRPr>
             </a:pPr>
             <a:r>
-              <a:t>3/39</a:t>
+              <a:t>3/40</a:t>
             </a:r>
           </a:p>
         </p:txBody>
@@ -19194,7 +19195,7 @@
               </a:defRPr>
             </a:pPr>
             <a:r>
-              <a:t>30/39</a:t>
+              <a:t>30/40</a:t>
             </a:r>
           </a:p>
         </p:txBody>
@@ -20487,7 +20488,7 @@
               </a:defRPr>
             </a:pPr>
             <a:r>
-              <a:t>31/39</a:t>
+              <a:t>31/40</a:t>
             </a:r>
           </a:p>
         </p:txBody>
@@ -20816,7 +20817,7 @@
               </a:defRPr>
             </a:pPr>
             <a:r>
-              <a:t>32/39</a:t>
+              <a:t>32/40</a:t>
             </a:r>
           </a:p>
         </p:txBody>
@@ -21197,7 +21198,7 @@
               </a:defRPr>
             </a:pPr>
             <a:r>
-              <a:t>33/39</a:t>
+              <a:t>33/40</a:t>
             </a:r>
           </a:p>
         </p:txBody>
@@ -21755,7 +21756,7 @@
               </a:defRPr>
             </a:pPr>
             <a:r>
-              <a:t>34/39</a:t>
+              <a:t>34/40</a:t>
             </a:r>
           </a:p>
         </p:txBody>
@@ -22084,7 +22085,7 @@
               </a:defRPr>
             </a:pPr>
             <a:r>
-              <a:t>35/39</a:t>
+              <a:t>35/40</a:t>
             </a:r>
           </a:p>
         </p:txBody>
@@ -22179,7 +22180,7 @@
               </a:defRPr>
             </a:pPr>
             <a:r>
-              <a:t>技术路线图：从能跑到好用</a:t>
+              <a:t>同学框架集成：统一实验标准</a:t>
             </a:r>
           </a:p>
         </p:txBody>
@@ -22199,7 +22200,7 @@
             <a:avLst/>
           </a:prstGeom>
           <a:solidFill>
-            <a:srgbClr val="0096C7"/>
+            <a:srgbClr val="28A745"/>
           </a:solidFill>
           <a:ln/>
         </p:spPr>
@@ -22272,20 +22273,20 @@
       </p:sp>
       <p:sp>
         <p:nvSpPr>
-          <p:cNvPr id="6" name="Rectangle 5"/>
-          <p:cNvSpPr/>
-          <p:nvPr/>
-        </p:nvSpPr>
-        <p:spPr>
-          <a:xfrm>
-            <a:off x="777240" y="3200400"/>
-            <a:ext cx="10972800" cy="73152"/>
-          </a:xfrm>
-          <a:prstGeom prst="rect">
-            <a:avLst/>
-          </a:prstGeom>
-          <a:solidFill>
-            <a:srgbClr val="6C757D"/>
+          <p:cNvPr id="6" name="Rounded Rectangle 5"/>
+          <p:cNvSpPr/>
+          <p:nvPr/>
+        </p:nvSpPr>
+        <p:spPr>
+          <a:xfrm>
+            <a:off x="621792" y="1353312"/>
+            <a:ext cx="5486400" cy="2286000"/>
+          </a:xfrm>
+          <a:prstGeom prst="roundRect">
+            <a:avLst/>
+          </a:prstGeom>
+          <a:solidFill>
+            <a:srgbClr val="D0D5DA"/>
           </a:solidFill>
           <a:ln/>
         </p:spPr>
@@ -22313,20 +22314,65 @@
       </p:sp>
       <p:sp>
         <p:nvSpPr>
-          <p:cNvPr id="7" name="Oval 6"/>
-          <p:cNvSpPr/>
-          <p:nvPr/>
-        </p:nvSpPr>
-        <p:spPr>
-          <a:xfrm>
-            <a:off x="822960" y="3063240"/>
-            <a:ext cx="320040" cy="320040"/>
-          </a:xfrm>
-          <a:prstGeom prst="ellipse">
-            <a:avLst/>
-          </a:prstGeom>
-          <a:solidFill>
-            <a:srgbClr val="28A745"/>
+          <p:cNvPr id="7" name="Rounded Rectangle 6"/>
+          <p:cNvSpPr/>
+          <p:nvPr/>
+        </p:nvSpPr>
+        <p:spPr>
+          <a:xfrm>
+            <a:off x="594360" y="1325880"/>
+            <a:ext cx="5486400" cy="2286000"/>
+          </a:xfrm>
+          <a:prstGeom prst="roundRect">
+            <a:avLst/>
+          </a:prstGeom>
+          <a:solidFill>
+            <a:srgbClr val="FFFFFF"/>
+          </a:solidFill>
+          <a:ln w="12700">
+            <a:solidFill>
+              <a:srgbClr val="DDE2E6"/>
+            </a:solidFill>
+          </a:ln>
+        </p:spPr>
+        <p:style>
+          <a:lnRef idx="1">
+            <a:schemeClr val="accent1"/>
+          </a:lnRef>
+          <a:fillRef idx="3">
+            <a:schemeClr val="accent1"/>
+          </a:fillRef>
+          <a:effectRef idx="2">
+            <a:schemeClr val="accent1"/>
+          </a:effectRef>
+          <a:fontRef idx="minor">
+            <a:schemeClr val="lt1"/>
+          </a:fontRef>
+        </p:style>
+        <p:txBody>
+          <a:bodyPr rtlCol="0" anchor="ctr"/>
+          <a:lstStyle/>
+          <a:p>
+            <a:pPr algn="ctr"/>
+          </a:p>
+        </p:txBody>
+      </p:sp>
+      <p:sp>
+        <p:nvSpPr>
+          <p:cNvPr id="8" name="Rectangle 7"/>
+          <p:cNvSpPr/>
+          <p:nvPr/>
+        </p:nvSpPr>
+        <p:spPr>
+          <a:xfrm>
+            <a:off x="594360" y="1325880"/>
+            <a:ext cx="5486400" cy="411480"/>
+          </a:xfrm>
+          <a:prstGeom prst="rect">
+            <a:avLst/>
+          </a:prstGeom>
+          <a:solidFill>
+            <a:srgbClr val="0096C7"/>
           </a:solidFill>
           <a:ln/>
         </p:spPr>
@@ -22354,14 +22400,14 @@
       </p:sp>
       <p:sp>
         <p:nvSpPr>
-          <p:cNvPr id="8" name="TextBox 7"/>
+          <p:cNvPr id="9" name="TextBox 8"/>
           <p:cNvSpPr txBox="1"/>
           <p:nvPr/>
         </p:nvSpPr>
         <p:spPr>
           <a:xfrm>
-            <a:off x="320040" y="2103120"/>
-            <a:ext cx="1645920" cy="457200"/>
+            <a:off x="667512" y="1399032"/>
+            <a:ext cx="5340096" cy="320040"/>
           </a:xfrm>
           <a:prstGeom prst="rect">
             <a:avLst/>
@@ -22374,30 +22420,244 @@
           </a:bodyPr>
           <a:lstStyle/>
           <a:p>
-            <a:pPr algn="ctr">
-              <a:defRPr sz="1300" b="1">
-                <a:solidFill>
-                  <a:srgbClr val="28A745"/>
-                </a:solidFill>
-                <a:latin typeface="Microsoft YaHei"/>
-              </a:defRPr>
-            </a:pPr>
-            <a:r>
-              <a:t>已完成</a:t>
-            </a:r>
-          </a:p>
-        </p:txBody>
-      </p:sp>
-      <p:sp>
-        <p:nvSpPr>
-          <p:cNvPr id="9" name="TextBox 8"/>
+            <a:pPr algn="l">
+              <a:defRPr sz="1400" b="1">
+                <a:solidFill>
+                  <a:srgbClr val="F3F6F9"/>
+                </a:solidFill>
+                <a:latin typeface="Microsoft YaHei"/>
+              </a:defRPr>
+            </a:pPr>
+            <a:r>
+              <a:t>规划器桥接（planner-http-adapter）</a:t>
+            </a:r>
+          </a:p>
+        </p:txBody>
+      </p:sp>
+      <p:sp>
+        <p:nvSpPr>
+          <p:cNvPr id="10" name="TextBox 9"/>
           <p:cNvSpPr txBox="1"/>
           <p:nvPr/>
         </p:nvSpPr>
         <p:spPr>
           <a:xfrm>
-            <a:off x="91439" y="3474720"/>
-            <a:ext cx="2194560" cy="1188720"/>
+            <a:off x="704088" y="1828800"/>
+            <a:ext cx="5266944" cy="1691640"/>
+          </a:xfrm>
+          <a:prstGeom prst="rect">
+            <a:avLst/>
+          </a:prstGeom>
+          <a:noFill/>
+        </p:spPr>
+        <p:txBody>
+          <a:bodyPr wrap="square">
+            <a:spAutoFit/>
+          </a:bodyPr>
+          <a:lstStyle/>
+          <a:p>
+            <a:pPr algn="l">
+              <a:spcAft>
+                <a:spcPts val="500"/>
+              </a:spcAft>
+              <a:defRPr sz="1200" b="0">
+                <a:solidFill>
+                  <a:srgbClr val="1E2933"/>
+                </a:solidFill>
+                <a:latin typeface="Microsoft YaHei"/>
+              </a:defRPr>
+            </a:pPr>
+            <a:r>
+              <a:t>harness_http provider ↔ 我们的 Chat Completions API</a:t>
+            </a:r>
+          </a:p>
+          <a:p>
+            <a:pPr algn="l">
+              <a:spcAft>
+                <a:spcPts val="500"/>
+              </a:spcAft>
+              <a:defRPr sz="1200" b="0">
+                <a:solidFill>
+                  <a:srgbClr val="1E2933"/>
+                </a:solidFill>
+                <a:latin typeface="Microsoft YaHei"/>
+              </a:defRPr>
+            </a:pPr>
+            <a:r>
+              <a:t>deepseek-v4-flash / mimo-v2.5 / kimi-k2.7 / qwen3.7-max</a:t>
+            </a:r>
+          </a:p>
+          <a:p>
+            <a:pPr algn="l">
+              <a:spcAft>
+                <a:spcPts val="500"/>
+              </a:spcAft>
+              <a:defRPr sz="1200" b="0">
+                <a:solidFill>
+                  <a:srgbClr val="1E2933"/>
+                </a:solidFill>
+                <a:latin typeface="Microsoft YaHei"/>
+              </a:defRPr>
+            </a:pPr>
+            <a:r>
+              <a:t>kimi few-shot 可产出 schema 合规 StrategySpec（7-48s）</a:t>
+            </a:r>
+          </a:p>
+          <a:p>
+            <a:pPr algn="l">
+              <a:spcAft>
+                <a:spcPts val="500"/>
+              </a:spcAft>
+              <a:defRPr sz="1200" b="0">
+                <a:solidFill>
+                  <a:srgbClr val="1E2933"/>
+                </a:solidFill>
+                <a:latin typeface="Microsoft YaHei"/>
+              </a:defRPr>
+            </a:pPr>
+            <a:r>
+              <a:t>fallback-first 模式：0ms 返回确定性策略</a:t>
+            </a:r>
+          </a:p>
+        </p:txBody>
+      </p:sp>
+      <p:sp>
+        <p:nvSpPr>
+          <p:cNvPr id="11" name="Rounded Rectangle 10"/>
+          <p:cNvSpPr/>
+          <p:nvPr/>
+        </p:nvSpPr>
+        <p:spPr>
+          <a:xfrm>
+            <a:off x="6382512" y="1353312"/>
+            <a:ext cx="5486400" cy="2286000"/>
+          </a:xfrm>
+          <a:prstGeom prst="roundRect">
+            <a:avLst/>
+          </a:prstGeom>
+          <a:solidFill>
+            <a:srgbClr val="D0D5DA"/>
+          </a:solidFill>
+          <a:ln/>
+        </p:spPr>
+        <p:style>
+          <a:lnRef idx="1">
+            <a:schemeClr val="accent1"/>
+          </a:lnRef>
+          <a:fillRef idx="3">
+            <a:schemeClr val="accent1"/>
+          </a:fillRef>
+          <a:effectRef idx="2">
+            <a:schemeClr val="accent1"/>
+          </a:effectRef>
+          <a:fontRef idx="minor">
+            <a:schemeClr val="lt1"/>
+          </a:fontRef>
+        </p:style>
+        <p:txBody>
+          <a:bodyPr rtlCol="0" anchor="ctr"/>
+          <a:lstStyle/>
+          <a:p>
+            <a:pPr algn="ctr"/>
+          </a:p>
+        </p:txBody>
+      </p:sp>
+      <p:sp>
+        <p:nvSpPr>
+          <p:cNvPr id="12" name="Rounded Rectangle 11"/>
+          <p:cNvSpPr/>
+          <p:nvPr/>
+        </p:nvSpPr>
+        <p:spPr>
+          <a:xfrm>
+            <a:off x="6355080" y="1325880"/>
+            <a:ext cx="5486400" cy="2286000"/>
+          </a:xfrm>
+          <a:prstGeom prst="roundRect">
+            <a:avLst/>
+          </a:prstGeom>
+          <a:solidFill>
+            <a:srgbClr val="FFFFFF"/>
+          </a:solidFill>
+          <a:ln w="12700">
+            <a:solidFill>
+              <a:srgbClr val="DDE2E6"/>
+            </a:solidFill>
+          </a:ln>
+        </p:spPr>
+        <p:style>
+          <a:lnRef idx="1">
+            <a:schemeClr val="accent1"/>
+          </a:lnRef>
+          <a:fillRef idx="3">
+            <a:schemeClr val="accent1"/>
+          </a:fillRef>
+          <a:effectRef idx="2">
+            <a:schemeClr val="accent1"/>
+          </a:effectRef>
+          <a:fontRef idx="minor">
+            <a:schemeClr val="lt1"/>
+          </a:fontRef>
+        </p:style>
+        <p:txBody>
+          <a:bodyPr rtlCol="0" anchor="ctr"/>
+          <a:lstStyle/>
+          <a:p>
+            <a:pPr algn="ctr"/>
+          </a:p>
+        </p:txBody>
+      </p:sp>
+      <p:sp>
+        <p:nvSpPr>
+          <p:cNvPr id="13" name="Rectangle 12"/>
+          <p:cNvSpPr/>
+          <p:nvPr/>
+        </p:nvSpPr>
+        <p:spPr>
+          <a:xfrm>
+            <a:off x="6355080" y="1325880"/>
+            <a:ext cx="5486400" cy="411480"/>
+          </a:xfrm>
+          <a:prstGeom prst="rect">
+            <a:avLst/>
+          </a:prstGeom>
+          <a:solidFill>
+            <a:srgbClr val="28A745"/>
+          </a:solidFill>
+          <a:ln/>
+        </p:spPr>
+        <p:style>
+          <a:lnRef idx="1">
+            <a:schemeClr val="accent1"/>
+          </a:lnRef>
+          <a:fillRef idx="3">
+            <a:schemeClr val="accent1"/>
+          </a:fillRef>
+          <a:effectRef idx="2">
+            <a:schemeClr val="accent1"/>
+          </a:effectRef>
+          <a:fontRef idx="minor">
+            <a:schemeClr val="lt1"/>
+          </a:fontRef>
+        </p:style>
+        <p:txBody>
+          <a:bodyPr rtlCol="0" anchor="ctr"/>
+          <a:lstStyle/>
+          <a:p>
+            <a:pPr algn="ctr"/>
+          </a:p>
+        </p:txBody>
+      </p:sp>
+      <p:sp>
+        <p:nvSpPr>
+          <p:cNvPr id="14" name="TextBox 13"/>
+          <p:cNvSpPr txBox="1"/>
+          <p:nvPr/>
+        </p:nvSpPr>
+        <p:spPr>
+          <a:xfrm>
+            <a:off x="6428232" y="1399032"/>
+            <a:ext cx="5340096" cy="320040"/>
           </a:xfrm>
           <a:prstGeom prst="rect">
             <a:avLst/>
@@ -22410,7 +22670,46 @@
           </a:bodyPr>
           <a:lstStyle/>
           <a:p>
-            <a:pPr algn="ctr">
+            <a:pPr algn="l">
+              <a:defRPr sz="1400" b="1">
+                <a:solidFill>
+                  <a:srgbClr val="F3F6F9"/>
+                </a:solidFill>
+                <a:latin typeface="Microsoft YaHei"/>
+              </a:defRPr>
+            </a:pPr>
+            <a:r>
+              <a:t>已解决的工程问题</a:t>
+            </a:r>
+          </a:p>
+        </p:txBody>
+      </p:sp>
+      <p:sp>
+        <p:nvSpPr>
+          <p:cNvPr id="15" name="TextBox 14"/>
+          <p:cNvSpPr txBox="1"/>
+          <p:nvPr/>
+        </p:nvSpPr>
+        <p:spPr>
+          <a:xfrm>
+            <a:off x="6464808" y="1828800"/>
+            <a:ext cx="5266944" cy="1691640"/>
+          </a:xfrm>
+          <a:prstGeom prst="rect">
+            <a:avLst/>
+          </a:prstGeom>
+          <a:noFill/>
+        </p:spPr>
+        <p:txBody>
+          <a:bodyPr wrap="square">
+            <a:spAutoFit/>
+          </a:bodyPr>
+          <a:lstStyle/>
+          <a:p>
+            <a:pPr algn="l">
+              <a:spcAft>
+                <a:spcPts val="500"/>
+              </a:spcAft>
               <a:defRPr sz="1200" b="0">
                 <a:solidFill>
                   <a:srgbClr val="1E2933"/>
@@ -22419,31 +22718,75 @@
               </a:defRPr>
             </a:pPr>
             <a:r>
-              <a:t>规则引擎 + 自动校准</a:t>
-            </a:r>
-            <a:br/>
-            <a:r>
-              <a:t>22 游戏可驱动</a:t>
-            </a:r>
-          </a:p>
-        </p:txBody>
-      </p:sp>
-      <p:sp>
-        <p:nvSpPr>
-          <p:cNvPr id="10" name="Oval 9"/>
-          <p:cNvSpPr/>
-          <p:nvPr/>
-        </p:nvSpPr>
-        <p:spPr>
-          <a:xfrm>
-            <a:off x="3108960" y="3063240"/>
-            <a:ext cx="320040" cy="320040"/>
-          </a:xfrm>
-          <a:prstGeom prst="ellipse">
-            <a:avLst/>
-          </a:prstGeom>
-          <a:solidFill>
-            <a:srgbClr val="28A745"/>
+              <a:t>WSL WebGL：headful + xvfb + swiftshader 标志</a:t>
+            </a:r>
+          </a:p>
+          <a:p>
+            <a:pPr algn="l">
+              <a:spcAft>
+                <a:spcPts val="500"/>
+              </a:spcAft>
+              <a:defRPr sz="1200" b="0">
+                <a:solidFill>
+                  <a:srgbClr val="1E2933"/>
+                </a:solidFill>
+                <a:latin typeface="Microsoft YaHei"/>
+              </a:defRPr>
+            </a:pPr>
+            <a:r>
+              <a:t>probe 假阳性：download/ad 按钮不再误判通关（§5.2 移植）</a:t>
+            </a:r>
+          </a:p>
+          <a:p>
+            <a:pPr algn="l">
+              <a:spcAft>
+                <a:spcPts val="500"/>
+              </a:spcAft>
+              <a:defRPr sz="1200" b="0">
+                <a:solidFill>
+                  <a:srgbClr val="1E2933"/>
+                </a:solidFill>
+                <a:latin typeface="Microsoft YaHei"/>
+              </a:defRPr>
+            </a:pPr>
+            <a:r>
+              <a:t>objective unresolved：无 guide 时用 target_id</a:t>
+            </a:r>
+          </a:p>
+          <a:p>
+            <a:pPr algn="l">
+              <a:spcAft>
+                <a:spcPts val="500"/>
+              </a:spcAft>
+              <a:defRPr sz="1200" b="0">
+                <a:solidFill>
+                  <a:srgbClr val="1E2933"/>
+                </a:solidFill>
+                <a:latin typeface="Microsoft YaHei"/>
+              </a:defRPr>
+            </a:pPr>
+            <a:r>
+              <a:t>代理网络：NODE_USE_ENV_PROXY=1 走 clash</a:t>
+            </a:r>
+          </a:p>
+        </p:txBody>
+      </p:sp>
+      <p:sp>
+        <p:nvSpPr>
+          <p:cNvPr id="16" name="Rounded Rectangle 15"/>
+          <p:cNvSpPr/>
+          <p:nvPr/>
+        </p:nvSpPr>
+        <p:spPr>
+          <a:xfrm>
+            <a:off x="621792" y="3822192"/>
+            <a:ext cx="11247120" cy="2194560"/>
+          </a:xfrm>
+          <a:prstGeom prst="roundRect">
+            <a:avLst/>
+          </a:prstGeom>
+          <a:solidFill>
+            <a:srgbClr val="D0D5DA"/>
           </a:solidFill>
           <a:ln/>
         </p:spPr>
@@ -22471,14 +22814,100 @@
       </p:sp>
       <p:sp>
         <p:nvSpPr>
-          <p:cNvPr id="11" name="TextBox 10"/>
+          <p:cNvPr id="17" name="Rounded Rectangle 16"/>
+          <p:cNvSpPr/>
+          <p:nvPr/>
+        </p:nvSpPr>
+        <p:spPr>
+          <a:xfrm>
+            <a:off x="594360" y="3794760"/>
+            <a:ext cx="11247120" cy="2194560"/>
+          </a:xfrm>
+          <a:prstGeom prst="roundRect">
+            <a:avLst/>
+          </a:prstGeom>
+          <a:solidFill>
+            <a:srgbClr val="FFFFFF"/>
+          </a:solidFill>
+          <a:ln w="12700">
+            <a:solidFill>
+              <a:srgbClr val="DDE2E6"/>
+            </a:solidFill>
+          </a:ln>
+        </p:spPr>
+        <p:style>
+          <a:lnRef idx="1">
+            <a:schemeClr val="accent1"/>
+          </a:lnRef>
+          <a:fillRef idx="3">
+            <a:schemeClr val="accent1"/>
+          </a:fillRef>
+          <a:effectRef idx="2">
+            <a:schemeClr val="accent1"/>
+          </a:effectRef>
+          <a:fontRef idx="minor">
+            <a:schemeClr val="lt1"/>
+          </a:fontRef>
+        </p:style>
+        <p:txBody>
+          <a:bodyPr rtlCol="0" anchor="ctr"/>
+          <a:lstStyle/>
+          <a:p>
+            <a:pPr algn="ctr"/>
+          </a:p>
+        </p:txBody>
+      </p:sp>
+      <p:sp>
+        <p:nvSpPr>
+          <p:cNvPr id="18" name="Rectangle 17"/>
+          <p:cNvSpPr/>
+          <p:nvPr/>
+        </p:nvSpPr>
+        <p:spPr>
+          <a:xfrm>
+            <a:off x="594360" y="3794760"/>
+            <a:ext cx="11247120" cy="411480"/>
+          </a:xfrm>
+          <a:prstGeom prst="rect">
+            <a:avLst/>
+          </a:prstGeom>
+          <a:solidFill>
+            <a:srgbClr val="FF6B35"/>
+          </a:solidFill>
+          <a:ln/>
+        </p:spPr>
+        <p:style>
+          <a:lnRef idx="1">
+            <a:schemeClr val="accent1"/>
+          </a:lnRef>
+          <a:fillRef idx="3">
+            <a:schemeClr val="accent1"/>
+          </a:fillRef>
+          <a:effectRef idx="2">
+            <a:schemeClr val="accent1"/>
+          </a:effectRef>
+          <a:fontRef idx="minor">
+            <a:schemeClr val="lt1"/>
+          </a:fontRef>
+        </p:style>
+        <p:txBody>
+          <a:bodyPr rtlCol="0" anchor="ctr"/>
+          <a:lstStyle/>
+          <a:p>
+            <a:pPr algn="ctr"/>
+          </a:p>
+        </p:txBody>
+      </p:sp>
+      <p:sp>
+        <p:nvSpPr>
+          <p:cNvPr id="19" name="TextBox 18"/>
           <p:cNvSpPr txBox="1"/>
           <p:nvPr/>
         </p:nvSpPr>
         <p:spPr>
           <a:xfrm>
-            <a:off x="2606039" y="2103120"/>
-            <a:ext cx="1645920" cy="457200"/>
+            <a:off x="667512" y="3867912"/>
+            <a:ext cx="11100816" cy="320040"/>
           </a:xfrm>
           <a:prstGeom prst="rect">
             <a:avLst/>
@@ -22491,30 +22920,158 @@
           </a:bodyPr>
           <a:lstStyle/>
           <a:p>
-            <a:pPr algn="ctr">
-              <a:defRPr sz="1300" b="1">
-                <a:solidFill>
-                  <a:srgbClr val="28A745"/>
-                </a:solidFill>
-                <a:latin typeface="Microsoft YaHei"/>
-              </a:defRPr>
-            </a:pPr>
-            <a:r>
-              <a:t>已完成</a:t>
-            </a:r>
-          </a:p>
-        </p:txBody>
-      </p:sp>
-      <p:sp>
-        <p:nvSpPr>
-          <p:cNvPr id="12" name="TextBox 11"/>
+            <a:pPr algn="l">
+              <a:defRPr sz="1400" b="1">
+                <a:solidFill>
+                  <a:srgbClr val="F3F6F9"/>
+                </a:solidFill>
+                <a:latin typeface="Microsoft YaHei"/>
+              </a:defRPr>
+            </a:pPr>
+            <a:r>
+              <a:t>运行结果与瓶颈</a:t>
+            </a:r>
+          </a:p>
+        </p:txBody>
+      </p:sp>
+      <p:sp>
+        <p:nvSpPr>
+          <p:cNvPr id="20" name="TextBox 19"/>
           <p:cNvSpPr txBox="1"/>
           <p:nvPr/>
         </p:nvSpPr>
         <p:spPr>
           <a:xfrm>
-            <a:off x="2377439" y="3474720"/>
-            <a:ext cx="2194560" cy="1188720"/>
+            <a:off x="704088" y="4297680"/>
+            <a:ext cx="11027664" cy="1600200"/>
+          </a:xfrm>
+          <a:prstGeom prst="rect">
+            <a:avLst/>
+          </a:prstGeom>
+          <a:noFill/>
+        </p:spPr>
+        <p:txBody>
+          <a:bodyPr wrap="square">
+            <a:spAutoFit/>
+          </a:bodyPr>
+          <a:lstStyle/>
+          <a:p>
+            <a:pPr algn="l">
+              <a:spcAft>
+                <a:spcPts val="500"/>
+              </a:spcAft>
+              <a:defRPr sz="1200" b="0">
+                <a:solidFill>
+                  <a:srgbClr val="1E2933"/>
+                </a:solidFill>
+                <a:latin typeface="Microsoft YaHei"/>
+              </a:defRPr>
+            </a:pPr>
+            <a:r>
+              <a:t>tiles-survive：可玩 3-4 步，joystick 校准被游戏特殊控制卡住（同学 Codex 用 1h17m 探索）</a:t>
+            </a:r>
+          </a:p>
+          <a:p>
+            <a:pPr algn="l">
+              <a:spcAft>
+                <a:spcPts val="500"/>
+              </a:spcAft>
+              <a:defRPr sz="1200" b="0">
+                <a:solidFill>
+                  <a:srgbClr val="1E2933"/>
+                </a:solidFill>
+                <a:latin typeface="Microsoft YaHei"/>
+              </a:defRPr>
+            </a:pPr>
+            <a:r>
+              <a:t>whiteout 商店：SETTLED_COMPLETE 假阳性已修复 → BLOCKED_UNKNOWN_MECHANIC（诚实信号）</a:t>
+            </a:r>
+          </a:p>
+          <a:p>
+            <a:pPr algn="l">
+              <a:spcAft>
+                <a:spcPts val="500"/>
+              </a:spcAft>
+              <a:defRPr sz="1200" b="0">
+                <a:solidFill>
+                  <a:srgbClr val="1E2933"/>
+                </a:solidFill>
+                <a:latin typeface="Microsoft YaHei"/>
+              </a:defRPr>
+            </a:pPr>
+            <a:r>
+              <a:t>瓶颈：模型 schema 遵循度（fallback 兜底）+ 每游戏控制知识 + WSL 软件渲染不稳定</a:t>
+            </a:r>
+          </a:p>
+          <a:p>
+            <a:pPr algn="l">
+              <a:spcAft>
+                <a:spcPts val="500"/>
+              </a:spcAft>
+              <a:defRPr sz="1200" b="0">
+                <a:solidFill>
+                  <a:srgbClr val="1E2933"/>
+                </a:solidFill>
+                <a:latin typeface="Microsoft YaHei"/>
+              </a:defRPr>
+            </a:pPr>
+            <a:r>
+              <a:t>25+25 游戏清单已筛选交付（指引箭头 + 通关画面 + 广告图标验证）</a:t>
+            </a:r>
+          </a:p>
+        </p:txBody>
+      </p:sp>
+      <p:sp>
+        <p:nvSpPr>
+          <p:cNvPr id="21" name="Rectangle 20"/>
+          <p:cNvSpPr/>
+          <p:nvPr/>
+        </p:nvSpPr>
+        <p:spPr>
+          <a:xfrm>
+            <a:off x="0" y="6537960"/>
+            <a:ext cx="12191695" cy="18288"/>
+          </a:xfrm>
+          <a:prstGeom prst="rect">
+            <a:avLst/>
+          </a:prstGeom>
+          <a:solidFill>
+            <a:srgbClr val="0096C7"/>
+          </a:solidFill>
+          <a:ln/>
+        </p:spPr>
+        <p:style>
+          <a:lnRef idx="1">
+            <a:schemeClr val="accent1"/>
+          </a:lnRef>
+          <a:fillRef idx="3">
+            <a:schemeClr val="accent1"/>
+          </a:fillRef>
+          <a:effectRef idx="2">
+            <a:schemeClr val="accent1"/>
+          </a:effectRef>
+          <a:fontRef idx="minor">
+            <a:schemeClr val="lt1"/>
+          </a:fontRef>
+        </p:style>
+        <p:txBody>
+          <a:bodyPr rtlCol="0" anchor="ctr"/>
+          <a:lstStyle/>
+          <a:p>
+            <a:pPr algn="ctr"/>
+          </a:p>
+        </p:txBody>
+      </p:sp>
+      <p:sp>
+        <p:nvSpPr>
+          <p:cNvPr id="22" name="TextBox 21"/>
+          <p:cNvSpPr txBox="1"/>
+          <p:nvPr/>
+        </p:nvSpPr>
+        <p:spPr>
+          <a:xfrm>
+            <a:off x="457200" y="6583680"/>
+            <a:ext cx="3657600" cy="228600"/>
           </a:xfrm>
           <a:prstGeom prst="rect">
             <a:avLst/>
@@ -22527,75 +23084,30 @@
           </a:bodyPr>
           <a:lstStyle/>
           <a:p>
-            <a:pPr algn="ctr">
-              <a:defRPr sz="1200" b="0">
-                <a:solidFill>
-                  <a:srgbClr val="1E2933"/>
-                </a:solidFill>
-                <a:latin typeface="Microsoft YaHei"/>
-              </a:defRPr>
-            </a:pPr>
-            <a:r>
-              <a:t>multi-bus-memory</a:t>
-            </a:r>
-            <a:br/>
-            <a:r>
-              <a:t>记忆读回 0.300</a:t>
-            </a:r>
-          </a:p>
-        </p:txBody>
-      </p:sp>
-      <p:sp>
-        <p:nvSpPr>
-          <p:cNvPr id="13" name="Oval 12"/>
-          <p:cNvSpPr/>
-          <p:nvPr/>
-        </p:nvSpPr>
-        <p:spPr>
-          <a:xfrm>
-            <a:off x="5394960" y="3063240"/>
-            <a:ext cx="320040" cy="320040"/>
-          </a:xfrm>
-          <a:prstGeom prst="ellipse">
-            <a:avLst/>
-          </a:prstGeom>
-          <a:solidFill>
-            <a:srgbClr val="28A745"/>
-          </a:solidFill>
-          <a:ln/>
-        </p:spPr>
-        <p:style>
-          <a:lnRef idx="1">
-            <a:schemeClr val="accent1"/>
-          </a:lnRef>
-          <a:fillRef idx="3">
-            <a:schemeClr val="accent1"/>
-          </a:fillRef>
-          <a:effectRef idx="2">
-            <a:schemeClr val="accent1"/>
-          </a:effectRef>
-          <a:fontRef idx="minor">
-            <a:schemeClr val="lt1"/>
-          </a:fontRef>
-        </p:style>
-        <p:txBody>
-          <a:bodyPr rtlCol="0" anchor="ctr"/>
-          <a:lstStyle/>
-          <a:p>
-            <a:pPr algn="ctr"/>
-          </a:p>
-        </p:txBody>
-      </p:sp>
-      <p:sp>
-        <p:nvSpPr>
-          <p:cNvPr id="14" name="TextBox 13"/>
+            <a:pPr algn="l">
+              <a:defRPr sz="1000" b="0">
+                <a:solidFill>
+                  <a:srgbClr val="6C757D"/>
+                </a:solidFill>
+                <a:latin typeface="Microsoft YaHei"/>
+              </a:defRPr>
+            </a:pPr>
+            <a:r>
+              <a:t>smallgameagent · LLM/VLM + 规则驱动</a:t>
+            </a:r>
+          </a:p>
+        </p:txBody>
+      </p:sp>
+      <p:sp>
+        <p:nvSpPr>
+          <p:cNvPr id="23" name="TextBox 22"/>
           <p:cNvSpPr txBox="1"/>
           <p:nvPr/>
         </p:nvSpPr>
         <p:spPr>
           <a:xfrm>
-            <a:off x="4892040" y="2103120"/>
-            <a:ext cx="1645920" cy="457200"/>
+            <a:off x="10789920" y="6583680"/>
+            <a:ext cx="914400" cy="228600"/>
           </a:xfrm>
           <a:prstGeom prst="rect">
             <a:avLst/>
@@ -22608,444 +23120,6 @@
           </a:bodyPr>
           <a:lstStyle/>
           <a:p>
-            <a:pPr algn="ctr">
-              <a:defRPr sz="1300" b="1">
-                <a:solidFill>
-                  <a:srgbClr val="28A745"/>
-                </a:solidFill>
-                <a:latin typeface="Microsoft YaHei"/>
-              </a:defRPr>
-            </a:pPr>
-            <a:r>
-              <a:t>已完成</a:t>
-            </a:r>
-          </a:p>
-        </p:txBody>
-      </p:sp>
-      <p:sp>
-        <p:nvSpPr>
-          <p:cNvPr id="15" name="TextBox 14"/>
-          <p:cNvSpPr txBox="1"/>
-          <p:nvPr/>
-        </p:nvSpPr>
-        <p:spPr>
-          <a:xfrm>
-            <a:off x="4663440" y="3474720"/>
-            <a:ext cx="2194560" cy="1188720"/>
-          </a:xfrm>
-          <a:prstGeom prst="rect">
-            <a:avLst/>
-          </a:prstGeom>
-          <a:noFill/>
-        </p:spPr>
-        <p:txBody>
-          <a:bodyPr wrap="none">
-            <a:spAutoFit/>
-          </a:bodyPr>
-          <a:lstStyle/>
-          <a:p>
-            <a:pPr algn="ctr">
-              <a:defRPr sz="1200" b="0">
-                <a:solidFill>
-                  <a:srgbClr val="1E2933"/>
-                </a:solidFill>
-                <a:latin typeface="Microsoft YaHei"/>
-              </a:defRPr>
-            </a:pPr>
-            <a:r>
-              <a:t>L2 code-file 更新</a:t>
-            </a:r>
-            <a:br/>
-            <a:r>
-              <a:t>qwen/kimi/xiaomi/opencodego 验证</a:t>
-            </a:r>
-          </a:p>
-        </p:txBody>
-      </p:sp>
-      <p:sp>
-        <p:nvSpPr>
-          <p:cNvPr id="16" name="Oval 15"/>
-          <p:cNvSpPr/>
-          <p:nvPr/>
-        </p:nvSpPr>
-        <p:spPr>
-          <a:xfrm>
-            <a:off x="7680960" y="3063240"/>
-            <a:ext cx="320040" cy="320040"/>
-          </a:xfrm>
-          <a:prstGeom prst="ellipse">
-            <a:avLst/>
-          </a:prstGeom>
-          <a:solidFill>
-            <a:srgbClr val="FF6B35"/>
-          </a:solidFill>
-          <a:ln/>
-        </p:spPr>
-        <p:style>
-          <a:lnRef idx="1">
-            <a:schemeClr val="accent1"/>
-          </a:lnRef>
-          <a:fillRef idx="3">
-            <a:schemeClr val="accent1"/>
-          </a:fillRef>
-          <a:effectRef idx="2">
-            <a:schemeClr val="accent1"/>
-          </a:effectRef>
-          <a:fontRef idx="minor">
-            <a:schemeClr val="lt1"/>
-          </a:fontRef>
-        </p:style>
-        <p:txBody>
-          <a:bodyPr rtlCol="0" anchor="ctr"/>
-          <a:lstStyle/>
-          <a:p>
-            <a:pPr algn="ctr"/>
-          </a:p>
-        </p:txBody>
-      </p:sp>
-      <p:sp>
-        <p:nvSpPr>
-          <p:cNvPr id="17" name="TextBox 16"/>
-          <p:cNvSpPr txBox="1"/>
-          <p:nvPr/>
-        </p:nvSpPr>
-        <p:spPr>
-          <a:xfrm>
-            <a:off x="7178040" y="2103120"/>
-            <a:ext cx="1645920" cy="457200"/>
-          </a:xfrm>
-          <a:prstGeom prst="rect">
-            <a:avLst/>
-          </a:prstGeom>
-          <a:noFill/>
-        </p:spPr>
-        <p:txBody>
-          <a:bodyPr wrap="none">
-            <a:spAutoFit/>
-          </a:bodyPr>
-          <a:lstStyle/>
-          <a:p>
-            <a:pPr algn="ctr">
-              <a:defRPr sz="1300" b="1">
-                <a:solidFill>
-                  <a:srgbClr val="FF6B35"/>
-                </a:solidFill>
-                <a:latin typeface="Microsoft YaHei"/>
-              </a:defRPr>
-            </a:pPr>
-            <a:r>
-              <a:t>进行中</a:t>
-            </a:r>
-          </a:p>
-        </p:txBody>
-      </p:sp>
-      <p:sp>
-        <p:nvSpPr>
-          <p:cNvPr id="18" name="TextBox 17"/>
-          <p:cNvSpPr txBox="1"/>
-          <p:nvPr/>
-        </p:nvSpPr>
-        <p:spPr>
-          <a:xfrm>
-            <a:off x="6949440" y="3474720"/>
-            <a:ext cx="2194560" cy="1188720"/>
-          </a:xfrm>
-          <a:prstGeom prst="rect">
-            <a:avLst/>
-          </a:prstGeom>
-          <a:noFill/>
-        </p:spPr>
-        <p:txBody>
-          <a:bodyPr wrap="none">
-            <a:spAutoFit/>
-          </a:bodyPr>
-          <a:lstStyle/>
-          <a:p>
-            <a:pPr algn="ctr">
-              <a:defRPr sz="1200" b="0">
-                <a:solidFill>
-                  <a:srgbClr val="1E2933"/>
-                </a:solidFill>
-                <a:latin typeface="Microsoft YaHei"/>
-              </a:defRPr>
-            </a:pPr>
-            <a:r>
-              <a:t>本地 VLM 上下文</a:t>
-            </a:r>
-            <a:br/>
-            <a:r>
-              <a:t>QLoRA 微调准备</a:t>
-            </a:r>
-          </a:p>
-        </p:txBody>
-      </p:sp>
-      <p:sp>
-        <p:nvSpPr>
-          <p:cNvPr id="19" name="Oval 18"/>
-          <p:cNvSpPr/>
-          <p:nvPr/>
-        </p:nvSpPr>
-        <p:spPr>
-          <a:xfrm>
-            <a:off x="9966960" y="3063240"/>
-            <a:ext cx="320040" cy="320040"/>
-          </a:xfrm>
-          <a:prstGeom prst="ellipse">
-            <a:avLst/>
-          </a:prstGeom>
-          <a:solidFill>
-            <a:srgbClr val="0096C7"/>
-          </a:solidFill>
-          <a:ln/>
-        </p:spPr>
-        <p:style>
-          <a:lnRef idx="1">
-            <a:schemeClr val="accent1"/>
-          </a:lnRef>
-          <a:fillRef idx="3">
-            <a:schemeClr val="accent1"/>
-          </a:fillRef>
-          <a:effectRef idx="2">
-            <a:schemeClr val="accent1"/>
-          </a:effectRef>
-          <a:fontRef idx="minor">
-            <a:schemeClr val="lt1"/>
-          </a:fontRef>
-        </p:style>
-        <p:txBody>
-          <a:bodyPr rtlCol="0" anchor="ctr"/>
-          <a:lstStyle/>
-          <a:p>
-            <a:pPr algn="ctr"/>
-          </a:p>
-        </p:txBody>
-      </p:sp>
-      <p:sp>
-        <p:nvSpPr>
-          <p:cNvPr id="20" name="TextBox 19"/>
-          <p:cNvSpPr txBox="1"/>
-          <p:nvPr/>
-        </p:nvSpPr>
-        <p:spPr>
-          <a:xfrm>
-            <a:off x="9464040" y="2103120"/>
-            <a:ext cx="1645920" cy="457200"/>
-          </a:xfrm>
-          <a:prstGeom prst="rect">
-            <a:avLst/>
-          </a:prstGeom>
-          <a:noFill/>
-        </p:spPr>
-        <p:txBody>
-          <a:bodyPr wrap="none">
-            <a:spAutoFit/>
-          </a:bodyPr>
-          <a:lstStyle/>
-          <a:p>
-            <a:pPr algn="ctr">
-              <a:defRPr sz="1300" b="1">
-                <a:solidFill>
-                  <a:srgbClr val="0096C7"/>
-                </a:solidFill>
-                <a:latin typeface="Microsoft YaHei"/>
-              </a:defRPr>
-            </a:pPr>
-            <a:r>
-              <a:t>下一步</a:t>
-            </a:r>
-          </a:p>
-        </p:txBody>
-      </p:sp>
-      <p:sp>
-        <p:nvSpPr>
-          <p:cNvPr id="21" name="TextBox 20"/>
-          <p:cNvSpPr txBox="1"/>
-          <p:nvPr/>
-        </p:nvSpPr>
-        <p:spPr>
-          <a:xfrm>
-            <a:off x="9235440" y="3474720"/>
-            <a:ext cx="2194560" cy="1188720"/>
-          </a:xfrm>
-          <a:prstGeom prst="rect">
-            <a:avLst/>
-          </a:prstGeom>
-          <a:noFill/>
-        </p:spPr>
-        <p:txBody>
-          <a:bodyPr wrap="none">
-            <a:spAutoFit/>
-          </a:bodyPr>
-          <a:lstStyle/>
-          <a:p>
-            <a:pPr algn="ctr">
-              <a:defRPr sz="1200" b="0">
-                <a:solidFill>
-                  <a:srgbClr val="1E2933"/>
-                </a:solidFill>
-                <a:latin typeface="Microsoft YaHei"/>
-              </a:defRPr>
-            </a:pPr>
-            <a:r>
-              <a:t>真实游戏在线触发</a:t>
-            </a:r>
-            <a:br/>
-            <a:r>
-              <a:t>规则更新 + A/B 回归</a:t>
-            </a:r>
-          </a:p>
-        </p:txBody>
-      </p:sp>
-      <p:sp>
-        <p:nvSpPr>
-          <p:cNvPr id="22" name="Rounded Rectangle 21"/>
-          <p:cNvSpPr/>
-          <p:nvPr/>
-        </p:nvSpPr>
-        <p:spPr>
-          <a:xfrm>
-            <a:off x="777240" y="5074920"/>
-            <a:ext cx="10972800" cy="822960"/>
-          </a:xfrm>
-          <a:prstGeom prst="roundRect">
-            <a:avLst/>
-          </a:prstGeom>
-          <a:solidFill>
-            <a:srgbClr val="F3F6F9"/>
-          </a:solidFill>
-          <a:ln/>
-        </p:spPr>
-        <p:style>
-          <a:lnRef idx="1">
-            <a:schemeClr val="accent1"/>
-          </a:lnRef>
-          <a:fillRef idx="3">
-            <a:schemeClr val="accent1"/>
-          </a:fillRef>
-          <a:effectRef idx="2">
-            <a:schemeClr val="accent1"/>
-          </a:effectRef>
-          <a:fontRef idx="minor">
-            <a:schemeClr val="lt1"/>
-          </a:fontRef>
-        </p:style>
-        <p:txBody>
-          <a:bodyPr rtlCol="0" anchor="ctr"/>
-          <a:lstStyle/>
-          <a:p>
-            <a:pPr algn="ctr">
-              <a:defRPr sz="1400" b="0">
-                <a:solidFill>
-                  <a:srgbClr val="1E2933"/>
-                </a:solidFill>
-                <a:latin typeface="Microsoft YaHei"/>
-              </a:defRPr>
-            </a:pPr>
-            <a:r>
-              <a:t>核心原则：把贵且慢的云端调用摊到多步，本地 VLM 只提供「证据」，规则引擎负责零延迟执行。</a:t>
-            </a:r>
-          </a:p>
-        </p:txBody>
-      </p:sp>
-      <p:sp>
-        <p:nvSpPr>
-          <p:cNvPr id="23" name="Rectangle 22"/>
-          <p:cNvSpPr/>
-          <p:nvPr/>
-        </p:nvSpPr>
-        <p:spPr>
-          <a:xfrm>
-            <a:off x="0" y="6537960"/>
-            <a:ext cx="12191695" cy="18288"/>
-          </a:xfrm>
-          <a:prstGeom prst="rect">
-            <a:avLst/>
-          </a:prstGeom>
-          <a:solidFill>
-            <a:srgbClr val="0096C7"/>
-          </a:solidFill>
-          <a:ln/>
-        </p:spPr>
-        <p:style>
-          <a:lnRef idx="1">
-            <a:schemeClr val="accent1"/>
-          </a:lnRef>
-          <a:fillRef idx="3">
-            <a:schemeClr val="accent1"/>
-          </a:fillRef>
-          <a:effectRef idx="2">
-            <a:schemeClr val="accent1"/>
-          </a:effectRef>
-          <a:fontRef idx="minor">
-            <a:schemeClr val="lt1"/>
-          </a:fontRef>
-        </p:style>
-        <p:txBody>
-          <a:bodyPr rtlCol="0" anchor="ctr"/>
-          <a:lstStyle/>
-          <a:p>
-            <a:pPr algn="ctr"/>
-          </a:p>
-        </p:txBody>
-      </p:sp>
-      <p:sp>
-        <p:nvSpPr>
-          <p:cNvPr id="24" name="TextBox 23"/>
-          <p:cNvSpPr txBox="1"/>
-          <p:nvPr/>
-        </p:nvSpPr>
-        <p:spPr>
-          <a:xfrm>
-            <a:off x="457200" y="6583680"/>
-            <a:ext cx="3657600" cy="228600"/>
-          </a:xfrm>
-          <a:prstGeom prst="rect">
-            <a:avLst/>
-          </a:prstGeom>
-          <a:noFill/>
-        </p:spPr>
-        <p:txBody>
-          <a:bodyPr wrap="none">
-            <a:spAutoFit/>
-          </a:bodyPr>
-          <a:lstStyle/>
-          <a:p>
-            <a:pPr algn="l">
-              <a:defRPr sz="1000" b="0">
-                <a:solidFill>
-                  <a:srgbClr val="6C757D"/>
-                </a:solidFill>
-                <a:latin typeface="Microsoft YaHei"/>
-              </a:defRPr>
-            </a:pPr>
-            <a:r>
-              <a:t>smallgameagent · LLM/VLM + 规则驱动</a:t>
-            </a:r>
-          </a:p>
-        </p:txBody>
-      </p:sp>
-      <p:sp>
-        <p:nvSpPr>
-          <p:cNvPr id="25" name="TextBox 24"/>
-          <p:cNvSpPr txBox="1"/>
-          <p:nvPr/>
-        </p:nvSpPr>
-        <p:spPr>
-          <a:xfrm>
-            <a:off x="10789920" y="6583680"/>
-            <a:ext cx="914400" cy="228600"/>
-          </a:xfrm>
-          <a:prstGeom prst="rect">
-            <a:avLst/>
-          </a:prstGeom>
-          <a:noFill/>
-        </p:spPr>
-        <p:txBody>
-          <a:bodyPr wrap="none">
-            <a:spAutoFit/>
-          </a:bodyPr>
-          <a:lstStyle/>
-          <a:p>
             <a:pPr algn="r">
               <a:defRPr sz="1000" b="0">
                 <a:solidFill>
@@ -23055,7 +23129,7 @@
               </a:defRPr>
             </a:pPr>
             <a:r>
-              <a:t>36/39</a:t>
+              <a:t>36/40</a:t>
             </a:r>
           </a:p>
         </p:txBody>
@@ -23087,7 +23161,7 @@
         <p:spPr>
           <a:xfrm>
             <a:off x="0" y="0"/>
-            <a:ext cx="12191695" cy="6858000"/>
+            <a:ext cx="12191695" cy="960120"/>
           </a:xfrm>
           <a:prstGeom prst="rect">
             <a:avLst/>
@@ -23121,58 +23195,14 @@
       </p:sp>
       <p:sp>
         <p:nvSpPr>
-          <p:cNvPr id="3" name="Rectangle 2"/>
-          <p:cNvSpPr/>
-          <p:nvPr/>
-        </p:nvSpPr>
-        <p:spPr>
-          <a:xfrm>
-            <a:off x="6858000" y="-914400"/>
-            <a:ext cx="5943600" cy="8686800"/>
-          </a:xfrm>
-          <a:prstGeom prst="rect">
-            <a:avLst/>
-          </a:prstGeom>
-          <a:solidFill>
-            <a:srgbClr val="0096C7">
-              <a:lumMod val="80000"/>
-              <a:lumOff val="20000"/>
-            </a:srgbClr>
-          </a:solidFill>
-          <a:ln/>
-        </p:spPr>
-        <p:style>
-          <a:lnRef idx="1">
-            <a:schemeClr val="accent1"/>
-          </a:lnRef>
-          <a:fillRef idx="3">
-            <a:schemeClr val="accent1"/>
-          </a:fillRef>
-          <a:effectRef idx="2">
-            <a:schemeClr val="accent1"/>
-          </a:effectRef>
-          <a:fontRef idx="minor">
-            <a:schemeClr val="lt1"/>
-          </a:fontRef>
-        </p:style>
-        <p:txBody>
-          <a:bodyPr rtlCol="0" anchor="ctr"/>
-          <a:lstStyle/>
-          <a:p>
-            <a:pPr algn="ctr"/>
-          </a:p>
-        </p:txBody>
-      </p:sp>
-      <p:sp>
-        <p:nvSpPr>
-          <p:cNvPr id="4" name="TextBox 3"/>
+          <p:cNvPr id="3" name="TextBox 2"/>
           <p:cNvSpPr txBox="1"/>
           <p:nvPr/>
         </p:nvSpPr>
         <p:spPr>
           <a:xfrm>
-            <a:off x="548640" y="1645920"/>
-            <a:ext cx="2743200" cy="1828800"/>
+            <a:off x="457200" y="228600"/>
+            <a:ext cx="11247120" cy="548640"/>
           </a:xfrm>
           <a:prstGeom prst="rect">
             <a:avLst/>
@@ -23186,29 +23216,197 @@
           <a:lstStyle/>
           <a:p>
             <a:pPr algn="l">
-              <a:defRPr sz="12000" b="1">
-                <a:solidFill>
-                  <a:srgbClr val="333DA0"/>
-                </a:solidFill>
-                <a:latin typeface="Microsoft YaHei"/>
-              </a:defRPr>
-            </a:pPr>
-            <a:r>
-              <a:t>10</a:t>
-            </a:r>
-          </a:p>
-        </p:txBody>
-      </p:sp>
-      <p:sp>
-        <p:nvSpPr>
-          <p:cNvPr id="5" name="TextBox 4"/>
+              <a:defRPr sz="3000" b="1">
+                <a:solidFill>
+                  <a:srgbClr val="F3F6F9"/>
+                </a:solidFill>
+                <a:latin typeface="Microsoft YaHei"/>
+              </a:defRPr>
+            </a:pPr>
+            <a:r>
+              <a:t>技术路线图：从能跑到好用</a:t>
+            </a:r>
+          </a:p>
+        </p:txBody>
+      </p:sp>
+      <p:sp>
+        <p:nvSpPr>
+          <p:cNvPr id="4" name="Rectangle 3"/>
+          <p:cNvSpPr/>
+          <p:nvPr/>
+        </p:nvSpPr>
+        <p:spPr>
+          <a:xfrm>
+            <a:off x="0" y="960120"/>
+            <a:ext cx="164592" cy="5897880"/>
+          </a:xfrm>
+          <a:prstGeom prst="rect">
+            <a:avLst/>
+          </a:prstGeom>
+          <a:solidFill>
+            <a:srgbClr val="0096C7"/>
+          </a:solidFill>
+          <a:ln/>
+        </p:spPr>
+        <p:style>
+          <a:lnRef idx="1">
+            <a:schemeClr val="accent1"/>
+          </a:lnRef>
+          <a:fillRef idx="3">
+            <a:schemeClr val="accent1"/>
+          </a:fillRef>
+          <a:effectRef idx="2">
+            <a:schemeClr val="accent1"/>
+          </a:effectRef>
+          <a:fontRef idx="minor">
+            <a:schemeClr val="lt1"/>
+          </a:fontRef>
+        </p:style>
+        <p:txBody>
+          <a:bodyPr rtlCol="0" anchor="ctr"/>
+          <a:lstStyle/>
+          <a:p>
+            <a:pPr algn="ctr"/>
+          </a:p>
+        </p:txBody>
+      </p:sp>
+      <p:sp>
+        <p:nvSpPr>
+          <p:cNvPr id="5" name="Rectangle 4"/>
+          <p:cNvSpPr/>
+          <p:nvPr/>
+        </p:nvSpPr>
+        <p:spPr>
+          <a:xfrm>
+            <a:off x="320040" y="1078992"/>
+            <a:ext cx="11548872" cy="5349240"/>
+          </a:xfrm>
+          <a:prstGeom prst="rect">
+            <a:avLst/>
+          </a:prstGeom>
+          <a:solidFill>
+            <a:srgbClr val="FFFFFF"/>
+          </a:solidFill>
+          <a:ln w="12700">
+            <a:solidFill>
+              <a:srgbClr val="E1E5E9"/>
+            </a:solidFill>
+          </a:ln>
+        </p:spPr>
+        <p:style>
+          <a:lnRef idx="1">
+            <a:schemeClr val="accent1"/>
+          </a:lnRef>
+          <a:fillRef idx="3">
+            <a:schemeClr val="accent1"/>
+          </a:fillRef>
+          <a:effectRef idx="2">
+            <a:schemeClr val="accent1"/>
+          </a:effectRef>
+          <a:fontRef idx="minor">
+            <a:schemeClr val="lt1"/>
+          </a:fontRef>
+        </p:style>
+        <p:txBody>
+          <a:bodyPr rtlCol="0" anchor="ctr"/>
+          <a:lstStyle/>
+          <a:p>
+            <a:pPr algn="ctr"/>
+          </a:p>
+        </p:txBody>
+      </p:sp>
+      <p:sp>
+        <p:nvSpPr>
+          <p:cNvPr id="6" name="Rectangle 5"/>
+          <p:cNvSpPr/>
+          <p:nvPr/>
+        </p:nvSpPr>
+        <p:spPr>
+          <a:xfrm>
+            <a:off x="777240" y="3200400"/>
+            <a:ext cx="10972800" cy="73152"/>
+          </a:xfrm>
+          <a:prstGeom prst="rect">
+            <a:avLst/>
+          </a:prstGeom>
+          <a:solidFill>
+            <a:srgbClr val="6C757D"/>
+          </a:solidFill>
+          <a:ln/>
+        </p:spPr>
+        <p:style>
+          <a:lnRef idx="1">
+            <a:schemeClr val="accent1"/>
+          </a:lnRef>
+          <a:fillRef idx="3">
+            <a:schemeClr val="accent1"/>
+          </a:fillRef>
+          <a:effectRef idx="2">
+            <a:schemeClr val="accent1"/>
+          </a:effectRef>
+          <a:fontRef idx="minor">
+            <a:schemeClr val="lt1"/>
+          </a:fontRef>
+        </p:style>
+        <p:txBody>
+          <a:bodyPr rtlCol="0" anchor="ctr"/>
+          <a:lstStyle/>
+          <a:p>
+            <a:pPr algn="ctr"/>
+          </a:p>
+        </p:txBody>
+      </p:sp>
+      <p:sp>
+        <p:nvSpPr>
+          <p:cNvPr id="7" name="Oval 6"/>
+          <p:cNvSpPr/>
+          <p:nvPr/>
+        </p:nvSpPr>
+        <p:spPr>
+          <a:xfrm>
+            <a:off x="822960" y="3063240"/>
+            <a:ext cx="320040" cy="320040"/>
+          </a:xfrm>
+          <a:prstGeom prst="ellipse">
+            <a:avLst/>
+          </a:prstGeom>
+          <a:solidFill>
+            <a:srgbClr val="28A745"/>
+          </a:solidFill>
+          <a:ln/>
+        </p:spPr>
+        <p:style>
+          <a:lnRef idx="1">
+            <a:schemeClr val="accent1"/>
+          </a:lnRef>
+          <a:fillRef idx="3">
+            <a:schemeClr val="accent1"/>
+          </a:fillRef>
+          <a:effectRef idx="2">
+            <a:schemeClr val="accent1"/>
+          </a:effectRef>
+          <a:fontRef idx="minor">
+            <a:schemeClr val="lt1"/>
+          </a:fontRef>
+        </p:style>
+        <p:txBody>
+          <a:bodyPr rtlCol="0" anchor="ctr"/>
+          <a:lstStyle/>
+          <a:p>
+            <a:pPr algn="ctr"/>
+          </a:p>
+        </p:txBody>
+      </p:sp>
+      <p:sp>
+        <p:nvSpPr>
+          <p:cNvPr id="8" name="TextBox 7"/>
           <p:cNvSpPr txBox="1"/>
           <p:nvPr/>
         </p:nvSpPr>
         <p:spPr>
           <a:xfrm>
-            <a:off x="548640" y="2834640"/>
-            <a:ext cx="11064240" cy="1097280"/>
+            <a:off x="320040" y="2103120"/>
+            <a:ext cx="1645920" cy="457200"/>
           </a:xfrm>
           <a:prstGeom prst="rect">
             <a:avLst/>
@@ -23221,112 +23419,30 @@
           </a:bodyPr>
           <a:lstStyle/>
           <a:p>
-            <a:pPr algn="l">
-              <a:defRPr sz="4400" b="1">
-                <a:solidFill>
-                  <a:srgbClr val="F3F6F9"/>
-                </a:solidFill>
-                <a:latin typeface="Microsoft YaHei"/>
-              </a:defRPr>
-            </a:pPr>
-            <a:r>
-              <a:t>下一步</a:t>
-            </a:r>
-          </a:p>
-        </p:txBody>
-      </p:sp>
-      <p:sp>
-        <p:nvSpPr>
-          <p:cNvPr id="6" name="Rectangle 5"/>
-          <p:cNvSpPr/>
-          <p:nvPr/>
-        </p:nvSpPr>
-        <p:spPr>
-          <a:xfrm>
-            <a:off x="548640" y="4023360"/>
-            <a:ext cx="1828800" cy="73152"/>
-          </a:xfrm>
-          <a:prstGeom prst="rect">
-            <a:avLst/>
-          </a:prstGeom>
-          <a:solidFill>
-            <a:srgbClr val="FF6B35"/>
-          </a:solidFill>
-          <a:ln/>
-        </p:spPr>
-        <p:style>
-          <a:lnRef idx="1">
-            <a:schemeClr val="accent1"/>
-          </a:lnRef>
-          <a:fillRef idx="3">
-            <a:schemeClr val="accent1"/>
-          </a:fillRef>
-          <a:effectRef idx="2">
-            <a:schemeClr val="accent1"/>
-          </a:effectRef>
-          <a:fontRef idx="minor">
-            <a:schemeClr val="lt1"/>
-          </a:fontRef>
-        </p:style>
-        <p:txBody>
-          <a:bodyPr rtlCol="0" anchor="ctr"/>
-          <a:lstStyle/>
-          <a:p>
-            <a:pPr algn="ctr"/>
-          </a:p>
-        </p:txBody>
-      </p:sp>
-      <p:sp>
-        <p:nvSpPr>
-          <p:cNvPr id="7" name="Rectangle 6"/>
-          <p:cNvSpPr/>
-          <p:nvPr/>
-        </p:nvSpPr>
-        <p:spPr>
-          <a:xfrm>
-            <a:off x="0" y="6537960"/>
-            <a:ext cx="12191695" cy="18288"/>
-          </a:xfrm>
-          <a:prstGeom prst="rect">
-            <a:avLst/>
-          </a:prstGeom>
-          <a:solidFill>
-            <a:srgbClr val="0096C7"/>
-          </a:solidFill>
-          <a:ln/>
-        </p:spPr>
-        <p:style>
-          <a:lnRef idx="1">
-            <a:schemeClr val="accent1"/>
-          </a:lnRef>
-          <a:fillRef idx="3">
-            <a:schemeClr val="accent1"/>
-          </a:fillRef>
-          <a:effectRef idx="2">
-            <a:schemeClr val="accent1"/>
-          </a:effectRef>
-          <a:fontRef idx="minor">
-            <a:schemeClr val="lt1"/>
-          </a:fontRef>
-        </p:style>
-        <p:txBody>
-          <a:bodyPr rtlCol="0" anchor="ctr"/>
-          <a:lstStyle/>
-          <a:p>
-            <a:pPr algn="ctr"/>
-          </a:p>
-        </p:txBody>
-      </p:sp>
-      <p:sp>
-        <p:nvSpPr>
-          <p:cNvPr id="8" name="TextBox 7"/>
+            <a:pPr algn="ctr">
+              <a:defRPr sz="1300" b="1">
+                <a:solidFill>
+                  <a:srgbClr val="28A745"/>
+                </a:solidFill>
+                <a:latin typeface="Microsoft YaHei"/>
+              </a:defRPr>
+            </a:pPr>
+            <a:r>
+              <a:t>已完成</a:t>
+            </a:r>
+          </a:p>
+        </p:txBody>
+      </p:sp>
+      <p:sp>
+        <p:nvSpPr>
+          <p:cNvPr id="9" name="TextBox 8"/>
           <p:cNvSpPr txBox="1"/>
           <p:nvPr/>
         </p:nvSpPr>
         <p:spPr>
           <a:xfrm>
-            <a:off x="457200" y="6583680"/>
-            <a:ext cx="3657600" cy="228600"/>
+            <a:off x="91439" y="3474720"/>
+            <a:ext cx="2194560" cy="1188720"/>
           </a:xfrm>
           <a:prstGeom prst="rect">
             <a:avLst/>
@@ -23339,30 +23455,75 @@
           </a:bodyPr>
           <a:lstStyle/>
           <a:p>
-            <a:pPr algn="l">
-              <a:defRPr sz="1000" b="0">
-                <a:solidFill>
-                  <a:srgbClr val="6C757D"/>
-                </a:solidFill>
-                <a:latin typeface="Microsoft YaHei"/>
-              </a:defRPr>
-            </a:pPr>
-            <a:r>
-              <a:t>smallgameagent · LLM/VLM + 规则驱动</a:t>
-            </a:r>
-          </a:p>
-        </p:txBody>
-      </p:sp>
-      <p:sp>
-        <p:nvSpPr>
-          <p:cNvPr id="9" name="TextBox 8"/>
+            <a:pPr algn="ctr">
+              <a:defRPr sz="1200" b="0">
+                <a:solidFill>
+                  <a:srgbClr val="1E2933"/>
+                </a:solidFill>
+                <a:latin typeface="Microsoft YaHei"/>
+              </a:defRPr>
+            </a:pPr>
+            <a:r>
+              <a:t>规则引擎 + 自动校准</a:t>
+            </a:r>
+            <a:br/>
+            <a:r>
+              <a:t>22 游戏可驱动</a:t>
+            </a:r>
+          </a:p>
+        </p:txBody>
+      </p:sp>
+      <p:sp>
+        <p:nvSpPr>
+          <p:cNvPr id="10" name="Oval 9"/>
+          <p:cNvSpPr/>
+          <p:nvPr/>
+        </p:nvSpPr>
+        <p:spPr>
+          <a:xfrm>
+            <a:off x="3108960" y="3063240"/>
+            <a:ext cx="320040" cy="320040"/>
+          </a:xfrm>
+          <a:prstGeom prst="ellipse">
+            <a:avLst/>
+          </a:prstGeom>
+          <a:solidFill>
+            <a:srgbClr val="28A745"/>
+          </a:solidFill>
+          <a:ln/>
+        </p:spPr>
+        <p:style>
+          <a:lnRef idx="1">
+            <a:schemeClr val="accent1"/>
+          </a:lnRef>
+          <a:fillRef idx="3">
+            <a:schemeClr val="accent1"/>
+          </a:fillRef>
+          <a:effectRef idx="2">
+            <a:schemeClr val="accent1"/>
+          </a:effectRef>
+          <a:fontRef idx="minor">
+            <a:schemeClr val="lt1"/>
+          </a:fontRef>
+        </p:style>
+        <p:txBody>
+          <a:bodyPr rtlCol="0" anchor="ctr"/>
+          <a:lstStyle/>
+          <a:p>
+            <a:pPr algn="ctr"/>
+          </a:p>
+        </p:txBody>
+      </p:sp>
+      <p:sp>
+        <p:nvSpPr>
+          <p:cNvPr id="11" name="TextBox 10"/>
           <p:cNvSpPr txBox="1"/>
           <p:nvPr/>
         </p:nvSpPr>
         <p:spPr>
           <a:xfrm>
-            <a:off x="10789920" y="6583680"/>
-            <a:ext cx="914400" cy="228600"/>
+            <a:off x="2606039" y="2103120"/>
+            <a:ext cx="1645920" cy="457200"/>
           </a:xfrm>
           <a:prstGeom prst="rect">
             <a:avLst/>
@@ -23375,6 +23536,561 @@
           </a:bodyPr>
           <a:lstStyle/>
           <a:p>
+            <a:pPr algn="ctr">
+              <a:defRPr sz="1300" b="1">
+                <a:solidFill>
+                  <a:srgbClr val="28A745"/>
+                </a:solidFill>
+                <a:latin typeface="Microsoft YaHei"/>
+              </a:defRPr>
+            </a:pPr>
+            <a:r>
+              <a:t>已完成</a:t>
+            </a:r>
+          </a:p>
+        </p:txBody>
+      </p:sp>
+      <p:sp>
+        <p:nvSpPr>
+          <p:cNvPr id="12" name="TextBox 11"/>
+          <p:cNvSpPr txBox="1"/>
+          <p:nvPr/>
+        </p:nvSpPr>
+        <p:spPr>
+          <a:xfrm>
+            <a:off x="2377439" y="3474720"/>
+            <a:ext cx="2194560" cy="1188720"/>
+          </a:xfrm>
+          <a:prstGeom prst="rect">
+            <a:avLst/>
+          </a:prstGeom>
+          <a:noFill/>
+        </p:spPr>
+        <p:txBody>
+          <a:bodyPr wrap="none">
+            <a:spAutoFit/>
+          </a:bodyPr>
+          <a:lstStyle/>
+          <a:p>
+            <a:pPr algn="ctr">
+              <a:defRPr sz="1200" b="0">
+                <a:solidFill>
+                  <a:srgbClr val="1E2933"/>
+                </a:solidFill>
+                <a:latin typeface="Microsoft YaHei"/>
+              </a:defRPr>
+            </a:pPr>
+            <a:r>
+              <a:t>multi-bus-memory</a:t>
+            </a:r>
+            <a:br/>
+            <a:r>
+              <a:t>记忆读回 0.300</a:t>
+            </a:r>
+          </a:p>
+        </p:txBody>
+      </p:sp>
+      <p:sp>
+        <p:nvSpPr>
+          <p:cNvPr id="13" name="Oval 12"/>
+          <p:cNvSpPr/>
+          <p:nvPr/>
+        </p:nvSpPr>
+        <p:spPr>
+          <a:xfrm>
+            <a:off x="5394960" y="3063240"/>
+            <a:ext cx="320040" cy="320040"/>
+          </a:xfrm>
+          <a:prstGeom prst="ellipse">
+            <a:avLst/>
+          </a:prstGeom>
+          <a:solidFill>
+            <a:srgbClr val="28A745"/>
+          </a:solidFill>
+          <a:ln/>
+        </p:spPr>
+        <p:style>
+          <a:lnRef idx="1">
+            <a:schemeClr val="accent1"/>
+          </a:lnRef>
+          <a:fillRef idx="3">
+            <a:schemeClr val="accent1"/>
+          </a:fillRef>
+          <a:effectRef idx="2">
+            <a:schemeClr val="accent1"/>
+          </a:effectRef>
+          <a:fontRef idx="minor">
+            <a:schemeClr val="lt1"/>
+          </a:fontRef>
+        </p:style>
+        <p:txBody>
+          <a:bodyPr rtlCol="0" anchor="ctr"/>
+          <a:lstStyle/>
+          <a:p>
+            <a:pPr algn="ctr"/>
+          </a:p>
+        </p:txBody>
+      </p:sp>
+      <p:sp>
+        <p:nvSpPr>
+          <p:cNvPr id="14" name="TextBox 13"/>
+          <p:cNvSpPr txBox="1"/>
+          <p:nvPr/>
+        </p:nvSpPr>
+        <p:spPr>
+          <a:xfrm>
+            <a:off x="4892040" y="2103120"/>
+            <a:ext cx="1645920" cy="457200"/>
+          </a:xfrm>
+          <a:prstGeom prst="rect">
+            <a:avLst/>
+          </a:prstGeom>
+          <a:noFill/>
+        </p:spPr>
+        <p:txBody>
+          <a:bodyPr wrap="none">
+            <a:spAutoFit/>
+          </a:bodyPr>
+          <a:lstStyle/>
+          <a:p>
+            <a:pPr algn="ctr">
+              <a:defRPr sz="1300" b="1">
+                <a:solidFill>
+                  <a:srgbClr val="28A745"/>
+                </a:solidFill>
+                <a:latin typeface="Microsoft YaHei"/>
+              </a:defRPr>
+            </a:pPr>
+            <a:r>
+              <a:t>已完成</a:t>
+            </a:r>
+          </a:p>
+        </p:txBody>
+      </p:sp>
+      <p:sp>
+        <p:nvSpPr>
+          <p:cNvPr id="15" name="TextBox 14"/>
+          <p:cNvSpPr txBox="1"/>
+          <p:nvPr/>
+        </p:nvSpPr>
+        <p:spPr>
+          <a:xfrm>
+            <a:off x="4663440" y="3474720"/>
+            <a:ext cx="2194560" cy="1188720"/>
+          </a:xfrm>
+          <a:prstGeom prst="rect">
+            <a:avLst/>
+          </a:prstGeom>
+          <a:noFill/>
+        </p:spPr>
+        <p:txBody>
+          <a:bodyPr wrap="none">
+            <a:spAutoFit/>
+          </a:bodyPr>
+          <a:lstStyle/>
+          <a:p>
+            <a:pPr algn="ctr">
+              <a:defRPr sz="1200" b="0">
+                <a:solidFill>
+                  <a:srgbClr val="1E2933"/>
+                </a:solidFill>
+                <a:latin typeface="Microsoft YaHei"/>
+              </a:defRPr>
+            </a:pPr>
+            <a:r>
+              <a:t>L2 code-file 更新</a:t>
+            </a:r>
+            <a:br/>
+            <a:r>
+              <a:t>qwen/kimi/xiaomi/opencodego 验证</a:t>
+            </a:r>
+          </a:p>
+        </p:txBody>
+      </p:sp>
+      <p:sp>
+        <p:nvSpPr>
+          <p:cNvPr id="16" name="Oval 15"/>
+          <p:cNvSpPr/>
+          <p:nvPr/>
+        </p:nvSpPr>
+        <p:spPr>
+          <a:xfrm>
+            <a:off x="7680960" y="3063240"/>
+            <a:ext cx="320040" cy="320040"/>
+          </a:xfrm>
+          <a:prstGeom prst="ellipse">
+            <a:avLst/>
+          </a:prstGeom>
+          <a:solidFill>
+            <a:srgbClr val="FF6B35"/>
+          </a:solidFill>
+          <a:ln/>
+        </p:spPr>
+        <p:style>
+          <a:lnRef idx="1">
+            <a:schemeClr val="accent1"/>
+          </a:lnRef>
+          <a:fillRef idx="3">
+            <a:schemeClr val="accent1"/>
+          </a:fillRef>
+          <a:effectRef idx="2">
+            <a:schemeClr val="accent1"/>
+          </a:effectRef>
+          <a:fontRef idx="minor">
+            <a:schemeClr val="lt1"/>
+          </a:fontRef>
+        </p:style>
+        <p:txBody>
+          <a:bodyPr rtlCol="0" anchor="ctr"/>
+          <a:lstStyle/>
+          <a:p>
+            <a:pPr algn="ctr"/>
+          </a:p>
+        </p:txBody>
+      </p:sp>
+      <p:sp>
+        <p:nvSpPr>
+          <p:cNvPr id="17" name="TextBox 16"/>
+          <p:cNvSpPr txBox="1"/>
+          <p:nvPr/>
+        </p:nvSpPr>
+        <p:spPr>
+          <a:xfrm>
+            <a:off x="7178040" y="2103120"/>
+            <a:ext cx="1645920" cy="457200"/>
+          </a:xfrm>
+          <a:prstGeom prst="rect">
+            <a:avLst/>
+          </a:prstGeom>
+          <a:noFill/>
+        </p:spPr>
+        <p:txBody>
+          <a:bodyPr wrap="none">
+            <a:spAutoFit/>
+          </a:bodyPr>
+          <a:lstStyle/>
+          <a:p>
+            <a:pPr algn="ctr">
+              <a:defRPr sz="1300" b="1">
+                <a:solidFill>
+                  <a:srgbClr val="FF6B35"/>
+                </a:solidFill>
+                <a:latin typeface="Microsoft YaHei"/>
+              </a:defRPr>
+            </a:pPr>
+            <a:r>
+              <a:t>进行中</a:t>
+            </a:r>
+          </a:p>
+        </p:txBody>
+      </p:sp>
+      <p:sp>
+        <p:nvSpPr>
+          <p:cNvPr id="18" name="TextBox 17"/>
+          <p:cNvSpPr txBox="1"/>
+          <p:nvPr/>
+        </p:nvSpPr>
+        <p:spPr>
+          <a:xfrm>
+            <a:off x="6949440" y="3474720"/>
+            <a:ext cx="2194560" cy="1188720"/>
+          </a:xfrm>
+          <a:prstGeom prst="rect">
+            <a:avLst/>
+          </a:prstGeom>
+          <a:noFill/>
+        </p:spPr>
+        <p:txBody>
+          <a:bodyPr wrap="none">
+            <a:spAutoFit/>
+          </a:bodyPr>
+          <a:lstStyle/>
+          <a:p>
+            <a:pPr algn="ctr">
+              <a:defRPr sz="1200" b="0">
+                <a:solidFill>
+                  <a:srgbClr val="1E2933"/>
+                </a:solidFill>
+                <a:latin typeface="Microsoft YaHei"/>
+              </a:defRPr>
+            </a:pPr>
+            <a:r>
+              <a:t>本地 VLM 上下文</a:t>
+            </a:r>
+            <a:br/>
+            <a:r>
+              <a:t>QLoRA 微调准备</a:t>
+            </a:r>
+          </a:p>
+        </p:txBody>
+      </p:sp>
+      <p:sp>
+        <p:nvSpPr>
+          <p:cNvPr id="19" name="Oval 18"/>
+          <p:cNvSpPr/>
+          <p:nvPr/>
+        </p:nvSpPr>
+        <p:spPr>
+          <a:xfrm>
+            <a:off x="9966960" y="3063240"/>
+            <a:ext cx="320040" cy="320040"/>
+          </a:xfrm>
+          <a:prstGeom prst="ellipse">
+            <a:avLst/>
+          </a:prstGeom>
+          <a:solidFill>
+            <a:srgbClr val="0096C7"/>
+          </a:solidFill>
+          <a:ln/>
+        </p:spPr>
+        <p:style>
+          <a:lnRef idx="1">
+            <a:schemeClr val="accent1"/>
+          </a:lnRef>
+          <a:fillRef idx="3">
+            <a:schemeClr val="accent1"/>
+          </a:fillRef>
+          <a:effectRef idx="2">
+            <a:schemeClr val="accent1"/>
+          </a:effectRef>
+          <a:fontRef idx="minor">
+            <a:schemeClr val="lt1"/>
+          </a:fontRef>
+        </p:style>
+        <p:txBody>
+          <a:bodyPr rtlCol="0" anchor="ctr"/>
+          <a:lstStyle/>
+          <a:p>
+            <a:pPr algn="ctr"/>
+          </a:p>
+        </p:txBody>
+      </p:sp>
+      <p:sp>
+        <p:nvSpPr>
+          <p:cNvPr id="20" name="TextBox 19"/>
+          <p:cNvSpPr txBox="1"/>
+          <p:nvPr/>
+        </p:nvSpPr>
+        <p:spPr>
+          <a:xfrm>
+            <a:off x="9464040" y="2103120"/>
+            <a:ext cx="1645920" cy="457200"/>
+          </a:xfrm>
+          <a:prstGeom prst="rect">
+            <a:avLst/>
+          </a:prstGeom>
+          <a:noFill/>
+        </p:spPr>
+        <p:txBody>
+          <a:bodyPr wrap="none">
+            <a:spAutoFit/>
+          </a:bodyPr>
+          <a:lstStyle/>
+          <a:p>
+            <a:pPr algn="ctr">
+              <a:defRPr sz="1300" b="1">
+                <a:solidFill>
+                  <a:srgbClr val="0096C7"/>
+                </a:solidFill>
+                <a:latin typeface="Microsoft YaHei"/>
+              </a:defRPr>
+            </a:pPr>
+            <a:r>
+              <a:t>下一步</a:t>
+            </a:r>
+          </a:p>
+        </p:txBody>
+      </p:sp>
+      <p:sp>
+        <p:nvSpPr>
+          <p:cNvPr id="21" name="TextBox 20"/>
+          <p:cNvSpPr txBox="1"/>
+          <p:nvPr/>
+        </p:nvSpPr>
+        <p:spPr>
+          <a:xfrm>
+            <a:off x="9235440" y="3474720"/>
+            <a:ext cx="2194560" cy="1188720"/>
+          </a:xfrm>
+          <a:prstGeom prst="rect">
+            <a:avLst/>
+          </a:prstGeom>
+          <a:noFill/>
+        </p:spPr>
+        <p:txBody>
+          <a:bodyPr wrap="none">
+            <a:spAutoFit/>
+          </a:bodyPr>
+          <a:lstStyle/>
+          <a:p>
+            <a:pPr algn="ctr">
+              <a:defRPr sz="1200" b="0">
+                <a:solidFill>
+                  <a:srgbClr val="1E2933"/>
+                </a:solidFill>
+                <a:latin typeface="Microsoft YaHei"/>
+              </a:defRPr>
+            </a:pPr>
+            <a:r>
+              <a:t>真实游戏在线触发</a:t>
+            </a:r>
+            <a:br/>
+            <a:r>
+              <a:t>规则更新 + A/B 回归</a:t>
+            </a:r>
+          </a:p>
+        </p:txBody>
+      </p:sp>
+      <p:sp>
+        <p:nvSpPr>
+          <p:cNvPr id="22" name="Rounded Rectangle 21"/>
+          <p:cNvSpPr/>
+          <p:nvPr/>
+        </p:nvSpPr>
+        <p:spPr>
+          <a:xfrm>
+            <a:off x="777240" y="5074920"/>
+            <a:ext cx="10972800" cy="822960"/>
+          </a:xfrm>
+          <a:prstGeom prst="roundRect">
+            <a:avLst/>
+          </a:prstGeom>
+          <a:solidFill>
+            <a:srgbClr val="F3F6F9"/>
+          </a:solidFill>
+          <a:ln/>
+        </p:spPr>
+        <p:style>
+          <a:lnRef idx="1">
+            <a:schemeClr val="accent1"/>
+          </a:lnRef>
+          <a:fillRef idx="3">
+            <a:schemeClr val="accent1"/>
+          </a:fillRef>
+          <a:effectRef idx="2">
+            <a:schemeClr val="accent1"/>
+          </a:effectRef>
+          <a:fontRef idx="minor">
+            <a:schemeClr val="lt1"/>
+          </a:fontRef>
+        </p:style>
+        <p:txBody>
+          <a:bodyPr rtlCol="0" anchor="ctr"/>
+          <a:lstStyle/>
+          <a:p>
+            <a:pPr algn="ctr">
+              <a:defRPr sz="1400" b="0">
+                <a:solidFill>
+                  <a:srgbClr val="1E2933"/>
+                </a:solidFill>
+                <a:latin typeface="Microsoft YaHei"/>
+              </a:defRPr>
+            </a:pPr>
+            <a:r>
+              <a:t>核心原则：把贵且慢的云端调用摊到多步，本地 VLM 只提供「证据」，规则引擎负责零延迟执行。</a:t>
+            </a:r>
+          </a:p>
+        </p:txBody>
+      </p:sp>
+      <p:sp>
+        <p:nvSpPr>
+          <p:cNvPr id="23" name="Rectangle 22"/>
+          <p:cNvSpPr/>
+          <p:nvPr/>
+        </p:nvSpPr>
+        <p:spPr>
+          <a:xfrm>
+            <a:off x="0" y="6537960"/>
+            <a:ext cx="12191695" cy="18288"/>
+          </a:xfrm>
+          <a:prstGeom prst="rect">
+            <a:avLst/>
+          </a:prstGeom>
+          <a:solidFill>
+            <a:srgbClr val="0096C7"/>
+          </a:solidFill>
+          <a:ln/>
+        </p:spPr>
+        <p:style>
+          <a:lnRef idx="1">
+            <a:schemeClr val="accent1"/>
+          </a:lnRef>
+          <a:fillRef idx="3">
+            <a:schemeClr val="accent1"/>
+          </a:fillRef>
+          <a:effectRef idx="2">
+            <a:schemeClr val="accent1"/>
+          </a:effectRef>
+          <a:fontRef idx="minor">
+            <a:schemeClr val="lt1"/>
+          </a:fontRef>
+        </p:style>
+        <p:txBody>
+          <a:bodyPr rtlCol="0" anchor="ctr"/>
+          <a:lstStyle/>
+          <a:p>
+            <a:pPr algn="ctr"/>
+          </a:p>
+        </p:txBody>
+      </p:sp>
+      <p:sp>
+        <p:nvSpPr>
+          <p:cNvPr id="24" name="TextBox 23"/>
+          <p:cNvSpPr txBox="1"/>
+          <p:nvPr/>
+        </p:nvSpPr>
+        <p:spPr>
+          <a:xfrm>
+            <a:off x="457200" y="6583680"/>
+            <a:ext cx="3657600" cy="228600"/>
+          </a:xfrm>
+          <a:prstGeom prst="rect">
+            <a:avLst/>
+          </a:prstGeom>
+          <a:noFill/>
+        </p:spPr>
+        <p:txBody>
+          <a:bodyPr wrap="none">
+            <a:spAutoFit/>
+          </a:bodyPr>
+          <a:lstStyle/>
+          <a:p>
+            <a:pPr algn="l">
+              <a:defRPr sz="1000" b="0">
+                <a:solidFill>
+                  <a:srgbClr val="6C757D"/>
+                </a:solidFill>
+                <a:latin typeface="Microsoft YaHei"/>
+              </a:defRPr>
+            </a:pPr>
+            <a:r>
+              <a:t>smallgameagent · LLM/VLM + 规则驱动</a:t>
+            </a:r>
+          </a:p>
+        </p:txBody>
+      </p:sp>
+      <p:sp>
+        <p:nvSpPr>
+          <p:cNvPr id="25" name="TextBox 24"/>
+          <p:cNvSpPr txBox="1"/>
+          <p:nvPr/>
+        </p:nvSpPr>
+        <p:spPr>
+          <a:xfrm>
+            <a:off x="10789920" y="6583680"/>
+            <a:ext cx="914400" cy="228600"/>
+          </a:xfrm>
+          <a:prstGeom prst="rect">
+            <a:avLst/>
+          </a:prstGeom>
+          <a:noFill/>
+        </p:spPr>
+        <p:txBody>
+          <a:bodyPr wrap="none">
+            <a:spAutoFit/>
+          </a:bodyPr>
+          <a:lstStyle/>
+          <a:p>
             <a:pPr algn="r">
               <a:defRPr sz="1000" b="0">
                 <a:solidFill>
@@ -23384,7 +24100,7 @@
               </a:defRPr>
             </a:pPr>
             <a:r>
-              <a:t>37/39</a:t>
+              <a:t>37/40</a:t>
             </a:r>
           </a:p>
         </p:txBody>
@@ -23416,7 +24132,7 @@
         <p:spPr>
           <a:xfrm>
             <a:off x="0" y="0"/>
-            <a:ext cx="12191695" cy="960120"/>
+            <a:ext cx="12191695" cy="6858000"/>
           </a:xfrm>
           <a:prstGeom prst="rect">
             <a:avLst/>
@@ -23450,14 +24166,58 @@
       </p:sp>
       <p:sp>
         <p:nvSpPr>
-          <p:cNvPr id="3" name="TextBox 2"/>
+          <p:cNvPr id="3" name="Rectangle 2"/>
+          <p:cNvSpPr/>
+          <p:nvPr/>
+        </p:nvSpPr>
+        <p:spPr>
+          <a:xfrm>
+            <a:off x="6858000" y="-914400"/>
+            <a:ext cx="5943600" cy="8686800"/>
+          </a:xfrm>
+          <a:prstGeom prst="rect">
+            <a:avLst/>
+          </a:prstGeom>
+          <a:solidFill>
+            <a:srgbClr val="0096C7">
+              <a:lumMod val="80000"/>
+              <a:lumOff val="20000"/>
+            </a:srgbClr>
+          </a:solidFill>
+          <a:ln/>
+        </p:spPr>
+        <p:style>
+          <a:lnRef idx="1">
+            <a:schemeClr val="accent1"/>
+          </a:lnRef>
+          <a:fillRef idx="3">
+            <a:schemeClr val="accent1"/>
+          </a:fillRef>
+          <a:effectRef idx="2">
+            <a:schemeClr val="accent1"/>
+          </a:effectRef>
+          <a:fontRef idx="minor">
+            <a:schemeClr val="lt1"/>
+          </a:fontRef>
+        </p:style>
+        <p:txBody>
+          <a:bodyPr rtlCol="0" anchor="ctr"/>
+          <a:lstStyle/>
+          <a:p>
+            <a:pPr algn="ctr"/>
+          </a:p>
+        </p:txBody>
+      </p:sp>
+      <p:sp>
+        <p:nvSpPr>
+          <p:cNvPr id="4" name="TextBox 3"/>
           <p:cNvSpPr txBox="1"/>
           <p:nvPr/>
         </p:nvSpPr>
         <p:spPr>
           <a:xfrm>
-            <a:off x="457200" y="228600"/>
-            <a:ext cx="11247120" cy="548640"/>
+            <a:off x="548640" y="1645920"/>
+            <a:ext cx="2743200" cy="1828800"/>
           </a:xfrm>
           <a:prstGeom prst="rect">
             <a:avLst/>
@@ -23471,578 +24231,29 @@
           <a:lstStyle/>
           <a:p>
             <a:pPr algn="l">
-              <a:defRPr sz="3000" b="1">
-                <a:solidFill>
-                  <a:srgbClr val="F3F6F9"/>
-                </a:solidFill>
-                <a:latin typeface="Microsoft YaHei"/>
-              </a:defRPr>
-            </a:pPr>
-            <a:r>
-              <a:t>下一步：把实验变成稳定系统</a:t>
-            </a:r>
-          </a:p>
-        </p:txBody>
-      </p:sp>
-      <p:sp>
-        <p:nvSpPr>
-          <p:cNvPr id="4" name="Rectangle 3"/>
-          <p:cNvSpPr/>
-          <p:nvPr/>
-        </p:nvSpPr>
-        <p:spPr>
-          <a:xfrm>
-            <a:off x="0" y="960120"/>
-            <a:ext cx="164592" cy="5897880"/>
-          </a:xfrm>
-          <a:prstGeom prst="rect">
-            <a:avLst/>
-          </a:prstGeom>
-          <a:solidFill>
-            <a:srgbClr val="0096C7"/>
-          </a:solidFill>
-          <a:ln/>
-        </p:spPr>
-        <p:style>
-          <a:lnRef idx="1">
-            <a:schemeClr val="accent1"/>
-          </a:lnRef>
-          <a:fillRef idx="3">
-            <a:schemeClr val="accent1"/>
-          </a:fillRef>
-          <a:effectRef idx="2">
-            <a:schemeClr val="accent1"/>
-          </a:effectRef>
-          <a:fontRef idx="minor">
-            <a:schemeClr val="lt1"/>
-          </a:fontRef>
-        </p:style>
-        <p:txBody>
-          <a:bodyPr rtlCol="0" anchor="ctr"/>
-          <a:lstStyle/>
-          <a:p>
-            <a:pPr algn="ctr"/>
-          </a:p>
-        </p:txBody>
-      </p:sp>
-      <p:sp>
-        <p:nvSpPr>
-          <p:cNvPr id="5" name="Rectangle 4"/>
-          <p:cNvSpPr/>
-          <p:nvPr/>
-        </p:nvSpPr>
-        <p:spPr>
-          <a:xfrm>
-            <a:off x="320040" y="1078992"/>
-            <a:ext cx="11548872" cy="5349240"/>
-          </a:xfrm>
-          <a:prstGeom prst="rect">
-            <a:avLst/>
-          </a:prstGeom>
-          <a:solidFill>
-            <a:srgbClr val="FFFFFF"/>
-          </a:solidFill>
-          <a:ln w="12700">
-            <a:solidFill>
-              <a:srgbClr val="E1E5E9"/>
-            </a:solidFill>
-          </a:ln>
-        </p:spPr>
-        <p:style>
-          <a:lnRef idx="1">
-            <a:schemeClr val="accent1"/>
-          </a:lnRef>
-          <a:fillRef idx="3">
-            <a:schemeClr val="accent1"/>
-          </a:fillRef>
-          <a:effectRef idx="2">
-            <a:schemeClr val="accent1"/>
-          </a:effectRef>
-          <a:fontRef idx="minor">
-            <a:schemeClr val="lt1"/>
-          </a:fontRef>
-        </p:style>
-        <p:txBody>
-          <a:bodyPr rtlCol="0" anchor="ctr"/>
-          <a:lstStyle/>
-          <a:p>
-            <a:pPr algn="ctr"/>
-          </a:p>
-        </p:txBody>
-      </p:sp>
-      <p:sp>
-        <p:nvSpPr>
-          <p:cNvPr id="6" name="TextBox 5"/>
+              <a:defRPr sz="12000" b="1">
+                <a:solidFill>
+                  <a:srgbClr val="333DA0"/>
+                </a:solidFill>
+                <a:latin typeface="Microsoft YaHei"/>
+              </a:defRPr>
+            </a:pPr>
+            <a:r>
+              <a:t>10</a:t>
+            </a:r>
+          </a:p>
+        </p:txBody>
+      </p:sp>
+      <p:sp>
+        <p:nvSpPr>
+          <p:cNvPr id="5" name="TextBox 4"/>
           <p:cNvSpPr txBox="1"/>
           <p:nvPr/>
         </p:nvSpPr>
         <p:spPr>
           <a:xfrm>
-            <a:off x="777240" y="1417320"/>
-            <a:ext cx="10972800" cy="5029200"/>
-          </a:xfrm>
-          <a:prstGeom prst="rect">
-            <a:avLst/>
-          </a:prstGeom>
-          <a:noFill/>
-        </p:spPr>
-        <p:txBody>
-          <a:bodyPr wrap="square">
-            <a:spAutoFit/>
-          </a:bodyPr>
-          <a:lstStyle/>
-          <a:p>
-            <a:pPr algn="l">
-              <a:spcAft>
-                <a:spcPts val="1200"/>
-              </a:spcAft>
-              <a:defRPr sz="1800" b="0">
-                <a:solidFill>
-                  <a:srgbClr val="1E2933"/>
-                </a:solidFill>
-                <a:latin typeface="Microsoft YaHei"/>
-              </a:defRPr>
-            </a:pPr>
-            <a:r>
-              <a:t>  在真实游戏运行中触发 code-file 更新，验证动态 stall/composite 下 L2 的决策质量</a:t>
-            </a:r>
-          </a:p>
-          <a:p>
-            <a:pPr algn="l">
-              <a:spcAft>
-                <a:spcPts val="1200"/>
-              </a:spcAft>
-              <a:defRPr sz="1800" b="0">
-                <a:solidFill>
-                  <a:srgbClr val="1E2933"/>
-                </a:solidFill>
-                <a:latin typeface="Microsoft YaHei"/>
-              </a:defRPr>
-            </a:pPr>
-            <a:r>
-              <a:t>  把 runtime_rules.json 的 schema 写进 L2 prompt，约束可改字段与取值范围</a:t>
-            </a:r>
-          </a:p>
-          <a:p>
-            <a:pPr algn="l">
-              <a:spcAft>
-                <a:spcPts val="1200"/>
-              </a:spcAft>
-              <a:defRPr sz="1800" b="0">
-                <a:solidFill>
-                  <a:srgbClr val="1E2933"/>
-                </a:solidFill>
-                <a:latin typeface="Microsoft YaHei"/>
-              </a:defRPr>
-            </a:pPr>
-            <a:r>
-              <a:t>  让本地 VLM 常驻，验证 L1 战术修正对 joystick 游戏的实际收益</a:t>
-            </a:r>
-          </a:p>
-          <a:p>
-            <a:pPr algn="l">
-              <a:spcAft>
-                <a:spcPts val="1200"/>
-              </a:spcAft>
-              <a:defRPr sz="1800" b="0">
-                <a:solidFill>
-                  <a:srgbClr val="1E2933"/>
-                </a:solidFill>
-                <a:latin typeface="Microsoft YaHei"/>
-              </a:defRPr>
-            </a:pPr>
-            <a:r>
-              <a:t>  在 5090 服务器跑 QLoRA 微调，把本地 VLM 训练成专用画面理解器</a:t>
-            </a:r>
-          </a:p>
-          <a:p>
-            <a:pPr algn="l">
-              <a:spcAft>
-                <a:spcPts val="1200"/>
-              </a:spcAft>
-              <a:defRPr sz="1800" b="0">
-                <a:solidFill>
-                  <a:srgbClr val="1E2933"/>
-                </a:solidFill>
-                <a:latin typeface="Microsoft YaHei"/>
-              </a:defRPr>
-            </a:pPr>
-            <a:r>
-              <a:t>  把离线回放接入 CI：每次规则改动自动跑 5 游戏回归</a:t>
-            </a:r>
-          </a:p>
-          <a:p>
-            <a:pPr algn="l">
-              <a:spcAft>
-                <a:spcPts val="1200"/>
-              </a:spcAft>
-              <a:defRPr sz="1800" b="0">
-                <a:solidFill>
-                  <a:srgbClr val="1E2933"/>
-                </a:solidFill>
-                <a:latin typeface="Microsoft YaHei"/>
-              </a:defRPr>
-            </a:pPr>
-            <a:r>
-              <a:t>  探索 Agent 间更严格的仲裁：Critic 对 L0/L2 冲突做最终决策</a:t>
-            </a:r>
-          </a:p>
-          <a:p>
-            <a:pPr algn="l">
-              <a:spcAft>
-                <a:spcPts val="1200"/>
-              </a:spcAft>
-              <a:defRPr sz="1800" b="0">
-                <a:solidFill>
-                  <a:srgbClr val="1E2933"/>
-                </a:solidFill>
-                <a:latin typeface="Microsoft YaHei"/>
-              </a:defRPr>
-            </a:pPr>
-            <a:r>
-              <a:t>   redesign strategy_memory 的 success 信号：结合位置变化、guide 触发、stall 减少</a:t>
-            </a:r>
-          </a:p>
-        </p:txBody>
-      </p:sp>
-      <p:sp>
-        <p:nvSpPr>
-          <p:cNvPr id="7" name="Oval 6"/>
-          <p:cNvSpPr/>
-          <p:nvPr/>
-        </p:nvSpPr>
-        <p:spPr>
-          <a:xfrm>
-            <a:off x="45720" y="0"/>
-            <a:ext cx="137160" cy="137160"/>
-          </a:xfrm>
-          <a:prstGeom prst="ellipse">
-            <a:avLst/>
-          </a:prstGeom>
-          <a:solidFill>
-            <a:srgbClr val="0096C7"/>
-          </a:solidFill>
-          <a:ln/>
-        </p:spPr>
-        <p:style>
-          <a:lnRef idx="1">
-            <a:schemeClr val="accent1"/>
-          </a:lnRef>
-          <a:fillRef idx="3">
-            <a:schemeClr val="accent1"/>
-          </a:fillRef>
-          <a:effectRef idx="2">
-            <a:schemeClr val="accent1"/>
-          </a:effectRef>
-          <a:fontRef idx="minor">
-            <a:schemeClr val="lt1"/>
-          </a:fontRef>
-        </p:style>
-        <p:txBody>
-          <a:bodyPr rtlCol="0" anchor="ctr"/>
-          <a:lstStyle/>
-          <a:p>
-            <a:pPr algn="ctr"/>
-          </a:p>
-        </p:txBody>
-      </p:sp>
-      <p:sp>
-        <p:nvSpPr>
-          <p:cNvPr id="8" name="Oval 7"/>
-          <p:cNvSpPr/>
-          <p:nvPr/>
-        </p:nvSpPr>
-        <p:spPr>
-          <a:xfrm>
-            <a:off x="45720" y="0"/>
-            <a:ext cx="137160" cy="137160"/>
-          </a:xfrm>
-          <a:prstGeom prst="ellipse">
-            <a:avLst/>
-          </a:prstGeom>
-          <a:solidFill>
-            <a:srgbClr val="0096C7"/>
-          </a:solidFill>
-          <a:ln/>
-        </p:spPr>
-        <p:style>
-          <a:lnRef idx="1">
-            <a:schemeClr val="accent1"/>
-          </a:lnRef>
-          <a:fillRef idx="3">
-            <a:schemeClr val="accent1"/>
-          </a:fillRef>
-          <a:effectRef idx="2">
-            <a:schemeClr val="accent1"/>
-          </a:effectRef>
-          <a:fontRef idx="minor">
-            <a:schemeClr val="lt1"/>
-          </a:fontRef>
-        </p:style>
-        <p:txBody>
-          <a:bodyPr rtlCol="0" anchor="ctr"/>
-          <a:lstStyle/>
-          <a:p>
-            <a:pPr algn="ctr"/>
-          </a:p>
-        </p:txBody>
-      </p:sp>
-      <p:sp>
-        <p:nvSpPr>
-          <p:cNvPr id="9" name="Oval 8"/>
-          <p:cNvSpPr/>
-          <p:nvPr/>
-        </p:nvSpPr>
-        <p:spPr>
-          <a:xfrm>
-            <a:off x="45720" y="0"/>
-            <a:ext cx="137160" cy="137160"/>
-          </a:xfrm>
-          <a:prstGeom prst="ellipse">
-            <a:avLst/>
-          </a:prstGeom>
-          <a:solidFill>
-            <a:srgbClr val="0096C7"/>
-          </a:solidFill>
-          <a:ln/>
-        </p:spPr>
-        <p:style>
-          <a:lnRef idx="1">
-            <a:schemeClr val="accent1"/>
-          </a:lnRef>
-          <a:fillRef idx="3">
-            <a:schemeClr val="accent1"/>
-          </a:fillRef>
-          <a:effectRef idx="2">
-            <a:schemeClr val="accent1"/>
-          </a:effectRef>
-          <a:fontRef idx="minor">
-            <a:schemeClr val="lt1"/>
-          </a:fontRef>
-        </p:style>
-        <p:txBody>
-          <a:bodyPr rtlCol="0" anchor="ctr"/>
-          <a:lstStyle/>
-          <a:p>
-            <a:pPr algn="ctr"/>
-          </a:p>
-        </p:txBody>
-      </p:sp>
-      <p:sp>
-        <p:nvSpPr>
-          <p:cNvPr id="10" name="Oval 9"/>
-          <p:cNvSpPr/>
-          <p:nvPr/>
-        </p:nvSpPr>
-        <p:spPr>
-          <a:xfrm>
-            <a:off x="45720" y="0"/>
-            <a:ext cx="137160" cy="137160"/>
-          </a:xfrm>
-          <a:prstGeom prst="ellipse">
-            <a:avLst/>
-          </a:prstGeom>
-          <a:solidFill>
-            <a:srgbClr val="0096C7"/>
-          </a:solidFill>
-          <a:ln/>
-        </p:spPr>
-        <p:style>
-          <a:lnRef idx="1">
-            <a:schemeClr val="accent1"/>
-          </a:lnRef>
-          <a:fillRef idx="3">
-            <a:schemeClr val="accent1"/>
-          </a:fillRef>
-          <a:effectRef idx="2">
-            <a:schemeClr val="accent1"/>
-          </a:effectRef>
-          <a:fontRef idx="minor">
-            <a:schemeClr val="lt1"/>
-          </a:fontRef>
-        </p:style>
-        <p:txBody>
-          <a:bodyPr rtlCol="0" anchor="ctr"/>
-          <a:lstStyle/>
-          <a:p>
-            <a:pPr algn="ctr"/>
-          </a:p>
-        </p:txBody>
-      </p:sp>
-      <p:sp>
-        <p:nvSpPr>
-          <p:cNvPr id="11" name="Oval 10"/>
-          <p:cNvSpPr/>
-          <p:nvPr/>
-        </p:nvSpPr>
-        <p:spPr>
-          <a:xfrm>
-            <a:off x="45720" y="0"/>
-            <a:ext cx="137160" cy="137160"/>
-          </a:xfrm>
-          <a:prstGeom prst="ellipse">
-            <a:avLst/>
-          </a:prstGeom>
-          <a:solidFill>
-            <a:srgbClr val="0096C7"/>
-          </a:solidFill>
-          <a:ln/>
-        </p:spPr>
-        <p:style>
-          <a:lnRef idx="1">
-            <a:schemeClr val="accent1"/>
-          </a:lnRef>
-          <a:fillRef idx="3">
-            <a:schemeClr val="accent1"/>
-          </a:fillRef>
-          <a:effectRef idx="2">
-            <a:schemeClr val="accent1"/>
-          </a:effectRef>
-          <a:fontRef idx="minor">
-            <a:schemeClr val="lt1"/>
-          </a:fontRef>
-        </p:style>
-        <p:txBody>
-          <a:bodyPr rtlCol="0" anchor="ctr"/>
-          <a:lstStyle/>
-          <a:p>
-            <a:pPr algn="ctr"/>
-          </a:p>
-        </p:txBody>
-      </p:sp>
-      <p:sp>
-        <p:nvSpPr>
-          <p:cNvPr id="12" name="Oval 11"/>
-          <p:cNvSpPr/>
-          <p:nvPr/>
-        </p:nvSpPr>
-        <p:spPr>
-          <a:xfrm>
-            <a:off x="45720" y="0"/>
-            <a:ext cx="137160" cy="137160"/>
-          </a:xfrm>
-          <a:prstGeom prst="ellipse">
-            <a:avLst/>
-          </a:prstGeom>
-          <a:solidFill>
-            <a:srgbClr val="0096C7"/>
-          </a:solidFill>
-          <a:ln/>
-        </p:spPr>
-        <p:style>
-          <a:lnRef idx="1">
-            <a:schemeClr val="accent1"/>
-          </a:lnRef>
-          <a:fillRef idx="3">
-            <a:schemeClr val="accent1"/>
-          </a:fillRef>
-          <a:effectRef idx="2">
-            <a:schemeClr val="accent1"/>
-          </a:effectRef>
-          <a:fontRef idx="minor">
-            <a:schemeClr val="lt1"/>
-          </a:fontRef>
-        </p:style>
-        <p:txBody>
-          <a:bodyPr rtlCol="0" anchor="ctr"/>
-          <a:lstStyle/>
-          <a:p>
-            <a:pPr algn="ctr"/>
-          </a:p>
-        </p:txBody>
-      </p:sp>
-      <p:sp>
-        <p:nvSpPr>
-          <p:cNvPr id="13" name="Oval 12"/>
-          <p:cNvSpPr/>
-          <p:nvPr/>
-        </p:nvSpPr>
-        <p:spPr>
-          <a:xfrm>
-            <a:off x="45720" y="0"/>
-            <a:ext cx="137160" cy="137160"/>
-          </a:xfrm>
-          <a:prstGeom prst="ellipse">
-            <a:avLst/>
-          </a:prstGeom>
-          <a:solidFill>
-            <a:srgbClr val="0096C7"/>
-          </a:solidFill>
-          <a:ln/>
-        </p:spPr>
-        <p:style>
-          <a:lnRef idx="1">
-            <a:schemeClr val="accent1"/>
-          </a:lnRef>
-          <a:fillRef idx="3">
-            <a:schemeClr val="accent1"/>
-          </a:fillRef>
-          <a:effectRef idx="2">
-            <a:schemeClr val="accent1"/>
-          </a:effectRef>
-          <a:fontRef idx="minor">
-            <a:schemeClr val="lt1"/>
-          </a:fontRef>
-        </p:style>
-        <p:txBody>
-          <a:bodyPr rtlCol="0" anchor="ctr"/>
-          <a:lstStyle/>
-          <a:p>
-            <a:pPr algn="ctr"/>
-          </a:p>
-        </p:txBody>
-      </p:sp>
-      <p:sp>
-        <p:nvSpPr>
-          <p:cNvPr id="14" name="Rectangle 13"/>
-          <p:cNvSpPr/>
-          <p:nvPr/>
-        </p:nvSpPr>
-        <p:spPr>
-          <a:xfrm>
-            <a:off x="0" y="6537960"/>
-            <a:ext cx="12191695" cy="18288"/>
-          </a:xfrm>
-          <a:prstGeom prst="rect">
-            <a:avLst/>
-          </a:prstGeom>
-          <a:solidFill>
-            <a:srgbClr val="0096C7"/>
-          </a:solidFill>
-          <a:ln/>
-        </p:spPr>
-        <p:style>
-          <a:lnRef idx="1">
-            <a:schemeClr val="accent1"/>
-          </a:lnRef>
-          <a:fillRef idx="3">
-            <a:schemeClr val="accent1"/>
-          </a:fillRef>
-          <a:effectRef idx="2">
-            <a:schemeClr val="accent1"/>
-          </a:effectRef>
-          <a:fontRef idx="minor">
-            <a:schemeClr val="lt1"/>
-          </a:fontRef>
-        </p:style>
-        <p:txBody>
-          <a:bodyPr rtlCol="0" anchor="ctr"/>
-          <a:lstStyle/>
-          <a:p>
-            <a:pPr algn="ctr"/>
-          </a:p>
-        </p:txBody>
-      </p:sp>
-      <p:sp>
-        <p:nvSpPr>
-          <p:cNvPr id="15" name="TextBox 14"/>
-          <p:cNvSpPr txBox="1"/>
-          <p:nvPr/>
-        </p:nvSpPr>
-        <p:spPr>
-          <a:xfrm>
-            <a:off x="457200" y="6583680"/>
-            <a:ext cx="3657600" cy="228600"/>
+            <a:off x="548640" y="2834640"/>
+            <a:ext cx="11064240" cy="1097280"/>
           </a:xfrm>
           <a:prstGeom prst="rect">
             <a:avLst/>
@@ -24056,29 +24267,111 @@
           <a:lstStyle/>
           <a:p>
             <a:pPr algn="l">
-              <a:defRPr sz="1000" b="0">
-                <a:solidFill>
-                  <a:srgbClr val="6C757D"/>
-                </a:solidFill>
-                <a:latin typeface="Microsoft YaHei"/>
-              </a:defRPr>
-            </a:pPr>
-            <a:r>
-              <a:t>smallgameagent · LLM/VLM + 规则驱动</a:t>
-            </a:r>
-          </a:p>
-        </p:txBody>
-      </p:sp>
-      <p:sp>
-        <p:nvSpPr>
-          <p:cNvPr id="16" name="TextBox 15"/>
+              <a:defRPr sz="4400" b="1">
+                <a:solidFill>
+                  <a:srgbClr val="F3F6F9"/>
+                </a:solidFill>
+                <a:latin typeface="Microsoft YaHei"/>
+              </a:defRPr>
+            </a:pPr>
+            <a:r>
+              <a:t>下一步</a:t>
+            </a:r>
+          </a:p>
+        </p:txBody>
+      </p:sp>
+      <p:sp>
+        <p:nvSpPr>
+          <p:cNvPr id="6" name="Rectangle 5"/>
+          <p:cNvSpPr/>
+          <p:nvPr/>
+        </p:nvSpPr>
+        <p:spPr>
+          <a:xfrm>
+            <a:off x="548640" y="4023360"/>
+            <a:ext cx="1828800" cy="73152"/>
+          </a:xfrm>
+          <a:prstGeom prst="rect">
+            <a:avLst/>
+          </a:prstGeom>
+          <a:solidFill>
+            <a:srgbClr val="FF6B35"/>
+          </a:solidFill>
+          <a:ln/>
+        </p:spPr>
+        <p:style>
+          <a:lnRef idx="1">
+            <a:schemeClr val="accent1"/>
+          </a:lnRef>
+          <a:fillRef idx="3">
+            <a:schemeClr val="accent1"/>
+          </a:fillRef>
+          <a:effectRef idx="2">
+            <a:schemeClr val="accent1"/>
+          </a:effectRef>
+          <a:fontRef idx="minor">
+            <a:schemeClr val="lt1"/>
+          </a:fontRef>
+        </p:style>
+        <p:txBody>
+          <a:bodyPr rtlCol="0" anchor="ctr"/>
+          <a:lstStyle/>
+          <a:p>
+            <a:pPr algn="ctr"/>
+          </a:p>
+        </p:txBody>
+      </p:sp>
+      <p:sp>
+        <p:nvSpPr>
+          <p:cNvPr id="7" name="Rectangle 6"/>
+          <p:cNvSpPr/>
+          <p:nvPr/>
+        </p:nvSpPr>
+        <p:spPr>
+          <a:xfrm>
+            <a:off x="0" y="6537960"/>
+            <a:ext cx="12191695" cy="18288"/>
+          </a:xfrm>
+          <a:prstGeom prst="rect">
+            <a:avLst/>
+          </a:prstGeom>
+          <a:solidFill>
+            <a:srgbClr val="0096C7"/>
+          </a:solidFill>
+          <a:ln/>
+        </p:spPr>
+        <p:style>
+          <a:lnRef idx="1">
+            <a:schemeClr val="accent1"/>
+          </a:lnRef>
+          <a:fillRef idx="3">
+            <a:schemeClr val="accent1"/>
+          </a:fillRef>
+          <a:effectRef idx="2">
+            <a:schemeClr val="accent1"/>
+          </a:effectRef>
+          <a:fontRef idx="minor">
+            <a:schemeClr val="lt1"/>
+          </a:fontRef>
+        </p:style>
+        <p:txBody>
+          <a:bodyPr rtlCol="0" anchor="ctr"/>
+          <a:lstStyle/>
+          <a:p>
+            <a:pPr algn="ctr"/>
+          </a:p>
+        </p:txBody>
+      </p:sp>
+      <p:sp>
+        <p:nvSpPr>
+          <p:cNvPr id="8" name="TextBox 7"/>
           <p:cNvSpPr txBox="1"/>
           <p:nvPr/>
         </p:nvSpPr>
         <p:spPr>
           <a:xfrm>
-            <a:off x="10789920" y="6583680"/>
-            <a:ext cx="914400" cy="228600"/>
+            <a:off x="457200" y="6583680"/>
+            <a:ext cx="3657600" cy="228600"/>
           </a:xfrm>
           <a:prstGeom prst="rect">
             <a:avLst/>
@@ -24091,6 +24384,42 @@
           </a:bodyPr>
           <a:lstStyle/>
           <a:p>
+            <a:pPr algn="l">
+              <a:defRPr sz="1000" b="0">
+                <a:solidFill>
+                  <a:srgbClr val="6C757D"/>
+                </a:solidFill>
+                <a:latin typeface="Microsoft YaHei"/>
+              </a:defRPr>
+            </a:pPr>
+            <a:r>
+              <a:t>smallgameagent · LLM/VLM + 规则驱动</a:t>
+            </a:r>
+          </a:p>
+        </p:txBody>
+      </p:sp>
+      <p:sp>
+        <p:nvSpPr>
+          <p:cNvPr id="9" name="TextBox 8"/>
+          <p:cNvSpPr txBox="1"/>
+          <p:nvPr/>
+        </p:nvSpPr>
+        <p:spPr>
+          <a:xfrm>
+            <a:off x="10789920" y="6583680"/>
+            <a:ext cx="914400" cy="228600"/>
+          </a:xfrm>
+          <a:prstGeom prst="rect">
+            <a:avLst/>
+          </a:prstGeom>
+          <a:noFill/>
+        </p:spPr>
+        <p:txBody>
+          <a:bodyPr wrap="none">
+            <a:spAutoFit/>
+          </a:bodyPr>
+          <a:lstStyle/>
+          <a:p>
             <a:pPr algn="r">
               <a:defRPr sz="1000" b="0">
                 <a:solidFill>
@@ -24100,7 +24429,7 @@
               </a:defRPr>
             </a:pPr>
             <a:r>
-              <a:t>38/39</a:t>
+              <a:t>38/40</a:t>
             </a:r>
           </a:p>
         </p:txBody>
@@ -24132,7 +24461,7 @@
         <p:spPr>
           <a:xfrm>
             <a:off x="0" y="0"/>
-            <a:ext cx="12191695" cy="6858000"/>
+            <a:ext cx="12191695" cy="960120"/>
           </a:xfrm>
           <a:prstGeom prst="rect">
             <a:avLst/>
@@ -24166,146 +24495,14 @@
       </p:sp>
       <p:sp>
         <p:nvSpPr>
-          <p:cNvPr id="3" name="Oval 2"/>
-          <p:cNvSpPr/>
-          <p:nvPr/>
-        </p:nvSpPr>
-        <p:spPr>
-          <a:xfrm>
-            <a:off x="9144000" y="914400"/>
-            <a:ext cx="1371600" cy="1371600"/>
-          </a:xfrm>
-          <a:prstGeom prst="ellipse">
-            <a:avLst/>
-          </a:prstGeom>
-          <a:solidFill>
-            <a:srgbClr val="0096C7">
-              <a:lumMod val="70000"/>
-              <a:lumOff val="30000"/>
-            </a:srgbClr>
-          </a:solidFill>
-          <a:ln/>
-        </p:spPr>
-        <p:style>
-          <a:lnRef idx="1">
-            <a:schemeClr val="accent1"/>
-          </a:lnRef>
-          <a:fillRef idx="3">
-            <a:schemeClr val="accent1"/>
-          </a:fillRef>
-          <a:effectRef idx="2">
-            <a:schemeClr val="accent1"/>
-          </a:effectRef>
-          <a:fontRef idx="minor">
-            <a:schemeClr val="lt1"/>
-          </a:fontRef>
-        </p:style>
-        <p:txBody>
-          <a:bodyPr rtlCol="0" anchor="ctr"/>
-          <a:lstStyle/>
-          <a:p>
-            <a:pPr algn="ctr"/>
-          </a:p>
-        </p:txBody>
-      </p:sp>
-      <p:sp>
-        <p:nvSpPr>
-          <p:cNvPr id="4" name="Oval 3"/>
-          <p:cNvSpPr/>
-          <p:nvPr/>
-        </p:nvSpPr>
-        <p:spPr>
-          <a:xfrm>
-            <a:off x="9784080" y="1371600"/>
-            <a:ext cx="1371600" cy="1371600"/>
-          </a:xfrm>
-          <a:prstGeom prst="ellipse">
-            <a:avLst/>
-          </a:prstGeom>
-          <a:solidFill>
-            <a:srgbClr val="0096C7">
-              <a:lumMod val="70000"/>
-              <a:lumOff val="30000"/>
-            </a:srgbClr>
-          </a:solidFill>
-          <a:ln/>
-        </p:spPr>
-        <p:style>
-          <a:lnRef idx="1">
-            <a:schemeClr val="accent1"/>
-          </a:lnRef>
-          <a:fillRef idx="3">
-            <a:schemeClr val="accent1"/>
-          </a:fillRef>
-          <a:effectRef idx="2">
-            <a:schemeClr val="accent1"/>
-          </a:effectRef>
-          <a:fontRef idx="minor">
-            <a:schemeClr val="lt1"/>
-          </a:fontRef>
-        </p:style>
-        <p:txBody>
-          <a:bodyPr rtlCol="0" anchor="ctr"/>
-          <a:lstStyle/>
-          <a:p>
-            <a:pPr algn="ctr"/>
-          </a:p>
-        </p:txBody>
-      </p:sp>
-      <p:sp>
-        <p:nvSpPr>
-          <p:cNvPr id="5" name="Oval 4"/>
-          <p:cNvSpPr/>
-          <p:nvPr/>
-        </p:nvSpPr>
-        <p:spPr>
-          <a:xfrm>
-            <a:off x="10424160" y="1828800"/>
-            <a:ext cx="1371600" cy="1371600"/>
-          </a:xfrm>
-          <a:prstGeom prst="ellipse">
-            <a:avLst/>
-          </a:prstGeom>
-          <a:solidFill>
-            <a:srgbClr val="0096C7">
-              <a:lumMod val="70000"/>
-              <a:lumOff val="30000"/>
-            </a:srgbClr>
-          </a:solidFill>
-          <a:ln/>
-        </p:spPr>
-        <p:style>
-          <a:lnRef idx="1">
-            <a:schemeClr val="accent1"/>
-          </a:lnRef>
-          <a:fillRef idx="3">
-            <a:schemeClr val="accent1"/>
-          </a:fillRef>
-          <a:effectRef idx="2">
-            <a:schemeClr val="accent1"/>
-          </a:effectRef>
-          <a:fontRef idx="minor">
-            <a:schemeClr val="lt1"/>
-          </a:fontRef>
-        </p:style>
-        <p:txBody>
-          <a:bodyPr rtlCol="0" anchor="ctr"/>
-          <a:lstStyle/>
-          <a:p>
-            <a:pPr algn="ctr"/>
-          </a:p>
-        </p:txBody>
-      </p:sp>
-      <p:sp>
-        <p:nvSpPr>
-          <p:cNvPr id="6" name="TextBox 5"/>
+          <p:cNvPr id="3" name="TextBox 2"/>
           <p:cNvSpPr txBox="1"/>
           <p:nvPr/>
         </p:nvSpPr>
         <p:spPr>
           <a:xfrm>
-            <a:off x="457200" y="2651760"/>
-            <a:ext cx="11247120" cy="1280160"/>
+            <a:off x="457200" y="228600"/>
+            <a:ext cx="11247120" cy="548640"/>
           </a:xfrm>
           <a:prstGeom prst="rect">
             <a:avLst/>
@@ -24318,8 +24515,8 @@
           </a:bodyPr>
           <a:lstStyle/>
           <a:p>
-            <a:pPr algn="ctr">
-              <a:defRPr sz="4800" b="1">
+            <a:pPr algn="l">
+              <a:defRPr sz="3000" b="1">
                 <a:solidFill>
                   <a:srgbClr val="F3F6F9"/>
                 </a:solidFill>
@@ -24327,27 +24524,27 @@
               </a:defRPr>
             </a:pPr>
             <a:r>
-              <a:t>谢谢，欢迎讨论</a:t>
-            </a:r>
-          </a:p>
-        </p:txBody>
-      </p:sp>
-      <p:sp>
-        <p:nvSpPr>
-          <p:cNvPr id="7" name="Rectangle 6"/>
-          <p:cNvSpPr/>
-          <p:nvPr/>
-        </p:nvSpPr>
-        <p:spPr>
-          <a:xfrm>
-            <a:off x="5184648" y="3931920"/>
-            <a:ext cx="1828800" cy="73152"/>
-          </a:xfrm>
-          <a:prstGeom prst="rect">
-            <a:avLst/>
-          </a:prstGeom>
-          <a:solidFill>
-            <a:srgbClr val="FF6B35"/>
+              <a:t>下一步：把实验变成稳定系统</a:t>
+            </a:r>
+          </a:p>
+        </p:txBody>
+      </p:sp>
+      <p:sp>
+        <p:nvSpPr>
+          <p:cNvPr id="4" name="Rectangle 3"/>
+          <p:cNvSpPr/>
+          <p:nvPr/>
+        </p:nvSpPr>
+        <p:spPr>
+          <a:xfrm>
+            <a:off x="0" y="960120"/>
+            <a:ext cx="164592" cy="5897880"/>
+          </a:xfrm>
+          <a:prstGeom prst="rect">
+            <a:avLst/>
+          </a:prstGeom>
+          <a:solidFill>
+            <a:srgbClr val="0096C7"/>
           </a:solidFill>
           <a:ln/>
         </p:spPr>
@@ -24375,7 +24572,474 @@
       </p:sp>
       <p:sp>
         <p:nvSpPr>
-          <p:cNvPr id="8" name="Rectangle 7"/>
+          <p:cNvPr id="5" name="Rectangle 4"/>
+          <p:cNvSpPr/>
+          <p:nvPr/>
+        </p:nvSpPr>
+        <p:spPr>
+          <a:xfrm>
+            <a:off x="320040" y="1078992"/>
+            <a:ext cx="11548872" cy="5349240"/>
+          </a:xfrm>
+          <a:prstGeom prst="rect">
+            <a:avLst/>
+          </a:prstGeom>
+          <a:solidFill>
+            <a:srgbClr val="FFFFFF"/>
+          </a:solidFill>
+          <a:ln w="12700">
+            <a:solidFill>
+              <a:srgbClr val="E1E5E9"/>
+            </a:solidFill>
+          </a:ln>
+        </p:spPr>
+        <p:style>
+          <a:lnRef idx="1">
+            <a:schemeClr val="accent1"/>
+          </a:lnRef>
+          <a:fillRef idx="3">
+            <a:schemeClr val="accent1"/>
+          </a:fillRef>
+          <a:effectRef idx="2">
+            <a:schemeClr val="accent1"/>
+          </a:effectRef>
+          <a:fontRef idx="minor">
+            <a:schemeClr val="lt1"/>
+          </a:fontRef>
+        </p:style>
+        <p:txBody>
+          <a:bodyPr rtlCol="0" anchor="ctr"/>
+          <a:lstStyle/>
+          <a:p>
+            <a:pPr algn="ctr"/>
+          </a:p>
+        </p:txBody>
+      </p:sp>
+      <p:sp>
+        <p:nvSpPr>
+          <p:cNvPr id="6" name="TextBox 5"/>
+          <p:cNvSpPr txBox="1"/>
+          <p:nvPr/>
+        </p:nvSpPr>
+        <p:spPr>
+          <a:xfrm>
+            <a:off x="777240" y="1417320"/>
+            <a:ext cx="10972800" cy="5029200"/>
+          </a:xfrm>
+          <a:prstGeom prst="rect">
+            <a:avLst/>
+          </a:prstGeom>
+          <a:noFill/>
+        </p:spPr>
+        <p:txBody>
+          <a:bodyPr wrap="square">
+            <a:spAutoFit/>
+          </a:bodyPr>
+          <a:lstStyle/>
+          <a:p>
+            <a:pPr algn="l">
+              <a:spcAft>
+                <a:spcPts val="1200"/>
+              </a:spcAft>
+              <a:defRPr sz="1800" b="0">
+                <a:solidFill>
+                  <a:srgbClr val="1E2933"/>
+                </a:solidFill>
+                <a:latin typeface="Microsoft YaHei"/>
+              </a:defRPr>
+            </a:pPr>
+            <a:r>
+              <a:t>  在真实游戏运行中触发 code-file 更新，验证动态 stall/composite 下 L2 的决策质量</a:t>
+            </a:r>
+          </a:p>
+          <a:p>
+            <a:pPr algn="l">
+              <a:spcAft>
+                <a:spcPts val="1200"/>
+              </a:spcAft>
+              <a:defRPr sz="1800" b="0">
+                <a:solidFill>
+                  <a:srgbClr val="1E2933"/>
+                </a:solidFill>
+                <a:latin typeface="Microsoft YaHei"/>
+              </a:defRPr>
+            </a:pPr>
+            <a:r>
+              <a:t>  把 runtime_rules.json 的 schema 写进 L2 prompt，约束可改字段与取值范围</a:t>
+            </a:r>
+          </a:p>
+          <a:p>
+            <a:pPr algn="l">
+              <a:spcAft>
+                <a:spcPts val="1200"/>
+              </a:spcAft>
+              <a:defRPr sz="1800" b="0">
+                <a:solidFill>
+                  <a:srgbClr val="1E2933"/>
+                </a:solidFill>
+                <a:latin typeface="Microsoft YaHei"/>
+              </a:defRPr>
+            </a:pPr>
+            <a:r>
+              <a:t>  让本地 VLM 常驻，验证 L1 战术修正对 joystick 游戏的实际收益</a:t>
+            </a:r>
+          </a:p>
+          <a:p>
+            <a:pPr algn="l">
+              <a:spcAft>
+                <a:spcPts val="1200"/>
+              </a:spcAft>
+              <a:defRPr sz="1800" b="0">
+                <a:solidFill>
+                  <a:srgbClr val="1E2933"/>
+                </a:solidFill>
+                <a:latin typeface="Microsoft YaHei"/>
+              </a:defRPr>
+            </a:pPr>
+            <a:r>
+              <a:t>  在 5090 服务器跑 QLoRA 微调，把本地 VLM 训练成专用画面理解器</a:t>
+            </a:r>
+          </a:p>
+          <a:p>
+            <a:pPr algn="l">
+              <a:spcAft>
+                <a:spcPts val="1200"/>
+              </a:spcAft>
+              <a:defRPr sz="1800" b="0">
+                <a:solidFill>
+                  <a:srgbClr val="1E2933"/>
+                </a:solidFill>
+                <a:latin typeface="Microsoft YaHei"/>
+              </a:defRPr>
+            </a:pPr>
+            <a:r>
+              <a:t>  把离线回放接入 CI：每次规则改动自动跑 5 游戏回归</a:t>
+            </a:r>
+          </a:p>
+          <a:p>
+            <a:pPr algn="l">
+              <a:spcAft>
+                <a:spcPts val="1200"/>
+              </a:spcAft>
+              <a:defRPr sz="1800" b="0">
+                <a:solidFill>
+                  <a:srgbClr val="1E2933"/>
+                </a:solidFill>
+                <a:latin typeface="Microsoft YaHei"/>
+              </a:defRPr>
+            </a:pPr>
+            <a:r>
+              <a:t>  探索 Agent 间更严格的仲裁：Critic 对 L0/L2 冲突做最终决策</a:t>
+            </a:r>
+          </a:p>
+          <a:p>
+            <a:pPr algn="l">
+              <a:spcAft>
+                <a:spcPts val="1200"/>
+              </a:spcAft>
+              <a:defRPr sz="1800" b="0">
+                <a:solidFill>
+                  <a:srgbClr val="1E2933"/>
+                </a:solidFill>
+                <a:latin typeface="Microsoft YaHei"/>
+              </a:defRPr>
+            </a:pPr>
+            <a:r>
+              <a:t>   redesign strategy_memory 的 success 信号：结合位置变化、guide 触发、stall 减少</a:t>
+            </a:r>
+          </a:p>
+        </p:txBody>
+      </p:sp>
+      <p:sp>
+        <p:nvSpPr>
+          <p:cNvPr id="7" name="Oval 6"/>
+          <p:cNvSpPr/>
+          <p:nvPr/>
+        </p:nvSpPr>
+        <p:spPr>
+          <a:xfrm>
+            <a:off x="45720" y="0"/>
+            <a:ext cx="137160" cy="137160"/>
+          </a:xfrm>
+          <a:prstGeom prst="ellipse">
+            <a:avLst/>
+          </a:prstGeom>
+          <a:solidFill>
+            <a:srgbClr val="0096C7"/>
+          </a:solidFill>
+          <a:ln/>
+        </p:spPr>
+        <p:style>
+          <a:lnRef idx="1">
+            <a:schemeClr val="accent1"/>
+          </a:lnRef>
+          <a:fillRef idx="3">
+            <a:schemeClr val="accent1"/>
+          </a:fillRef>
+          <a:effectRef idx="2">
+            <a:schemeClr val="accent1"/>
+          </a:effectRef>
+          <a:fontRef idx="minor">
+            <a:schemeClr val="lt1"/>
+          </a:fontRef>
+        </p:style>
+        <p:txBody>
+          <a:bodyPr rtlCol="0" anchor="ctr"/>
+          <a:lstStyle/>
+          <a:p>
+            <a:pPr algn="ctr"/>
+          </a:p>
+        </p:txBody>
+      </p:sp>
+      <p:sp>
+        <p:nvSpPr>
+          <p:cNvPr id="8" name="Oval 7"/>
+          <p:cNvSpPr/>
+          <p:nvPr/>
+        </p:nvSpPr>
+        <p:spPr>
+          <a:xfrm>
+            <a:off x="45720" y="0"/>
+            <a:ext cx="137160" cy="137160"/>
+          </a:xfrm>
+          <a:prstGeom prst="ellipse">
+            <a:avLst/>
+          </a:prstGeom>
+          <a:solidFill>
+            <a:srgbClr val="0096C7"/>
+          </a:solidFill>
+          <a:ln/>
+        </p:spPr>
+        <p:style>
+          <a:lnRef idx="1">
+            <a:schemeClr val="accent1"/>
+          </a:lnRef>
+          <a:fillRef idx="3">
+            <a:schemeClr val="accent1"/>
+          </a:fillRef>
+          <a:effectRef idx="2">
+            <a:schemeClr val="accent1"/>
+          </a:effectRef>
+          <a:fontRef idx="minor">
+            <a:schemeClr val="lt1"/>
+          </a:fontRef>
+        </p:style>
+        <p:txBody>
+          <a:bodyPr rtlCol="0" anchor="ctr"/>
+          <a:lstStyle/>
+          <a:p>
+            <a:pPr algn="ctr"/>
+          </a:p>
+        </p:txBody>
+      </p:sp>
+      <p:sp>
+        <p:nvSpPr>
+          <p:cNvPr id="9" name="Oval 8"/>
+          <p:cNvSpPr/>
+          <p:nvPr/>
+        </p:nvSpPr>
+        <p:spPr>
+          <a:xfrm>
+            <a:off x="45720" y="0"/>
+            <a:ext cx="137160" cy="137160"/>
+          </a:xfrm>
+          <a:prstGeom prst="ellipse">
+            <a:avLst/>
+          </a:prstGeom>
+          <a:solidFill>
+            <a:srgbClr val="0096C7"/>
+          </a:solidFill>
+          <a:ln/>
+        </p:spPr>
+        <p:style>
+          <a:lnRef idx="1">
+            <a:schemeClr val="accent1"/>
+          </a:lnRef>
+          <a:fillRef idx="3">
+            <a:schemeClr val="accent1"/>
+          </a:fillRef>
+          <a:effectRef idx="2">
+            <a:schemeClr val="accent1"/>
+          </a:effectRef>
+          <a:fontRef idx="minor">
+            <a:schemeClr val="lt1"/>
+          </a:fontRef>
+        </p:style>
+        <p:txBody>
+          <a:bodyPr rtlCol="0" anchor="ctr"/>
+          <a:lstStyle/>
+          <a:p>
+            <a:pPr algn="ctr"/>
+          </a:p>
+        </p:txBody>
+      </p:sp>
+      <p:sp>
+        <p:nvSpPr>
+          <p:cNvPr id="10" name="Oval 9"/>
+          <p:cNvSpPr/>
+          <p:nvPr/>
+        </p:nvSpPr>
+        <p:spPr>
+          <a:xfrm>
+            <a:off x="45720" y="0"/>
+            <a:ext cx="137160" cy="137160"/>
+          </a:xfrm>
+          <a:prstGeom prst="ellipse">
+            <a:avLst/>
+          </a:prstGeom>
+          <a:solidFill>
+            <a:srgbClr val="0096C7"/>
+          </a:solidFill>
+          <a:ln/>
+        </p:spPr>
+        <p:style>
+          <a:lnRef idx="1">
+            <a:schemeClr val="accent1"/>
+          </a:lnRef>
+          <a:fillRef idx="3">
+            <a:schemeClr val="accent1"/>
+          </a:fillRef>
+          <a:effectRef idx="2">
+            <a:schemeClr val="accent1"/>
+          </a:effectRef>
+          <a:fontRef idx="minor">
+            <a:schemeClr val="lt1"/>
+          </a:fontRef>
+        </p:style>
+        <p:txBody>
+          <a:bodyPr rtlCol="0" anchor="ctr"/>
+          <a:lstStyle/>
+          <a:p>
+            <a:pPr algn="ctr"/>
+          </a:p>
+        </p:txBody>
+      </p:sp>
+      <p:sp>
+        <p:nvSpPr>
+          <p:cNvPr id="11" name="Oval 10"/>
+          <p:cNvSpPr/>
+          <p:nvPr/>
+        </p:nvSpPr>
+        <p:spPr>
+          <a:xfrm>
+            <a:off x="45720" y="0"/>
+            <a:ext cx="137160" cy="137160"/>
+          </a:xfrm>
+          <a:prstGeom prst="ellipse">
+            <a:avLst/>
+          </a:prstGeom>
+          <a:solidFill>
+            <a:srgbClr val="0096C7"/>
+          </a:solidFill>
+          <a:ln/>
+        </p:spPr>
+        <p:style>
+          <a:lnRef idx="1">
+            <a:schemeClr val="accent1"/>
+          </a:lnRef>
+          <a:fillRef idx="3">
+            <a:schemeClr val="accent1"/>
+          </a:fillRef>
+          <a:effectRef idx="2">
+            <a:schemeClr val="accent1"/>
+          </a:effectRef>
+          <a:fontRef idx="minor">
+            <a:schemeClr val="lt1"/>
+          </a:fontRef>
+        </p:style>
+        <p:txBody>
+          <a:bodyPr rtlCol="0" anchor="ctr"/>
+          <a:lstStyle/>
+          <a:p>
+            <a:pPr algn="ctr"/>
+          </a:p>
+        </p:txBody>
+      </p:sp>
+      <p:sp>
+        <p:nvSpPr>
+          <p:cNvPr id="12" name="Oval 11"/>
+          <p:cNvSpPr/>
+          <p:nvPr/>
+        </p:nvSpPr>
+        <p:spPr>
+          <a:xfrm>
+            <a:off x="45720" y="0"/>
+            <a:ext cx="137160" cy="137160"/>
+          </a:xfrm>
+          <a:prstGeom prst="ellipse">
+            <a:avLst/>
+          </a:prstGeom>
+          <a:solidFill>
+            <a:srgbClr val="0096C7"/>
+          </a:solidFill>
+          <a:ln/>
+        </p:spPr>
+        <p:style>
+          <a:lnRef idx="1">
+            <a:schemeClr val="accent1"/>
+          </a:lnRef>
+          <a:fillRef idx="3">
+            <a:schemeClr val="accent1"/>
+          </a:fillRef>
+          <a:effectRef idx="2">
+            <a:schemeClr val="accent1"/>
+          </a:effectRef>
+          <a:fontRef idx="minor">
+            <a:schemeClr val="lt1"/>
+          </a:fontRef>
+        </p:style>
+        <p:txBody>
+          <a:bodyPr rtlCol="0" anchor="ctr"/>
+          <a:lstStyle/>
+          <a:p>
+            <a:pPr algn="ctr"/>
+          </a:p>
+        </p:txBody>
+      </p:sp>
+      <p:sp>
+        <p:nvSpPr>
+          <p:cNvPr id="13" name="Oval 12"/>
+          <p:cNvSpPr/>
+          <p:nvPr/>
+        </p:nvSpPr>
+        <p:spPr>
+          <a:xfrm>
+            <a:off x="45720" y="0"/>
+            <a:ext cx="137160" cy="137160"/>
+          </a:xfrm>
+          <a:prstGeom prst="ellipse">
+            <a:avLst/>
+          </a:prstGeom>
+          <a:solidFill>
+            <a:srgbClr val="0096C7"/>
+          </a:solidFill>
+          <a:ln/>
+        </p:spPr>
+        <p:style>
+          <a:lnRef idx="1">
+            <a:schemeClr val="accent1"/>
+          </a:lnRef>
+          <a:fillRef idx="3">
+            <a:schemeClr val="accent1"/>
+          </a:fillRef>
+          <a:effectRef idx="2">
+            <a:schemeClr val="accent1"/>
+          </a:effectRef>
+          <a:fontRef idx="minor">
+            <a:schemeClr val="lt1"/>
+          </a:fontRef>
+        </p:style>
+        <p:txBody>
+          <a:bodyPr rtlCol="0" anchor="ctr"/>
+          <a:lstStyle/>
+          <a:p>
+            <a:pPr algn="ctr"/>
+          </a:p>
+        </p:txBody>
+      </p:sp>
+      <p:sp>
+        <p:nvSpPr>
+          <p:cNvPr id="14" name="Rectangle 13"/>
           <p:cNvSpPr/>
           <p:nvPr/>
         </p:nvSpPr>
@@ -24416,7 +25080,7 @@
       </p:sp>
       <p:sp>
         <p:nvSpPr>
-          <p:cNvPr id="9" name="TextBox 8"/>
+          <p:cNvPr id="15" name="TextBox 14"/>
           <p:cNvSpPr txBox="1"/>
           <p:nvPr/>
         </p:nvSpPr>
@@ -24452,7 +25116,7 @@
       </p:sp>
       <p:sp>
         <p:nvSpPr>
-          <p:cNvPr id="10" name="TextBox 9"/>
+          <p:cNvPr id="16" name="TextBox 15"/>
           <p:cNvSpPr txBox="1"/>
           <p:nvPr/>
         </p:nvSpPr>
@@ -24481,7 +25145,7 @@
               </a:defRPr>
             </a:pPr>
             <a:r>
-              <a:t>39/39</a:t>
+              <a:t>39/40</a:t>
             </a:r>
           </a:p>
         </p:txBody>
@@ -25821,7 +26485,388 @@
               </a:defRPr>
             </a:pPr>
             <a:r>
-              <a:t>4/39</a:t>
+              <a:t>4/40</a:t>
+            </a:r>
+          </a:p>
+        </p:txBody>
+      </p:sp>
+    </p:spTree>
+  </p:cSld>
+  <p:clrMapOvr>
+    <a:masterClrMapping/>
+  </p:clrMapOvr>
+</p:sld>
+</file>
+
+<file path=ppt/slides/slide40.xml><?xml version="1.0" encoding="utf-8"?>
+<p:sld xmlns:a="http://schemas.openxmlformats.org/drawingml/2006/main" xmlns:p="http://schemas.openxmlformats.org/presentationml/2006/main" xmlns:r="http://schemas.openxmlformats.org/officeDocument/2006/relationships">
+  <p:cSld>
+    <p:spTree>
+      <p:nvGrpSpPr>
+        <p:cNvPr id="1" name=""/>
+        <p:cNvGrpSpPr/>
+        <p:nvPr/>
+      </p:nvGrpSpPr>
+      <p:grpSpPr/>
+      <p:sp>
+        <p:nvSpPr>
+          <p:cNvPr id="2" name="Rectangle 1"/>
+          <p:cNvSpPr/>
+          <p:nvPr/>
+        </p:nvSpPr>
+        <p:spPr>
+          <a:xfrm>
+            <a:off x="0" y="0"/>
+            <a:ext cx="12191695" cy="6858000"/>
+          </a:xfrm>
+          <a:prstGeom prst="rect">
+            <a:avLst/>
+          </a:prstGeom>
+          <a:solidFill>
+            <a:srgbClr val="1A237E"/>
+          </a:solidFill>
+          <a:ln/>
+        </p:spPr>
+        <p:style>
+          <a:lnRef idx="1">
+            <a:schemeClr val="accent1"/>
+          </a:lnRef>
+          <a:fillRef idx="3">
+            <a:schemeClr val="accent1"/>
+          </a:fillRef>
+          <a:effectRef idx="2">
+            <a:schemeClr val="accent1"/>
+          </a:effectRef>
+          <a:fontRef idx="minor">
+            <a:schemeClr val="lt1"/>
+          </a:fontRef>
+        </p:style>
+        <p:txBody>
+          <a:bodyPr rtlCol="0" anchor="ctr"/>
+          <a:lstStyle/>
+          <a:p>
+            <a:pPr algn="ctr"/>
+          </a:p>
+        </p:txBody>
+      </p:sp>
+      <p:sp>
+        <p:nvSpPr>
+          <p:cNvPr id="3" name="Oval 2"/>
+          <p:cNvSpPr/>
+          <p:nvPr/>
+        </p:nvSpPr>
+        <p:spPr>
+          <a:xfrm>
+            <a:off x="9144000" y="914400"/>
+            <a:ext cx="1371600" cy="1371600"/>
+          </a:xfrm>
+          <a:prstGeom prst="ellipse">
+            <a:avLst/>
+          </a:prstGeom>
+          <a:solidFill>
+            <a:srgbClr val="0096C7">
+              <a:lumMod val="70000"/>
+              <a:lumOff val="30000"/>
+            </a:srgbClr>
+          </a:solidFill>
+          <a:ln/>
+        </p:spPr>
+        <p:style>
+          <a:lnRef idx="1">
+            <a:schemeClr val="accent1"/>
+          </a:lnRef>
+          <a:fillRef idx="3">
+            <a:schemeClr val="accent1"/>
+          </a:fillRef>
+          <a:effectRef idx="2">
+            <a:schemeClr val="accent1"/>
+          </a:effectRef>
+          <a:fontRef idx="minor">
+            <a:schemeClr val="lt1"/>
+          </a:fontRef>
+        </p:style>
+        <p:txBody>
+          <a:bodyPr rtlCol="0" anchor="ctr"/>
+          <a:lstStyle/>
+          <a:p>
+            <a:pPr algn="ctr"/>
+          </a:p>
+        </p:txBody>
+      </p:sp>
+      <p:sp>
+        <p:nvSpPr>
+          <p:cNvPr id="4" name="Oval 3"/>
+          <p:cNvSpPr/>
+          <p:nvPr/>
+        </p:nvSpPr>
+        <p:spPr>
+          <a:xfrm>
+            <a:off x="9784080" y="1371600"/>
+            <a:ext cx="1371600" cy="1371600"/>
+          </a:xfrm>
+          <a:prstGeom prst="ellipse">
+            <a:avLst/>
+          </a:prstGeom>
+          <a:solidFill>
+            <a:srgbClr val="0096C7">
+              <a:lumMod val="70000"/>
+              <a:lumOff val="30000"/>
+            </a:srgbClr>
+          </a:solidFill>
+          <a:ln/>
+        </p:spPr>
+        <p:style>
+          <a:lnRef idx="1">
+            <a:schemeClr val="accent1"/>
+          </a:lnRef>
+          <a:fillRef idx="3">
+            <a:schemeClr val="accent1"/>
+          </a:fillRef>
+          <a:effectRef idx="2">
+            <a:schemeClr val="accent1"/>
+          </a:effectRef>
+          <a:fontRef idx="minor">
+            <a:schemeClr val="lt1"/>
+          </a:fontRef>
+        </p:style>
+        <p:txBody>
+          <a:bodyPr rtlCol="0" anchor="ctr"/>
+          <a:lstStyle/>
+          <a:p>
+            <a:pPr algn="ctr"/>
+          </a:p>
+        </p:txBody>
+      </p:sp>
+      <p:sp>
+        <p:nvSpPr>
+          <p:cNvPr id="5" name="Oval 4"/>
+          <p:cNvSpPr/>
+          <p:nvPr/>
+        </p:nvSpPr>
+        <p:spPr>
+          <a:xfrm>
+            <a:off x="10424160" y="1828800"/>
+            <a:ext cx="1371600" cy="1371600"/>
+          </a:xfrm>
+          <a:prstGeom prst="ellipse">
+            <a:avLst/>
+          </a:prstGeom>
+          <a:solidFill>
+            <a:srgbClr val="0096C7">
+              <a:lumMod val="70000"/>
+              <a:lumOff val="30000"/>
+            </a:srgbClr>
+          </a:solidFill>
+          <a:ln/>
+        </p:spPr>
+        <p:style>
+          <a:lnRef idx="1">
+            <a:schemeClr val="accent1"/>
+          </a:lnRef>
+          <a:fillRef idx="3">
+            <a:schemeClr val="accent1"/>
+          </a:fillRef>
+          <a:effectRef idx="2">
+            <a:schemeClr val="accent1"/>
+          </a:effectRef>
+          <a:fontRef idx="minor">
+            <a:schemeClr val="lt1"/>
+          </a:fontRef>
+        </p:style>
+        <p:txBody>
+          <a:bodyPr rtlCol="0" anchor="ctr"/>
+          <a:lstStyle/>
+          <a:p>
+            <a:pPr algn="ctr"/>
+          </a:p>
+        </p:txBody>
+      </p:sp>
+      <p:sp>
+        <p:nvSpPr>
+          <p:cNvPr id="6" name="TextBox 5"/>
+          <p:cNvSpPr txBox="1"/>
+          <p:nvPr/>
+        </p:nvSpPr>
+        <p:spPr>
+          <a:xfrm>
+            <a:off x="457200" y="2651760"/>
+            <a:ext cx="11247120" cy="1280160"/>
+          </a:xfrm>
+          <a:prstGeom prst="rect">
+            <a:avLst/>
+          </a:prstGeom>
+          <a:noFill/>
+        </p:spPr>
+        <p:txBody>
+          <a:bodyPr wrap="none">
+            <a:spAutoFit/>
+          </a:bodyPr>
+          <a:lstStyle/>
+          <a:p>
+            <a:pPr algn="ctr">
+              <a:defRPr sz="4800" b="1">
+                <a:solidFill>
+                  <a:srgbClr val="F3F6F9"/>
+                </a:solidFill>
+                <a:latin typeface="Microsoft YaHei"/>
+              </a:defRPr>
+            </a:pPr>
+            <a:r>
+              <a:t>谢谢，欢迎讨论</a:t>
+            </a:r>
+          </a:p>
+        </p:txBody>
+      </p:sp>
+      <p:sp>
+        <p:nvSpPr>
+          <p:cNvPr id="7" name="Rectangle 6"/>
+          <p:cNvSpPr/>
+          <p:nvPr/>
+        </p:nvSpPr>
+        <p:spPr>
+          <a:xfrm>
+            <a:off x="5184648" y="3931920"/>
+            <a:ext cx="1828800" cy="73152"/>
+          </a:xfrm>
+          <a:prstGeom prst="rect">
+            <a:avLst/>
+          </a:prstGeom>
+          <a:solidFill>
+            <a:srgbClr val="FF6B35"/>
+          </a:solidFill>
+          <a:ln/>
+        </p:spPr>
+        <p:style>
+          <a:lnRef idx="1">
+            <a:schemeClr val="accent1"/>
+          </a:lnRef>
+          <a:fillRef idx="3">
+            <a:schemeClr val="accent1"/>
+          </a:fillRef>
+          <a:effectRef idx="2">
+            <a:schemeClr val="accent1"/>
+          </a:effectRef>
+          <a:fontRef idx="minor">
+            <a:schemeClr val="lt1"/>
+          </a:fontRef>
+        </p:style>
+        <p:txBody>
+          <a:bodyPr rtlCol="0" anchor="ctr"/>
+          <a:lstStyle/>
+          <a:p>
+            <a:pPr algn="ctr"/>
+          </a:p>
+        </p:txBody>
+      </p:sp>
+      <p:sp>
+        <p:nvSpPr>
+          <p:cNvPr id="8" name="Rectangle 7"/>
+          <p:cNvSpPr/>
+          <p:nvPr/>
+        </p:nvSpPr>
+        <p:spPr>
+          <a:xfrm>
+            <a:off x="0" y="6537960"/>
+            <a:ext cx="12191695" cy="18288"/>
+          </a:xfrm>
+          <a:prstGeom prst="rect">
+            <a:avLst/>
+          </a:prstGeom>
+          <a:solidFill>
+            <a:srgbClr val="0096C7"/>
+          </a:solidFill>
+          <a:ln/>
+        </p:spPr>
+        <p:style>
+          <a:lnRef idx="1">
+            <a:schemeClr val="accent1"/>
+          </a:lnRef>
+          <a:fillRef idx="3">
+            <a:schemeClr val="accent1"/>
+          </a:fillRef>
+          <a:effectRef idx="2">
+            <a:schemeClr val="accent1"/>
+          </a:effectRef>
+          <a:fontRef idx="minor">
+            <a:schemeClr val="lt1"/>
+          </a:fontRef>
+        </p:style>
+        <p:txBody>
+          <a:bodyPr rtlCol="0" anchor="ctr"/>
+          <a:lstStyle/>
+          <a:p>
+            <a:pPr algn="ctr"/>
+          </a:p>
+        </p:txBody>
+      </p:sp>
+      <p:sp>
+        <p:nvSpPr>
+          <p:cNvPr id="9" name="TextBox 8"/>
+          <p:cNvSpPr txBox="1"/>
+          <p:nvPr/>
+        </p:nvSpPr>
+        <p:spPr>
+          <a:xfrm>
+            <a:off x="457200" y="6583680"/>
+            <a:ext cx="3657600" cy="228600"/>
+          </a:xfrm>
+          <a:prstGeom prst="rect">
+            <a:avLst/>
+          </a:prstGeom>
+          <a:noFill/>
+        </p:spPr>
+        <p:txBody>
+          <a:bodyPr wrap="none">
+            <a:spAutoFit/>
+          </a:bodyPr>
+          <a:lstStyle/>
+          <a:p>
+            <a:pPr algn="l">
+              <a:defRPr sz="1000" b="0">
+                <a:solidFill>
+                  <a:srgbClr val="6C757D"/>
+                </a:solidFill>
+                <a:latin typeface="Microsoft YaHei"/>
+              </a:defRPr>
+            </a:pPr>
+            <a:r>
+              <a:t>smallgameagent · LLM/VLM + 规则驱动</a:t>
+            </a:r>
+          </a:p>
+        </p:txBody>
+      </p:sp>
+      <p:sp>
+        <p:nvSpPr>
+          <p:cNvPr id="10" name="TextBox 9"/>
+          <p:cNvSpPr txBox="1"/>
+          <p:nvPr/>
+        </p:nvSpPr>
+        <p:spPr>
+          <a:xfrm>
+            <a:off x="10789920" y="6583680"/>
+            <a:ext cx="914400" cy="228600"/>
+          </a:xfrm>
+          <a:prstGeom prst="rect">
+            <a:avLst/>
+          </a:prstGeom>
+          <a:noFill/>
+        </p:spPr>
+        <p:txBody>
+          <a:bodyPr wrap="none">
+            <a:spAutoFit/>
+          </a:bodyPr>
+          <a:lstStyle/>
+          <a:p>
+            <a:pPr algn="r">
+              <a:defRPr sz="1000" b="0">
+                <a:solidFill>
+                  <a:srgbClr val="6C757D"/>
+                </a:solidFill>
+                <a:latin typeface="Microsoft YaHei"/>
+              </a:defRPr>
+            </a:pPr>
+            <a:r>
+              <a:t>40/40</a:t>
             </a:r>
           </a:p>
         </p:txBody>
@@ -26150,7 +27195,7 @@
               </a:defRPr>
             </a:pPr>
             <a:r>
-              <a:t>5/39</a:t>
+              <a:t>5/40</a:t>
             </a:r>
           </a:p>
         </p:txBody>
@@ -26547,7 +27592,7 @@
               </a:defRPr>
             </a:pPr>
             <a:r>
-              <a:t>6/39</a:t>
+              <a:t>6/40</a:t>
             </a:r>
           </a:p>
         </p:txBody>
@@ -26876,7 +27921,7 @@
               </a:defRPr>
             </a:pPr>
             <a:r>
-              <a:t>7/39</a:t>
+              <a:t>7/40</a:t>
             </a:r>
           </a:p>
         </p:txBody>
@@ -28180,7 +29225,7 @@
               </a:defRPr>
             </a:pPr>
             <a:r>
-              <a:t>8/39</a:t>
+              <a:t>8/40</a:t>
             </a:r>
           </a:p>
         </p:txBody>
@@ -28561,7 +29606,7 @@
               </a:defRPr>
             </a:pPr>
             <a:r>
-              <a:t>9/39</a:t>
+              <a:t>9/40</a:t>
             </a:r>
           </a:p>
         </p:txBody>

</xml_diff>